<commit_message>
Lesson sd-10-017: keep the source's milestones and describe each language from its own documentation instead of following the source's families, with the figure, metadata and deck
Co-Authored-By: Claude Sonnet 5.5 <noreply@anthropic.com>
Claude-Session: https://claude.ai/code/session_011dmt3ZFdN8sjiTfDnyUVN7
</commit_message>
<xml_diff>
--- a/system-design-101/vi/lessons/sd-10-017/slides/sd-10-017.pptx
+++ b/system-design-101/vi/lessons/sd-10-017/slides/sd-10-017.pptx
@@ -5437,7 +5437,40 @@
                 <a:ea typeface="Be Vietnam Pro" pitchFamily="34" charset="-122"/>
                 <a:cs typeface="Be Vietnam Pro" pitchFamily="34" charset="-120"/>
               </a:rPr>
-              <a:t> cải tiến</a:t>
+              <a:t> mới,</a:t>
+            </a:r>
+            <a:r>
+              <a:rPr lang="en-US" sz="2250" dirty="0" spc="0" kern="0">
+                <a:solidFill>
+                  <a:srgbClr val="6B6A66"/>
+                </a:solidFill>
+                <a:latin typeface="Be Vietnam Pro" pitchFamily="34" charset="0"/>
+                <a:ea typeface="Be Vietnam Pro" pitchFamily="34" charset="-122"/>
+                <a:cs typeface="Be Vietnam Pro" pitchFamily="34" charset="-120"/>
+              </a:rPr>
+              <a:t> mỗi</a:t>
+            </a:r>
+            <a:r>
+              <a:rPr lang="en-US" sz="2250" dirty="0" spc="-1" kern="0">
+                <a:solidFill>
+                  <a:srgbClr val="6B6A66"/>
+                </a:solidFill>
+                <a:latin typeface="Be Vietnam Pro" pitchFamily="34" charset="0"/>
+                <a:ea typeface="Be Vietnam Pro" pitchFamily="34" charset="-122"/>
+                <a:cs typeface="Be Vietnam Pro" pitchFamily="34" charset="-120"/>
+              </a:rPr>
+              <a:t> cái</a:t>
+            </a:r>
+            <a:r>
+              <a:rPr lang="en-US" sz="2250" dirty="0" spc="-4" kern="0">
+                <a:solidFill>
+                  <a:srgbClr val="6B6A66"/>
+                </a:solidFill>
+                <a:latin typeface="Be Vietnam Pro" pitchFamily="34" charset="0"/>
+                <a:ea typeface="Be Vietnam Pro" pitchFamily="34" charset="-122"/>
+                <a:cs typeface="Be Vietnam Pro" pitchFamily="34" charset="-120"/>
+              </a:rPr>
+              <a:t> một</a:t>
             </a:r>
             <a:r>
               <a:rPr lang="en-US" sz="2250" dirty="0" spc="3" kern="0">
@@ -5448,10 +5481,10 @@
                 <a:ea typeface="Be Vietnam Pro" pitchFamily="34" charset="-122"/>
                 <a:cs typeface="Be Vietnam Pro" pitchFamily="34" charset="-120"/>
               </a:rPr>
-              <a:t> C++</a:t>
-            </a:r>
-            <a:r>
-              <a:rPr lang="en-US" sz="2250" dirty="0" spc="-3" kern="0">
+              <a:t> mục</a:t>
+            </a:r>
+            <a:r>
+              <a:rPr lang="en-US" sz="2250" dirty="0" spc="-2" kern="0">
                 <a:solidFill>
                   <a:srgbClr val="6B6A66"/>
                 </a:solidFill>
@@ -5459,18 +5492,7 @@
                 <a:ea typeface="Be Vietnam Pro" pitchFamily="34" charset="-122"/>
                 <a:cs typeface="Be Vietnam Pro" pitchFamily="34" charset="-120"/>
               </a:rPr>
-              <a:t> hoặc</a:t>
-            </a:r>
-            <a:r>
-              <a:rPr lang="en-US" sz="2250" dirty="0" spc="-21" kern="0">
-                <a:solidFill>
-                  <a:srgbClr val="6B6A66"/>
-                </a:solidFill>
-                <a:latin typeface="Be Vietnam Pro" pitchFamily="34" charset="0"/>
-                <a:ea typeface="Be Vietnam Pro" pitchFamily="34" charset="-122"/>
-                <a:cs typeface="Be Vietnam Pro" pitchFamily="34" charset="-120"/>
-              </a:rPr>
-              <a:t> Java</a:t>
+              <a:t> tiêu</a:t>
             </a:r>
             <a:endParaRPr lang="en-US" sz="2250" dirty="0"/>
           </a:p>
@@ -6682,7 +6704,7 @@
               <a:buNone/>
             </a:pPr>
             <a:r>
-              <a:rPr lang="en-US" sz="2700" dirty="0" spc="20" kern="0">
+              <a:rPr lang="en-US" sz="2700" dirty="0" spc="-1" kern="0">
                 <a:solidFill>
                   <a:srgbClr val="F3EEE3"/>
                 </a:solidFill>
@@ -6690,7 +6712,62 @@
                 <a:ea typeface="Be Vietnam Pro" pitchFamily="34" charset="-122"/>
                 <a:cs typeface="Be Vietnam Pro" pitchFamily="34" charset="-120"/>
               </a:rPr>
-              <a:t>Những</a:t>
+              <a:t>Bài</a:t>
+            </a:r>
+            <a:r>
+              <a:rPr lang="en-US" sz="2700" dirty="0" spc="-2" kern="0">
+                <a:solidFill>
+                  <a:srgbClr val="F3EEE3"/>
+                </a:solidFill>
+                <a:latin typeface="Be Vietnam Pro" pitchFamily="34" charset="0"/>
+                <a:ea typeface="Be Vietnam Pro" pitchFamily="34" charset="-122"/>
+                <a:cs typeface="Be Vietnam Pro" pitchFamily="34" charset="-120"/>
+              </a:rPr>
+              <a:t> nguồn nói</a:t>
+            </a:r>
+            <a:r>
+              <a:rPr lang="en-US" sz="2700" dirty="0" spc="2" kern="0">
+                <a:solidFill>
+                  <a:srgbClr val="F3EEE3"/>
+                </a:solidFill>
+                <a:latin typeface="Be Vietnam Pro" pitchFamily="34" charset="0"/>
+                <a:ea typeface="Be Vietnam Pro" pitchFamily="34" charset="-122"/>
+                <a:cs typeface="Be Vietnam Pro" pitchFamily="34" charset="-120"/>
+              </a:rPr>
+              <a:t> các</a:t>
+            </a:r>
+            <a:r>
+              <a:rPr lang="en-US" sz="2700" dirty="0" spc="-2" kern="0">
+                <a:solidFill>
+                  <a:srgbClr val="F3EEE3"/>
+                </a:solidFill>
+                <a:latin typeface="Be Vietnam Pro" pitchFamily="34" charset="0"/>
+                <a:ea typeface="Be Vietnam Pro" pitchFamily="34" charset="-122"/>
+                <a:cs typeface="Be Vietnam Pro" pitchFamily="34" charset="-120"/>
+              </a:rPr>
+              <a:t> tính năng</a:t>
+            </a:r>
+            <a:r>
+              <a:rPr lang="en-US" sz="2700" dirty="0" spc="-12" kern="0">
+                <a:solidFill>
+                  <a:srgbClr val="F3EEE3"/>
+                </a:solidFill>
+                <a:latin typeface="Be Vietnam Pro" pitchFamily="34" charset="0"/>
+                <a:ea typeface="Be Vietnam Pro" pitchFamily="34" charset="-122"/>
+                <a:cs typeface="Be Vietnam Pro" pitchFamily="34" charset="-120"/>
+              </a:rPr>
+              <a:t> này</a:t>
+            </a:r>
+            <a:r>
+              <a:rPr lang="en-US" sz="2700" dirty="0" spc="0" kern="0">
+                <a:solidFill>
+                  <a:srgbClr val="F3EEE3"/>
+                </a:solidFill>
+                <a:latin typeface="Be Vietnam Pro" pitchFamily="34" charset="0"/>
+                <a:ea typeface="Be Vietnam Pro" pitchFamily="34" charset="-122"/>
+                <a:cs typeface="Be Vietnam Pro" pitchFamily="34" charset="-120"/>
+              </a:rPr>
+              <a:t> có</a:t>
             </a:r>
             <a:r>
               <a:rPr lang="en-US" sz="2700" dirty="0" spc="-1" kern="0">
@@ -6701,10 +6778,10 @@
                 <a:ea typeface="Be Vietnam Pro" pitchFamily="34" charset="-122"/>
                 <a:cs typeface="Be Vietnam Pro" pitchFamily="34" charset="-120"/>
               </a:rPr>
-              <a:t> tính</a:t>
-            </a:r>
-            <a:r>
-              <a:rPr lang="en-US" sz="2700" dirty="0" spc="-3" kern="0">
+              <a:t> từ</a:t>
+            </a:r>
+            <a:r>
+              <a:rPr lang="en-US" sz="2700" dirty="0" spc="-6" kern="0">
                 <a:solidFill>
                   <a:srgbClr val="F3EEE3"/>
                 </a:solidFill>
@@ -6712,10 +6789,10 @@
                 <a:ea typeface="Be Vietnam Pro" pitchFamily="34" charset="-122"/>
                 <a:cs typeface="Be Vietnam Pro" pitchFamily="34" charset="-120"/>
               </a:rPr>
-              <a:t> năng</a:t>
-            </a:r>
-            <a:r>
-              <a:rPr lang="en-US" sz="2700" dirty="0" spc="9" kern="0">
+              <a:t> sớm;</a:t>
+            </a:r>
+            <a:r>
+              <a:rPr lang="en-US" sz="2700" dirty="0" spc="8" kern="0">
                 <a:solidFill>
                   <a:srgbClr val="F3EEE3"/>
                 </a:solidFill>
@@ -6723,10 +6800,10 @@
                 <a:ea typeface="Be Vietnam Pro" pitchFamily="34" charset="-122"/>
                 <a:cs typeface="Be Vietnam Pro" pitchFamily="34" charset="-120"/>
               </a:rPr>
-              <a:t> được</a:t>
-            </a:r>
-            <a:r>
-              <a:rPr lang="en-US" sz="2700" dirty="0" spc="15" kern="0">
+              <a:t> chưa</a:t>
+            </a:r>
+            <a:r>
+              <a:rPr lang="en-US" sz="2700" dirty="0" spc="12" kern="0">
                 <a:solidFill>
                   <a:srgbClr val="F3EEE3"/>
                 </a:solidFill>
@@ -6734,10 +6811,10 @@
                 <a:ea typeface="Be Vietnam Pro" pitchFamily="34" charset="-122"/>
                 <a:cs typeface="Be Vietnam Pro" pitchFamily="34" charset="-120"/>
               </a:rPr>
-              <a:t> đề</a:t>
-            </a:r>
-            <a:r>
-              <a:rPr lang="en-US" sz="2700" dirty="0" spc="-10" kern="0">
+              <a:t> đối</a:t>
+            </a:r>
+            <a:r>
+              <a:rPr lang="en-US" sz="2700" dirty="0" spc="-1" kern="0">
                 <a:solidFill>
                   <a:srgbClr val="F3EEE3"/>
                 </a:solidFill>
@@ -6745,106 +6822,7 @@
                 <a:ea typeface="Be Vietnam Pro" pitchFamily="34" charset="-122"/>
                 <a:cs typeface="Be Vietnam Pro" pitchFamily="34" charset="-120"/>
               </a:rPr>
-              <a:t> xuất</a:t>
-            </a:r>
-            <a:r>
-              <a:rPr lang="en-US" sz="2700" dirty="0" spc="-1" kern="0">
-                <a:solidFill>
-                  <a:srgbClr val="F3EEE3"/>
-                </a:solidFill>
-                <a:latin typeface="Be Vietnam Pro" pitchFamily="34" charset="0"/>
-                <a:ea typeface="Be Vietnam Pro" pitchFamily="34" charset="-122"/>
-                <a:cs typeface="Be Vietnam Pro" pitchFamily="34" charset="-120"/>
-              </a:rPr>
-              <a:t> từ</a:t>
-            </a:r>
-            <a:r>
-              <a:rPr lang="en-US" sz="2700" dirty="0" spc="-10" kern="0">
-                <a:solidFill>
-                  <a:srgbClr val="F3EEE3"/>
-                </a:solidFill>
-                <a:latin typeface="Be Vietnam Pro" pitchFamily="34" charset="0"/>
-                <a:ea typeface="Be Vietnam Pro" pitchFamily="34" charset="-122"/>
-                <a:cs typeface="Be Vietnam Pro" pitchFamily="34" charset="-120"/>
-              </a:rPr>
-              <a:t> sớm</a:t>
-            </a:r>
-            <a:r>
-              <a:rPr lang="en-US" sz="2700" dirty="0" spc="-13" kern="0">
-                <a:solidFill>
-                  <a:srgbClr val="F3EEE3"/>
-                </a:solidFill>
-                <a:latin typeface="Be Vietnam Pro" pitchFamily="34" charset="0"/>
-                <a:ea typeface="Be Vietnam Pro" pitchFamily="34" charset="-122"/>
-                <a:cs typeface="Be Vietnam Pro" pitchFamily="34" charset="-120"/>
-              </a:rPr>
-              <a:t> vẫn</a:t>
-            </a:r>
-            <a:r>
-              <a:rPr lang="en-US" sz="2700" dirty="0" spc="-1" kern="0">
-                <a:solidFill>
-                  <a:srgbClr val="F3EEE3"/>
-                </a:solidFill>
-                <a:latin typeface="Be Vietnam Pro" pitchFamily="34" charset="0"/>
-                <a:ea typeface="Be Vietnam Pro" pitchFamily="34" charset="-122"/>
-                <a:cs typeface="Be Vietnam Pro" pitchFamily="34" charset="-120"/>
-              </a:rPr>
-              <a:t> còn</a:t>
-            </a:r>
-            <a:r>
-              <a:rPr lang="en-US" sz="2700" dirty="0" spc="-20" kern="0">
-                <a:solidFill>
-                  <a:srgbClr val="F3EEE3"/>
-                </a:solidFill>
-                <a:latin typeface="Be Vietnam Pro" pitchFamily="34" charset="0"/>
-                <a:ea typeface="Be Vietnam Pro" pitchFamily="34" charset="-122"/>
-                <a:cs typeface="Be Vietnam Pro" pitchFamily="34" charset="-120"/>
-              </a:rPr>
-              <a:t> trong</a:t>
-            </a:r>
-            <a:r>
-              <a:rPr lang="en-US" sz="2700" dirty="0" spc="-13" kern="0">
-                <a:solidFill>
-                  <a:srgbClr val="F3EEE3"/>
-                </a:solidFill>
-                <a:latin typeface="Be Vietnam Pro" pitchFamily="34" charset="0"/>
-                <a:ea typeface="Be Vietnam Pro" pitchFamily="34" charset="-122"/>
-                <a:cs typeface="Be Vietnam Pro" pitchFamily="34" charset="-120"/>
-              </a:rPr>
-              <a:t> ngôn</a:t>
-            </a:r>
-            <a:r>
-              <a:rPr lang="en-US" sz="2700" dirty="0" spc="-4" kern="0">
-                <a:solidFill>
-                  <a:srgbClr val="F3EEE3"/>
-                </a:solidFill>
-                <a:latin typeface="Be Vietnam Pro" pitchFamily="34" charset="0"/>
-                <a:ea typeface="Be Vietnam Pro" pitchFamily="34" charset="-122"/>
-                <a:cs typeface="Be Vietnam Pro" pitchFamily="34" charset="-120"/>
-              </a:rPr>
-              <a:t> ngữ</a:t>
-            </a:r>
-            <a:r>
-              <a:rPr lang="en-US" sz="2700" dirty="0" spc="-2" kern="0">
-                <a:solidFill>
-                  <a:srgbClr val="F3EEE3"/>
-                </a:solidFill>
-                <a:latin typeface="Be Vietnam Pro" pitchFamily="34" charset="0"/>
-                <a:ea typeface="Be Vietnam Pro" pitchFamily="34" charset="-122"/>
-                <a:cs typeface="Be Vietnam Pro" pitchFamily="34" charset="-120"/>
-              </a:rPr>
-              <a:t> hiện</a:t>
-            </a:r>
-            <a:r>
-              <a:rPr lang="en-US" sz="2700" dirty="0" spc="9" kern="0">
-                <a:solidFill>
-                  <a:srgbClr val="F3EEE3"/>
-                </a:solidFill>
-                <a:latin typeface="Be Vietnam Pro" pitchFamily="34" charset="0"/>
-                <a:ea typeface="Be Vietnam Pro" pitchFamily="34" charset="-122"/>
-                <a:cs typeface="Be Vietnam Pro" pitchFamily="34" charset="-120"/>
-              </a:rPr>
-              <a:t> đại.</a:t>
+              <a:t> chiếu.</a:t>
             </a:r>
             <a:endParaRPr lang="en-US" sz="2700" dirty="0"/>
           </a:p>
@@ -7815,7 +7793,7 @@
               <a:t> TỪ</a:t>
             </a:r>
             <a:r>
-              <a:rPr lang="en-US" sz="1800" b="1" spc="231" kern="0" dirty="0">
+              <a:rPr lang="en-US" sz="1800" b="1" spc="229" kern="0" dirty="0">
                 <a:solidFill>
                   <a:srgbClr val="7C93FF"/>
                 </a:solidFill>
@@ -7823,7 +7801,29 @@
                 <a:ea typeface="Be Vietnam Pro" pitchFamily="34" charset="-122"/>
                 <a:cs typeface="Be Vietnam Pro" pitchFamily="34" charset="-120"/>
               </a:rPr>
-              <a:t> SỚM</a:t>
+              <a:t> SỚM,</a:t>
+            </a:r>
+            <a:r>
+              <a:rPr lang="en-US" sz="1800" b="1" spc="223" kern="0" dirty="0">
+                <a:solidFill>
+                  <a:srgbClr val="7C93FF"/>
+                </a:solidFill>
+                <a:latin typeface="Be Vietnam Pro" pitchFamily="34" charset="0"/>
+                <a:ea typeface="Be Vietnam Pro" pitchFamily="34" charset="-122"/>
+                <a:cs typeface="Be Vietnam Pro" pitchFamily="34" charset="-120"/>
+              </a:rPr>
+              <a:t> THEO</a:t>
+            </a:r>
+            <a:r>
+              <a:rPr lang="en-US" sz="1800" b="1" spc="226" kern="0" dirty="0">
+                <a:solidFill>
+                  <a:srgbClr val="7C93FF"/>
+                </a:solidFill>
+                <a:latin typeface="Be Vietnam Pro" pitchFamily="34" charset="0"/>
+                <a:ea typeface="Be Vietnam Pro" pitchFamily="34" charset="-122"/>
+                <a:cs typeface="Be Vietnam Pro" pitchFamily="34" charset="-120"/>
+              </a:rPr>
+              <a:t> NGUỒN</a:t>
             </a:r>
             <a:endParaRPr lang="en-US" sz="1800" dirty="0"/>
           </a:p>
@@ -9734,81 +9734,48 @@
               <a:buNone/>
             </a:pPr>
             <a:r>
-              <a:rPr lang="en-US" sz="2100" dirty="0" spc="6" kern="0">
-                <a:solidFill>
-                  <a:srgbClr val="14161C"/>
-                </a:solidFill>
-                <a:latin typeface="Be Vietnam Pro" pitchFamily="34" charset="0"/>
-                <a:ea typeface="Be Vietnam Pro" pitchFamily="34" charset="-122"/>
-                <a:cs typeface="Be Vietnam Pro" pitchFamily="34" charset="-120"/>
-              </a:rPr>
-              <a:t>được</a:t>
-            </a:r>
-            <a:r>
-              <a:rPr lang="en-US" sz="2100" dirty="0" spc="-11" kern="0">
-                <a:solidFill>
-                  <a:srgbClr val="14161C"/>
-                </a:solidFill>
-                <a:latin typeface="Be Vietnam Pro" pitchFamily="34" charset="0"/>
-                <a:ea typeface="Be Vietnam Pro" pitchFamily="34" charset="-122"/>
-                <a:cs typeface="Be Vietnam Pro" pitchFamily="34" charset="-120"/>
-              </a:rPr>
-              <a:t> phát</a:t>
-            </a:r>
-            <a:r>
-              <a:rPr lang="en-US" sz="2100" dirty="0" spc="7" kern="0">
-                <a:solidFill>
-                  <a:srgbClr val="14161C"/>
-                </a:solidFill>
-                <a:latin typeface="Be Vietnam Pro" pitchFamily="34" charset="0"/>
-                <a:ea typeface="Be Vietnam Pro" pitchFamily="34" charset="-122"/>
-                <a:cs typeface="Be Vietnam Pro" pitchFamily="34" charset="-120"/>
-              </a:rPr>
-              <a:t> triển</a:t>
-            </a:r>
-            <a:r>
-              <a:rPr lang="en-US" sz="2100" dirty="0" spc="16" kern="0">
-                <a:solidFill>
-                  <a:srgbClr val="14161C"/>
-                </a:solidFill>
-                <a:latin typeface="Be Vietnam Pro" pitchFamily="34" charset="0"/>
-                <a:ea typeface="Be Vietnam Pro" pitchFamily="34" charset="-122"/>
-                <a:cs typeface="Be Vietnam Pro" pitchFamily="34" charset="-120"/>
-              </a:rPr>
-              <a:t> để</a:t>
-            </a:r>
-            <a:r>
-              <a:rPr lang="en-US" sz="2100" dirty="0" spc="-4" kern="0">
-                <a:solidFill>
-                  <a:srgbClr val="14161C"/>
-                </a:solidFill>
-                <a:latin typeface="Be Vietnam Pro" pitchFamily="34" charset="0"/>
-                <a:ea typeface="Be Vietnam Pro" pitchFamily="34" charset="-122"/>
-                <a:cs typeface="Be Vietnam Pro" pitchFamily="34" charset="-120"/>
-              </a:rPr>
-              <a:t> lập</a:t>
-            </a:r>
-            <a:r>
-              <a:rPr lang="en-US" sz="2100" dirty="0" spc="7" kern="0">
-                <a:solidFill>
-                  <a:srgbClr val="14161C"/>
-                </a:solidFill>
-                <a:latin typeface="Be Vietnam Pro" pitchFamily="34" charset="0"/>
-                <a:ea typeface="Be Vietnam Pro" pitchFamily="34" charset="-122"/>
-                <a:cs typeface="Be Vietnam Pro" pitchFamily="34" charset="-120"/>
-              </a:rPr>
-              <a:t> trình</a:t>
-            </a:r>
-            <a:r>
-              <a:rPr lang="en-US" sz="2100" dirty="0" spc="-17" kern="0">
-                <a:solidFill>
-                  <a:srgbClr val="14161C"/>
-                </a:solidFill>
-                <a:latin typeface="Be Vietnam Pro" pitchFamily="34" charset="0"/>
-                <a:ea typeface="Be Vietnam Pro" pitchFamily="34" charset="-122"/>
-                <a:cs typeface="Be Vietnam Pro" pitchFamily="34" charset="-120"/>
-              </a:rPr>
-              <a:t> trên</a:t>
+              <a:rPr lang="en-US" sz="2100" dirty="0" spc="-44" kern="0">
+                <a:solidFill>
+                  <a:srgbClr val="14161C"/>
+                </a:solidFill>
+                <a:latin typeface="Be Vietnam Pro" pitchFamily="34" charset="0"/>
+                <a:ea typeface="Be Vietnam Pro" pitchFamily="34" charset="-122"/>
+                <a:cs typeface="Be Vietnam Pro" pitchFamily="34" charset="-120"/>
+              </a:rPr>
+              <a:t>ra</a:t>
+            </a:r>
+            <a:r>
+              <a:rPr lang="en-US" sz="2100" dirty="0" spc="10" kern="0">
+                <a:solidFill>
+                  <a:srgbClr val="14161C"/>
+                </a:solidFill>
+                <a:latin typeface="Be Vietnam Pro" pitchFamily="34" charset="0"/>
+                <a:ea typeface="Be Vietnam Pro" pitchFamily="34" charset="-122"/>
+                <a:cs typeface="Be Vietnam Pro" pitchFamily="34" charset="-120"/>
+              </a:rPr>
+              <a:t> đời</a:t>
+            </a:r>
+            <a:r>
+              <a:rPr lang="en-US" sz="2100" dirty="0" spc="-1" kern="0">
+                <a:solidFill>
+                  <a:srgbClr val="14161C"/>
+                </a:solidFill>
+                <a:latin typeface="Be Vietnam Pro" pitchFamily="34" charset="0"/>
+                <a:ea typeface="Be Vietnam Pro" pitchFamily="34" charset="-122"/>
+                <a:cs typeface="Be Vietnam Pro" pitchFamily="34" charset="-120"/>
+              </a:rPr>
+              <a:t> năm 1972,</a:t>
+            </a:r>
+            <a:r>
+              <a:rPr lang="en-US" sz="2100" dirty="0" spc="-5" kern="0">
+                <a:solidFill>
+                  <a:srgbClr val="14161C"/>
+                </a:solidFill>
+                <a:latin typeface="Be Vietnam Pro" pitchFamily="34" charset="0"/>
+                <a:ea typeface="Be Vietnam Pro" pitchFamily="34" charset="-122"/>
+                <a:cs typeface="Be Vietnam Pro" pitchFamily="34" charset="-120"/>
+              </a:rPr>
+              <a:t> theo</a:t>
             </a:r>
             <a:r>
               <a:rPr lang="en-US" sz="2100" dirty="0" spc="0" kern="0">
@@ -9819,7 +9786,7 @@
                 <a:ea typeface="Be Vietnam Pro" pitchFamily="34" charset="-122"/>
                 <a:cs typeface="Be Vietnam Pro" pitchFamily="34" charset="-120"/>
               </a:rPr>
-              <a:t> Unix</a:t>
+              <a:t> nguồn</a:t>
             </a:r>
             <a:endParaRPr lang="en-US" sz="2100" dirty="0"/>
           </a:p>
@@ -10524,6 +10491,50 @@
               <a:buNone/>
             </a:pPr>
             <a:r>
+              <a:rPr lang="en-US" sz="2100" dirty="0" spc="-44" kern="0">
+                <a:solidFill>
+                  <a:srgbClr val="14161C"/>
+                </a:solidFill>
+                <a:latin typeface="Be Vietnam Pro" pitchFamily="34" charset="0"/>
+                <a:ea typeface="Be Vietnam Pro" pitchFamily="34" charset="-122"/>
+                <a:cs typeface="Be Vietnam Pro" pitchFamily="34" charset="-120"/>
+              </a:rPr>
+              <a:t>ra</a:t>
+            </a:r>
+            <a:r>
+              <a:rPr lang="en-US" sz="2100" dirty="0" spc="10" kern="0">
+                <a:solidFill>
+                  <a:srgbClr val="14161C"/>
+                </a:solidFill>
+                <a:latin typeface="Be Vietnam Pro" pitchFamily="34" charset="0"/>
+                <a:ea typeface="Be Vietnam Pro" pitchFamily="34" charset="-122"/>
+                <a:cs typeface="Be Vietnam Pro" pitchFamily="34" charset="-120"/>
+              </a:rPr>
+              <a:t> đời</a:t>
+            </a:r>
+            <a:r>
+              <a:rPr lang="en-US" sz="2100" dirty="0" spc="-1" kern="0">
+                <a:solidFill>
+                  <a:srgbClr val="14161C"/>
+                </a:solidFill>
+                <a:latin typeface="Be Vietnam Pro" pitchFamily="34" charset="0"/>
+                <a:ea typeface="Be Vietnam Pro" pitchFamily="34" charset="-122"/>
+                <a:cs typeface="Be Vietnam Pro" pitchFamily="34" charset="-120"/>
+              </a:rPr>
+              <a:t> năm 1972,</a:t>
+            </a:r>
+            <a:r>
+              <a:rPr lang="en-US" sz="2100" dirty="0" spc="-5" kern="0">
+                <a:solidFill>
+                  <a:srgbClr val="14161C"/>
+                </a:solidFill>
+                <a:latin typeface="Be Vietnam Pro" pitchFamily="34" charset="0"/>
+                <a:ea typeface="Be Vietnam Pro" pitchFamily="34" charset="-122"/>
+                <a:cs typeface="Be Vietnam Pro" pitchFamily="34" charset="-120"/>
+              </a:rPr>
+              <a:t> theo</a:t>
+            </a:r>
+            <a:r>
               <a:rPr lang="en-US" sz="2100" dirty="0" spc="0" kern="0">
                 <a:solidFill>
                   <a:srgbClr val="14161C"/>
@@ -10532,150 +10543,7 @@
                 <a:ea typeface="Be Vietnam Pro" pitchFamily="34" charset="-122"/>
                 <a:cs typeface="Be Vietnam Pro" pitchFamily="34" charset="-120"/>
               </a:rPr>
-              <a:t>ảnh</a:t>
-            </a:r>
-            <a:r>
-              <a:rPr lang="en-US" sz="2100" dirty="0" spc="3" kern="0">
-                <a:solidFill>
-                  <a:srgbClr val="14161C"/>
-                </a:solidFill>
-                <a:latin typeface="Be Vietnam Pro" pitchFamily="34" charset="0"/>
-                <a:ea typeface="Be Vietnam Pro" pitchFamily="34" charset="-122"/>
-                <a:cs typeface="Be Vietnam Pro" pitchFamily="34" charset="-120"/>
-              </a:rPr>
-              <a:t> hưởng</a:t>
-            </a:r>
-            <a:r>
-              <a:rPr lang="en-US" sz="2100" dirty="0" spc="2" kern="0">
-                <a:solidFill>
-                  <a:srgbClr val="14161C"/>
-                </a:solidFill>
-                <a:latin typeface="Be Vietnam Pro" pitchFamily="34" charset="0"/>
-                <a:ea typeface="Be Vietnam Pro" pitchFamily="34" charset="-122"/>
-                <a:cs typeface="Be Vietnam Pro" pitchFamily="34" charset="-120"/>
-              </a:rPr>
-              <a:t> nhiều</a:t>
-            </a:r>
-            <a:r>
-              <a:rPr lang="en-US" sz="2100" dirty="0" spc="-13" kern="0">
-                <a:solidFill>
-                  <a:srgbClr val="14161C"/>
-                </a:solidFill>
-                <a:latin typeface="Be Vietnam Pro" pitchFamily="34" charset="0"/>
-                <a:ea typeface="Be Vietnam Pro" pitchFamily="34" charset="-122"/>
-                <a:cs typeface="Be Vietnam Pro" pitchFamily="34" charset="-120"/>
-              </a:rPr>
-              <a:t> tới</a:t>
-            </a:r>
-            <a:r>
-              <a:rPr lang="en-US" sz="2100" dirty="0" spc="-9" kern="0">
-                <a:solidFill>
-                  <a:srgbClr val="14161C"/>
-                </a:solidFill>
-                <a:latin typeface="Be Vietnam Pro" pitchFamily="34" charset="0"/>
-                <a:ea typeface="Be Vietnam Pro" pitchFamily="34" charset="-122"/>
-                <a:cs typeface="Be Vietnam Pro" pitchFamily="34" charset="-120"/>
-              </a:rPr>
-              <a:t> ngôn</a:t>
-            </a:r>
-            <a:r>
-              <a:rPr lang="en-US" sz="2100" dirty="0" spc="1" kern="0">
-                <a:solidFill>
-                  <a:srgbClr val="14161C"/>
-                </a:solidFill>
-                <a:latin typeface="Be Vietnam Pro" pitchFamily="34" charset="0"/>
-                <a:ea typeface="Be Vietnam Pro" pitchFamily="34" charset="-122"/>
-                <a:cs typeface="Be Vietnam Pro" pitchFamily="34" charset="-120"/>
-              </a:rPr>
-              <a:t> ngữ</a:t>
-            </a:r>
-            <a:r>
-              <a:rPr lang="en-US" sz="2100" dirty="0" spc="0" kern="0">
-                <a:solidFill>
-                  <a:srgbClr val="14161C"/>
-                </a:solidFill>
-                <a:latin typeface="Be Vietnam Pro" pitchFamily="34" charset="0"/>
-                <a:ea typeface="Be Vietnam Pro" pitchFamily="34" charset="-122"/>
-                <a:cs typeface="Be Vietnam Pro" pitchFamily="34" charset="-120"/>
-              </a:rPr>
-              <a:t> kịch</a:t>
-            </a:r>
-            <a:r>
-              <a:rPr lang="en-US" sz="2100" dirty="0" spc="-5" kern="0">
-                <a:solidFill>
-                  <a:srgbClr val="14161C"/>
-                </a:solidFill>
-                <a:latin typeface="Be Vietnam Pro" pitchFamily="34" charset="0"/>
-                <a:ea typeface="Be Vietnam Pro" pitchFamily="34" charset="-122"/>
-                <a:cs typeface="Be Vietnam Pro" pitchFamily="34" charset="-120"/>
-              </a:rPr>
-              <a:t> bản</a:t>
-            </a:r>
-            <a:r>
-              <a:rPr lang="en-US" sz="2100" dirty="0" spc="-18" kern="0">
-                <a:solidFill>
-                  <a:srgbClr val="14161C"/>
-                </a:solidFill>
-                <a:latin typeface="Be Vietnam Pro" pitchFamily="34" charset="0"/>
-                <a:ea typeface="Be Vietnam Pro" pitchFamily="34" charset="-122"/>
-                <a:cs typeface="Be Vietnam Pro" pitchFamily="34" charset="-120"/>
-              </a:rPr>
-              <a:t> và</a:t>
-            </a:r>
-            <a:r>
-              <a:rPr lang="en-US" sz="2100" dirty="0" spc="-9" kern="0">
-                <a:solidFill>
-                  <a:srgbClr val="14161C"/>
-                </a:solidFill>
-                <a:latin typeface="Be Vietnam Pro" pitchFamily="34" charset="0"/>
-                <a:ea typeface="Be Vietnam Pro" pitchFamily="34" charset="-122"/>
-                <a:cs typeface="Be Vietnam Pro" pitchFamily="34" charset="-120"/>
-              </a:rPr>
-              <a:t> ngôn</a:t>
-            </a:r>
-            <a:r>
-              <a:rPr lang="en-US" sz="2100" dirty="0" spc="1" kern="0">
-                <a:solidFill>
-                  <a:srgbClr val="14161C"/>
-                </a:solidFill>
-                <a:latin typeface="Be Vietnam Pro" pitchFamily="34" charset="0"/>
-                <a:ea typeface="Be Vietnam Pro" pitchFamily="34" charset="-122"/>
-                <a:cs typeface="Be Vietnam Pro" pitchFamily="34" charset="-120"/>
-              </a:rPr>
-              <a:t> ngữ</a:t>
-            </a:r>
-            <a:r>
-              <a:rPr lang="en-US" sz="2100" dirty="0" spc="-2" kern="0">
-                <a:solidFill>
-                  <a:srgbClr val="14161C"/>
-                </a:solidFill>
-                <a:latin typeface="Be Vietnam Pro" pitchFamily="34" charset="0"/>
-                <a:ea typeface="Be Vietnam Pro" pitchFamily="34" charset="-122"/>
-                <a:cs typeface="Be Vietnam Pro" pitchFamily="34" charset="-120"/>
-              </a:rPr>
-              <a:t> phía</a:t>
-            </a:r>
-            <a:r>
-              <a:rPr lang="en-US" sz="2100" dirty="0" spc="-10" kern="0">
-                <a:solidFill>
-                  <a:srgbClr val="14161C"/>
-                </a:solidFill>
-                <a:latin typeface="Be Vietnam Pro" pitchFamily="34" charset="0"/>
-                <a:ea typeface="Be Vietnam Pro" pitchFamily="34" charset="-122"/>
-                <a:cs typeface="Be Vietnam Pro" pitchFamily="34" charset="-120"/>
-              </a:rPr>
-              <a:t> máy</a:t>
-            </a:r>
-            <a:r>
-              <a:rPr lang="en-US" sz="2100" dirty="0" spc="-1" kern="0">
-                <a:solidFill>
-                  <a:srgbClr val="14161C"/>
-                </a:solidFill>
-                <a:latin typeface="Be Vietnam Pro" pitchFamily="34" charset="0"/>
-                <a:ea typeface="Be Vietnam Pro" pitchFamily="34" charset="-122"/>
-                <a:cs typeface="Be Vietnam Pro" pitchFamily="34" charset="-120"/>
-              </a:rPr>
-              <a:t> khách</a:t>
+              <a:t> nguồn</a:t>
             </a:r>
             <a:endParaRPr lang="en-US" sz="2100" dirty="0"/>
           </a:p>
@@ -10946,7 +10814,7 @@
               <a:buNone/>
             </a:pPr>
             <a:r>
-              <a:rPr lang="en-US" sz="3300" b="1" dirty="0" spc="-5" kern="0">
+              <a:rPr lang="en-US" sz="3300" b="1" dirty="0" spc="-2" kern="0">
                 <a:solidFill>
                   <a:srgbClr val="FFB454"/>
                 </a:solidFill>
@@ -10954,10 +10822,10 @@
                 <a:ea typeface="Be Vietnam Pro" pitchFamily="34" charset="-122"/>
                 <a:cs typeface="Be Vietnam Pro" pitchFamily="34" charset="-120"/>
               </a:rPr>
-              <a:t>Nhấn</a:t>
-            </a:r>
-            <a:r>
-              <a:rPr lang="en-US" sz="3300" b="1" dirty="0" spc="-19" kern="0">
+              <a:t>Python</a:t>
+            </a:r>
+            <a:r>
+              <a:rPr lang="en-US" sz="3300" b="1" dirty="0" spc="-30" kern="0">
                 <a:solidFill>
                   <a:srgbClr val="FFB454"/>
                 </a:solidFill>
@@ -10965,10 +10833,10 @@
                 <a:ea typeface="Be Vietnam Pro" pitchFamily="34" charset="-122"/>
                 <a:cs typeface="Be Vietnam Pro" pitchFamily="34" charset="-120"/>
               </a:rPr>
-              <a:t> vào</a:t>
-            </a:r>
-            <a:r>
-              <a:rPr lang="en-US" sz="3300" b="1" dirty="0" spc="1" kern="0">
+              <a:t> và</a:t>
+            </a:r>
+            <a:r>
+              <a:rPr lang="en-US" sz="3300" b="1" dirty="0" spc="-14" kern="0">
                 <a:solidFill>
                   <a:srgbClr val="FFB454"/>
                 </a:solidFill>
@@ -10976,51 +10844,7 @@
                 <a:ea typeface="Be Vietnam Pro" pitchFamily="34" charset="-122"/>
                 <a:cs typeface="Be Vietnam Pro" pitchFamily="34" charset="-120"/>
               </a:rPr>
-              <a:t> an</a:t>
-            </a:r>
-            <a:r>
-              <a:rPr lang="en-US" sz="3300" b="1" dirty="0" spc="-9" kern="0">
-                <a:solidFill>
-                  <a:srgbClr val="FFB454"/>
-                </a:solidFill>
-                <a:latin typeface="Be Vietnam Pro" pitchFamily="34" charset="0"/>
-                <a:ea typeface="Be Vietnam Pro" pitchFamily="34" charset="-122"/>
-                <a:cs typeface="Be Vietnam Pro" pitchFamily="34" charset="-120"/>
-              </a:rPr>
-              <a:t> toàn</a:t>
-            </a:r>
-            <a:r>
-              <a:rPr lang="en-US" sz="3300" b="1" dirty="0" spc="-31" kern="0">
-                <a:solidFill>
-                  <a:srgbClr val="FFB454"/>
-                </a:solidFill>
-                <a:latin typeface="Be Vietnam Pro" pitchFamily="34" charset="0"/>
-                <a:ea typeface="Be Vietnam Pro" pitchFamily="34" charset="-122"/>
-                <a:cs typeface="Be Vietnam Pro" pitchFamily="34" charset="-120"/>
-              </a:rPr>
-              <a:t> và</a:t>
-            </a:r>
-            <a:r>
-              <a:rPr lang="en-US" sz="3300" b="1" dirty="0" spc="3" kern="0">
-                <a:solidFill>
-                  <a:srgbClr val="FFB454"/>
-                </a:solidFill>
-                <a:latin typeface="Be Vietnam Pro" pitchFamily="34" charset="0"/>
-                <a:ea typeface="Be Vietnam Pro" pitchFamily="34" charset="-122"/>
-                <a:cs typeface="Be Vietnam Pro" pitchFamily="34" charset="-120"/>
-              </a:rPr>
-              <a:t> đơn</a:t>
-            </a:r>
-            <a:r>
-              <a:rPr lang="en-US" sz="3300" b="1" dirty="0" spc="1" kern="0">
-                <a:solidFill>
-                  <a:srgbClr val="FFB454"/>
-                </a:solidFill>
-                <a:latin typeface="Be Vietnam Pro" pitchFamily="34" charset="0"/>
-                <a:ea typeface="Be Vietnam Pro" pitchFamily="34" charset="-122"/>
-                <a:cs typeface="Be Vietnam Pro" pitchFamily="34" charset="-120"/>
-              </a:rPr>
-              <a:t> giản</a:t>
+              <a:t> JavaScript</a:t>
             </a:r>
             <a:endParaRPr lang="en-US" sz="3300" dirty="0"/>
           </a:p>
@@ -11098,26 +10922,48 @@
               <a:buNone/>
             </a:pPr>
             <a:r>
-              <a:rPr lang="en-US" sz="2250" b="1" dirty="0" spc="-4" kern="0">
-                <a:solidFill>
-                  <a:srgbClr val="14161C"/>
-                </a:solidFill>
-                <a:latin typeface="Be Vietnam Pro" pitchFamily="34" charset="0"/>
-                <a:ea typeface="Be Vietnam Pro" pitchFamily="34" charset="-122"/>
-                <a:cs typeface="Be Vietnam Pro" pitchFamily="34" charset="-120"/>
-              </a:rPr>
-              <a:t>dễ</a:t>
-            </a:r>
-            <a:r>
-              <a:rPr lang="en-US" sz="2250" b="1" dirty="0" spc="-1" kern="0">
-                <a:solidFill>
-                  <a:srgbClr val="14161C"/>
-                </a:solidFill>
-                <a:latin typeface="Be Vietnam Pro" pitchFamily="34" charset="0"/>
-                <a:ea typeface="Be Vietnam Pro" pitchFamily="34" charset="-122"/>
-                <a:cs typeface="Be Vietnam Pro" pitchFamily="34" charset="-120"/>
-              </a:rPr>
-              <a:t> học</a:t>
+              <a:rPr lang="en-US" sz="2250" b="1" dirty="0" spc="12" kern="0">
+                <a:solidFill>
+                  <a:srgbClr val="14161C"/>
+                </a:solidFill>
+                <a:latin typeface="Be Vietnam Pro" pitchFamily="34" charset="0"/>
+                <a:ea typeface="Be Vietnam Pro" pitchFamily="34" charset="-122"/>
+                <a:cs typeface="Be Vietnam Pro" pitchFamily="34" charset="-120"/>
+              </a:rPr>
+              <a:t>đầu</a:t>
+            </a:r>
+            <a:r>
+              <a:rPr lang="en-US" sz="2250" b="1" dirty="0" spc="2" kern="0">
+                <a:solidFill>
+                  <a:srgbClr val="14161C"/>
+                </a:solidFill>
+                <a:latin typeface="Be Vietnam Pro" pitchFamily="34" charset="0"/>
+                <a:ea typeface="Be Vietnam Pro" pitchFamily="34" charset="-122"/>
+                <a:cs typeface="Be Vietnam Pro" pitchFamily="34" charset="-120"/>
+              </a:rPr>
+              <a:t> thập</a:t>
+            </a:r>
+            <a:r>
+              <a:rPr lang="en-US" sz="2250" b="1" dirty="0" spc="-3" kern="0">
+                <a:solidFill>
+                  <a:srgbClr val="14161C"/>
+                </a:solidFill>
+                <a:latin typeface="Be Vietnam Pro" pitchFamily="34" charset="0"/>
+                <a:ea typeface="Be Vietnam Pro" pitchFamily="34" charset="-122"/>
+                <a:cs typeface="Be Vietnam Pro" pitchFamily="34" charset="-120"/>
+              </a:rPr>
+              <a:t> niên</a:t>
+            </a:r>
+            <a:r>
+              <a:rPr lang="en-US" sz="2250" b="1" dirty="0" spc="0" kern="0">
+                <a:solidFill>
+                  <a:srgbClr val="14161C"/>
+                </a:solidFill>
+                <a:latin typeface="Be Vietnam Pro" pitchFamily="34" charset="0"/>
+                <a:ea typeface="Be Vietnam Pro" pitchFamily="34" charset="-122"/>
+                <a:cs typeface="Be Vietnam Pro" pitchFamily="34" charset="-120"/>
+              </a:rPr>
+              <a:t> 1990</a:t>
             </a:r>
             <a:endParaRPr lang="en-US" sz="2250" dirty="0"/>
           </a:p>
@@ -11152,6 +10998,39 @@
               <a:buNone/>
             </a:pPr>
             <a:r>
+              <a:rPr lang="en-US" sz="2250" b="1" dirty="0" spc="-44" kern="0">
+                <a:solidFill>
+                  <a:srgbClr val="14161C"/>
+                </a:solidFill>
+                <a:latin typeface="Be Vietnam Pro" pitchFamily="34" charset="0"/>
+                <a:ea typeface="Be Vietnam Pro" pitchFamily="34" charset="-122"/>
+                <a:cs typeface="Be Vietnam Pro" pitchFamily="34" charset="-120"/>
+              </a:rPr>
+              <a:t>kế</a:t>
+            </a:r>
+            <a:r>
+              <a:rPr lang="en-US" sz="2250" b="1" dirty="0" spc="1" kern="0">
+                <a:solidFill>
+                  <a:srgbClr val="14161C"/>
+                </a:solidFill>
+                <a:latin typeface="Be Vietnam Pro" pitchFamily="34" charset="0"/>
+                <a:ea typeface="Be Vietnam Pro" pitchFamily="34" charset="-122"/>
+                <a:cs typeface="Be Vietnam Pro" pitchFamily="34" charset="-120"/>
+              </a:rPr>
+              <a:t> nhiệm</a:t>
+            </a:r>
+            <a:r>
+              <a:rPr lang="en-US" sz="2250" b="1" dirty="0" spc="-10" kern="0">
+                <a:solidFill>
+                  <a:srgbClr val="14161C"/>
+                </a:solidFill>
+                <a:latin typeface="Be Vietnam Pro" pitchFamily="34" charset="0"/>
+                <a:ea typeface="Be Vietnam Pro" pitchFamily="34" charset="-122"/>
+                <a:cs typeface="Be Vietnam Pro" pitchFamily="34" charset="-120"/>
+              </a:rPr>
+              <a:t> ngôn</a:t>
+            </a:r>
+            <a:r>
               <a:rPr lang="en-US" sz="2250" b="1" dirty="0" spc="-4" kern="0">
                 <a:solidFill>
                   <a:srgbClr val="14161C"/>
@@ -11160,29 +11039,18 @@
                 <a:ea typeface="Be Vietnam Pro" pitchFamily="34" charset="-122"/>
                 <a:cs typeface="Be Vietnam Pro" pitchFamily="34" charset="-120"/>
               </a:rPr>
-              <a:t>dễ</a:t>
-            </a:r>
-            <a:r>
-              <a:rPr lang="en-US" sz="2250" b="1" dirty="0" spc="0" kern="0">
-                <a:solidFill>
-                  <a:srgbClr val="14161C"/>
-                </a:solidFill>
-                <a:latin typeface="Be Vietnam Pro" pitchFamily="34" charset="0"/>
-                <a:ea typeface="Be Vietnam Pro" pitchFamily="34" charset="-122"/>
-                <a:cs typeface="Be Vietnam Pro" pitchFamily="34" charset="-120"/>
-              </a:rPr>
-              <a:t> mở</a:t>
-            </a:r>
-            <a:r>
-              <a:rPr lang="en-US" sz="2250" b="1" dirty="0" spc="-14" kern="0">
-                <a:solidFill>
-                  <a:srgbClr val="14161C"/>
-                </a:solidFill>
-                <a:latin typeface="Be Vietnam Pro" pitchFamily="34" charset="0"/>
-                <a:ea typeface="Be Vietnam Pro" pitchFamily="34" charset="-122"/>
-                <a:cs typeface="Be Vietnam Pro" pitchFamily="34" charset="-120"/>
-              </a:rPr>
-              <a:t> rộng</a:t>
+              <a:t> ngữ</a:t>
+            </a:r>
+            <a:r>
+              <a:rPr lang="en-US" sz="2250" b="1" dirty="0" spc="3" kern="0">
+                <a:solidFill>
+                  <a:srgbClr val="14161C"/>
+                </a:solidFill>
+                <a:latin typeface="Be Vietnam Pro" pitchFamily="34" charset="0"/>
+                <a:ea typeface="Be Vietnam Pro" pitchFamily="34" charset="-122"/>
+                <a:cs typeface="Be Vietnam Pro" pitchFamily="34" charset="-120"/>
+              </a:rPr>
+              <a:t> cũ</a:t>
             </a:r>
             <a:endParaRPr lang="en-US" sz="2250" dirty="0"/>
           </a:p>
@@ -11552,7 +11420,7 @@
               <a:buNone/>
             </a:pPr>
             <a:r>
-              <a:rPr lang="en-US" sz="1650" b="1" spc="94" kern="0" dirty="0">
+              <a:rPr lang="en-US" sz="1650" b="1" spc="93" kern="0" dirty="0">
                 <a:solidFill>
                   <a:srgbClr val="FFB454"/>
                 </a:solidFill>
@@ -11560,10 +11428,10 @@
                 <a:ea typeface="Be Vietnam Pro" pitchFamily="34" charset="-122"/>
                 <a:cs typeface="Be Vietnam Pro" pitchFamily="34" charset="-120"/>
               </a:rPr>
-              <a:t>MÁY</a:t>
-            </a:r>
-            <a:r>
-              <a:rPr lang="en-US" sz="1650" b="1" spc="149" kern="0" dirty="0">
+              <a:t>TÀI</a:t>
+            </a:r>
+            <a:r>
+              <a:rPr lang="en-US" sz="1650" b="1" spc="153" kern="0" dirty="0">
                 <a:solidFill>
                   <a:srgbClr val="FFB454"/>
                 </a:solidFill>
@@ -11571,10 +11439,10 @@
                 <a:ea typeface="Be Vietnam Pro" pitchFamily="34" charset="-122"/>
                 <a:cs typeface="Be Vietnam Pro" pitchFamily="34" charset="-120"/>
               </a:rPr>
-              <a:t> TÍNH</a:t>
-            </a:r>
-            <a:r>
-              <a:rPr lang="en-US" sz="1650" b="1" spc="128" kern="0" dirty="0">
+              <a:t> LIỆU</a:t>
+            </a:r>
+            <a:r>
+              <a:rPr lang="en-US" sz="1650" b="1" spc="152" kern="0" dirty="0">
                 <a:solidFill>
                   <a:srgbClr val="FFB454"/>
                 </a:solidFill>
@@ -11582,18 +11450,7 @@
                 <a:ea typeface="Be Vietnam Pro" pitchFamily="34" charset="-122"/>
                 <a:cs typeface="Be Vietnam Pro" pitchFamily="34" charset="-120"/>
               </a:rPr>
-              <a:t> CÁ</a:t>
-            </a:r>
-            <a:r>
-              <a:rPr lang="en-US" sz="1650" b="1" spc="148" kern="0" dirty="0">
-                <a:solidFill>
-                  <a:srgbClr val="FFB454"/>
-                </a:solidFill>
-                <a:latin typeface="Be Vietnam Pro" pitchFamily="34" charset="0"/>
-                <a:ea typeface="Be Vietnam Pro" pitchFamily="34" charset="-122"/>
-                <a:cs typeface="Be Vietnam Pro" pitchFamily="34" charset="-120"/>
-              </a:rPr>
-              <a:t> NHÂN</a:t>
+              <a:t> MDN</a:t>
             </a:r>
             <a:endParaRPr lang="en-US" sz="1650" dirty="0"/>
           </a:p>
@@ -11624,7 +11481,7 @@
               <a:buNone/>
             </a:pPr>
             <a:r>
-              <a:rPr lang="en-US" sz="2850" b="1" dirty="0" spc="-2" kern="0">
+              <a:rPr lang="en-US" sz="2850" b="1" dirty="0" spc="-10" kern="0">
                 <a:solidFill>
                   <a:srgbClr val="F3EEE3"/>
                 </a:solidFill>
@@ -11632,10 +11489,10 @@
                 <a:ea typeface="Be Vietnam Pro" pitchFamily="34" charset="-122"/>
                 <a:cs typeface="Be Vietnam Pro" pitchFamily="34" charset="-120"/>
               </a:rPr>
-              <a:t>PC</a:t>
-            </a:r>
-            <a:r>
-              <a:rPr lang="en-US" sz="2850" b="1" dirty="0" spc="-20" kern="0">
+              <a:t>JavaScript,</a:t>
+            </a:r>
+            <a:r>
+              <a:rPr lang="en-US" sz="2850" b="1" dirty="0" spc="1" kern="0">
                 <a:solidFill>
                   <a:srgbClr val="F3EEE3"/>
                 </a:solidFill>
@@ -11643,18 +11500,7 @@
                 <a:ea typeface="Be Vietnam Pro" pitchFamily="34" charset="-122"/>
                 <a:cs typeface="Be Vietnam Pro" pitchFamily="34" charset="-120"/>
               </a:rPr>
-              <a:t> rẻ</a:t>
-            </a:r>
-            <a:r>
-              <a:rPr lang="en-US" sz="2850" b="1" dirty="0" spc="-5" kern="0">
-                <a:solidFill>
-                  <a:srgbClr val="F3EEE3"/>
-                </a:solidFill>
-                <a:latin typeface="Be Vietnam Pro" pitchFamily="34" charset="0"/>
-                <a:ea typeface="Be Vietnam Pro" pitchFamily="34" charset="-122"/>
-                <a:cs typeface="Be Vietnam Pro" pitchFamily="34" charset="-120"/>
-              </a:rPr>
-              <a:t> hơn</a:t>
+              <a:t> 9/1995</a:t>
             </a:r>
             <a:endParaRPr lang="en-US" sz="2850" dirty="0"/>
           </a:p>
@@ -11828,7 +11674,7 @@
               <a:buNone/>
             </a:pPr>
             <a:r>
-              <a:rPr lang="en-US" sz="2250" dirty="0" spc="0" kern="0">
+              <a:rPr lang="en-US" sz="2250" dirty="0" spc="13" kern="0">
                 <a:solidFill>
                   <a:srgbClr val="C4C8D6"/>
                 </a:solidFill>
@@ -11836,7 +11682,18 @@
                 <a:ea typeface="Be Vietnam Pro" pitchFamily="34" charset="-122"/>
                 <a:cs typeface="Be Vietnam Pro" pitchFamily="34" charset="-120"/>
               </a:rPr>
-              <a:t>dễ</a:t>
+              <a:t>đầu</a:t>
+            </a:r>
+            <a:r>
+              <a:rPr lang="en-US" sz="2250" dirty="0" spc="1" kern="0">
+                <a:solidFill>
+                  <a:srgbClr val="C4C8D6"/>
+                </a:solidFill>
+                <a:latin typeface="Be Vietnam Pro" pitchFamily="34" charset="0"/>
+                <a:ea typeface="Be Vietnam Pro" pitchFamily="34" charset="-122"/>
+                <a:cs typeface="Be Vietnam Pro" pitchFamily="34" charset="-120"/>
+              </a:rPr>
+              <a:t> thập</a:t>
             </a:r>
             <a:r>
               <a:rPr lang="en-US" sz="2250" dirty="0" spc="-1" kern="0">
@@ -11847,7 +11704,7 @@
                 <a:ea typeface="Be Vietnam Pro" pitchFamily="34" charset="-122"/>
                 <a:cs typeface="Be Vietnam Pro" pitchFamily="34" charset="-120"/>
               </a:rPr>
-              <a:t> học,</a:t>
+              <a:t> niên</a:t>
             </a:r>
             <a:r>
               <a:rPr lang="en-US" sz="2250" dirty="0" spc="2" kern="0">
@@ -11858,10 +11715,10 @@
                 <a:ea typeface="Be Vietnam Pro" pitchFamily="34" charset="-122"/>
                 <a:cs typeface="Be Vietnam Pro" pitchFamily="34" charset="-120"/>
               </a:rPr>
-              <a:t> dễ mở</a:t>
-            </a:r>
-            <a:r>
-              <a:rPr lang="en-US" sz="2250" dirty="0" spc="-16" kern="0">
+              <a:t> 1990,</a:t>
+            </a:r>
+            <a:r>
+              <a:rPr lang="en-US" sz="2250" dirty="0" spc="-34" kern="0">
                 <a:solidFill>
                   <a:srgbClr val="C4C8D6"/>
                 </a:solidFill>
@@ -11869,10 +11726,10 @@
                 <a:ea typeface="Be Vietnam Pro" pitchFamily="34" charset="-122"/>
                 <a:cs typeface="Be Vietnam Pro" pitchFamily="34" charset="-120"/>
               </a:rPr>
-              <a:t> rộng,</a:t>
-            </a:r>
-            <a:r>
-              <a:rPr lang="en-US" sz="2250" dirty="0" spc="1" kern="0">
+              <a:t> kế</a:t>
+            </a:r>
+            <a:r>
+              <a:rPr lang="en-US" sz="2250" dirty="0" spc="-2" kern="0">
                 <a:solidFill>
                   <a:srgbClr val="C4C8D6"/>
                 </a:solidFill>
@@ -11880,10 +11737,10 @@
                 <a:ea typeface="Be Vietnam Pro" pitchFamily="34" charset="-122"/>
                 <a:cs typeface="Be Vietnam Pro" pitchFamily="34" charset="-120"/>
               </a:rPr>
-              <a:t> nhanh</a:t>
-            </a:r>
-            <a:r>
-              <a:rPr lang="en-US" sz="2250" dirty="0" spc="9" kern="0">
+              <a:t> nhiệm</a:t>
+            </a:r>
+            <a:r>
+              <a:rPr lang="en-US" sz="2250" dirty="0" spc="-3" kern="0">
                 <a:solidFill>
                   <a:srgbClr val="C4C8D6"/>
                 </a:solidFill>
@@ -11891,7 +11748,18 @@
                 <a:ea typeface="Be Vietnam Pro" pitchFamily="34" charset="-122"/>
                 <a:cs typeface="Be Vietnam Pro" pitchFamily="34" charset="-120"/>
               </a:rPr>
-              <a:t> được ưa</a:t>
+              <a:t> một</a:t>
+            </a:r>
+            <a:r>
+              <a:rPr lang="en-US" sz="2250" dirty="0" spc="-7" kern="0">
+                <a:solidFill>
+                  <a:srgbClr val="C4C8D6"/>
+                </a:solidFill>
+                <a:latin typeface="Be Vietnam Pro" pitchFamily="34" charset="0"/>
+                <a:ea typeface="Be Vietnam Pro" pitchFamily="34" charset="-122"/>
+                <a:cs typeface="Be Vietnam Pro" pitchFamily="34" charset="-120"/>
+              </a:rPr>
+              <a:t> ngôn</a:t>
             </a:r>
             <a:r>
               <a:rPr lang="en-US" sz="2250" dirty="0" spc="2" kern="0">
@@ -11902,7 +11770,18 @@
                 <a:ea typeface="Be Vietnam Pro" pitchFamily="34" charset="-122"/>
                 <a:cs typeface="Be Vietnam Pro" pitchFamily="34" charset="-120"/>
               </a:rPr>
-              <a:t> chuộng</a:t>
+              <a:t> ngữ</a:t>
+            </a:r>
+            <a:r>
+              <a:rPr lang="en-US" sz="2250" dirty="0" spc="4" kern="0">
+                <a:solidFill>
+                  <a:srgbClr val="C4C8D6"/>
+                </a:solidFill>
+                <a:latin typeface="Be Vietnam Pro" pitchFamily="34" charset="0"/>
+                <a:ea typeface="Be Vietnam Pro" pitchFamily="34" charset="-122"/>
+                <a:cs typeface="Be Vietnam Pro" pitchFamily="34" charset="-120"/>
+              </a:rPr>
+              <a:t> cũ</a:t>
             </a:r>
             <a:endParaRPr lang="en-US" sz="2250" dirty="0"/>
           </a:p>
@@ -12521,7 +12400,7 @@
               <a:buNone/>
             </a:pPr>
             <a:r>
-              <a:rPr lang="en-US" sz="2850" b="1" dirty="0" spc="4" kern="0">
+              <a:rPr lang="en-US" sz="2850" b="1" dirty="0" spc="1" kern="0">
                 <a:solidFill>
                   <a:srgbClr val="F3EEE3"/>
                 </a:solidFill>
@@ -12529,21 +12408,10 @@
                 <a:ea typeface="Be Vietnam Pro" pitchFamily="34" charset="-122"/>
                 <a:cs typeface="Be Vietnam Pro" pitchFamily="34" charset="-120"/>
               </a:rPr>
-              <a:t>An</a:t>
-            </a:r>
-            <a:r>
-              <a:rPr lang="en-US" sz="2850" b="1" dirty="0" spc="-4" kern="0">
-                <a:solidFill>
-                  <a:srgbClr val="F3EEE3"/>
-                </a:solidFill>
-                <a:latin typeface="Be Vietnam Pro" pitchFamily="34" charset="0"/>
-                <a:ea typeface="Be Vietnam Pro" pitchFamily="34" charset="-122"/>
-                <a:cs typeface="Be Vietnam Pro" pitchFamily="34" charset="-120"/>
-              </a:rPr>
-              <a:t> toàn</a:t>
-            </a:r>
-            <a:r>
-              <a:rPr lang="en-US" sz="2850" b="1" dirty="0" spc="-20" kern="0">
+              <a:t>Python</a:t>
+            </a:r>
+            <a:r>
+              <a:rPr lang="en-US" sz="2850" b="1" dirty="0" spc="-21" kern="0">
                 <a:solidFill>
                   <a:srgbClr val="F3EEE3"/>
                 </a:solidFill>
@@ -12560,7 +12428,7 @@
               <a:buNone/>
             </a:pPr>
             <a:r>
-              <a:rPr lang="en-US" sz="2850" b="1" dirty="0" spc="7" kern="0">
+              <a:rPr lang="en-US" sz="2850" b="1" dirty="0" spc="-11" kern="0">
                 <a:solidFill>
                   <a:srgbClr val="F3EEE3"/>
                 </a:solidFill>
@@ -12568,18 +12436,7 @@
                 <a:ea typeface="Be Vietnam Pro" pitchFamily="34" charset="-122"/>
                 <a:cs typeface="Be Vietnam Pro" pitchFamily="34" charset="-120"/>
               </a:rPr>
-              <a:t>đơn</a:t>
-            </a:r>
-            <a:r>
-              <a:rPr lang="en-US" sz="2850" b="1" dirty="0" spc="6" kern="0">
-                <a:solidFill>
-                  <a:srgbClr val="F3EEE3"/>
-                </a:solidFill>
-                <a:latin typeface="Be Vietnam Pro" pitchFamily="34" charset="0"/>
-                <a:ea typeface="Be Vietnam Pro" pitchFamily="34" charset="-122"/>
-                <a:cs typeface="Be Vietnam Pro" pitchFamily="34" charset="-120"/>
-              </a:rPr>
-              <a:t> giản</a:t>
+              <a:t>JavaScript</a:t>
             </a:r>
             <a:endParaRPr lang="en-US" sz="2850" dirty="0"/>
           </a:p>
@@ -12613,7 +12470,7 @@
               <a:buNone/>
             </a:pPr>
             <a:r>
-              <a:rPr lang="en-US" sz="2850" dirty="0" spc="-13" kern="0">
+              <a:rPr lang="en-US" sz="2850" dirty="0" spc="8" kern="0">
                 <a:solidFill>
                   <a:srgbClr val="C4C8D6"/>
                 </a:solidFill>
@@ -12621,7 +12478,29 @@
                 <a:ea typeface="Be Vietnam Pro" pitchFamily="34" charset="-122"/>
                 <a:cs typeface="Be Vietnam Pro" pitchFamily="34" charset="-120"/>
               </a:rPr>
-              <a:t>Máy</a:t>
+              <a:t>Python</a:t>
+            </a:r>
+            <a:r>
+              <a:rPr lang="en-US" sz="2850" dirty="0" spc="-33" kern="0">
+                <a:solidFill>
+                  <a:srgbClr val="C4C8D6"/>
+                </a:solidFill>
+                <a:latin typeface="Be Vietnam Pro" pitchFamily="34" charset="0"/>
+                <a:ea typeface="Be Vietnam Pro" pitchFamily="34" charset="-122"/>
+                <a:cs typeface="Be Vietnam Pro" pitchFamily="34" charset="-120"/>
+              </a:rPr>
+              <a:t> ra</a:t>
+            </a:r>
+            <a:r>
+              <a:rPr lang="en-US" sz="2850" dirty="0" spc="15" kern="0">
+                <a:solidFill>
+                  <a:srgbClr val="C4C8D6"/>
+                </a:solidFill>
+                <a:latin typeface="Be Vietnam Pro" pitchFamily="34" charset="0"/>
+                <a:ea typeface="Be Vietnam Pro" pitchFamily="34" charset="-122"/>
+                <a:cs typeface="Be Vietnam Pro" pitchFamily="34" charset="-120"/>
+              </a:rPr>
+              <a:t> đời đầu</a:t>
             </a:r>
             <a:r>
               <a:rPr lang="en-US" sz="2850" dirty="0" spc="-1" kern="0">
@@ -12632,10 +12511,10 @@
                 <a:ea typeface="Be Vietnam Pro" pitchFamily="34" charset="-122"/>
                 <a:cs typeface="Be Vietnam Pro" pitchFamily="34" charset="-120"/>
               </a:rPr>
-              <a:t> tính</a:t>
-            </a:r>
-            <a:r>
-              <a:rPr lang="en-US" sz="2850" dirty="0" spc="0" kern="0">
+              <a:t> thập niên</a:t>
+            </a:r>
+            <a:r>
+              <a:rPr lang="en-US" sz="2850" dirty="0" spc="1" kern="0">
                 <a:solidFill>
                   <a:srgbClr val="C4C8D6"/>
                 </a:solidFill>
@@ -12643,7 +12522,29 @@
                 <a:ea typeface="Be Vietnam Pro" pitchFamily="34" charset="-122"/>
                 <a:cs typeface="Be Vietnam Pro" pitchFamily="34" charset="-120"/>
               </a:rPr>
-              <a:t> cá</a:t>
+              <a:t> 1990;</a:t>
+            </a:r>
+            <a:r>
+              <a:rPr lang="en-US" sz="2850" dirty="0" spc="-7" kern="0">
+                <a:solidFill>
+                  <a:srgbClr val="C4C8D6"/>
+                </a:solidFill>
+                <a:latin typeface="Be Vietnam Pro" pitchFamily="34" charset="0"/>
+                <a:ea typeface="Be Vietnam Pro" pitchFamily="34" charset="-122"/>
+                <a:cs typeface="Be Vietnam Pro" pitchFamily="34" charset="-120"/>
+              </a:rPr>
+              <a:t> JavaScript</a:t>
+            </a:r>
+            <a:r>
+              <a:rPr lang="en-US" sz="2850" dirty="0" spc="-10" kern="0">
+                <a:solidFill>
+                  <a:srgbClr val="C4C8D6"/>
+                </a:solidFill>
+                <a:latin typeface="Be Vietnam Pro" pitchFamily="34" charset="0"/>
+                <a:ea typeface="Be Vietnam Pro" pitchFamily="34" charset="-122"/>
+                <a:cs typeface="Be Vietnam Pro" pitchFamily="34" charset="-120"/>
+              </a:rPr>
+              <a:t> vào Netscape</a:t>
             </a:r>
             <a:r>
               <a:rPr lang="en-US" sz="2850" dirty="0" spc="-1" kern="0">
@@ -12654,10 +12555,10 @@
                 <a:ea typeface="Be Vietnam Pro" pitchFamily="34" charset="-122"/>
                 <a:cs typeface="Be Vietnam Pro" pitchFamily="34" charset="-120"/>
               </a:rPr>
-              <a:t> nhân</a:t>
-            </a:r>
-            <a:r>
-              <a:rPr lang="en-US" sz="2850" dirty="0" spc="0" kern="0">
+              <a:t> tháng</a:t>
+            </a:r>
+            <a:r>
+              <a:rPr lang="en-US" sz="2850" dirty="0" spc="2" kern="0">
                 <a:solidFill>
                   <a:srgbClr val="C4C8D6"/>
                 </a:solidFill>
@@ -12665,10 +12566,10 @@
                 <a:ea typeface="Be Vietnam Pro" pitchFamily="34" charset="-122"/>
                 <a:cs typeface="Be Vietnam Pro" pitchFamily="34" charset="-120"/>
               </a:rPr>
-              <a:t> (PC)</a:t>
-            </a:r>
-            <a:r>
-              <a:rPr lang="en-US" sz="2850" dirty="0" spc="-35" kern="0">
+              <a:t> 9</a:t>
+            </a:r>
+            <a:r>
+              <a:rPr lang="en-US" sz="2850" dirty="0" spc="-2" kern="0">
                 <a:solidFill>
                   <a:srgbClr val="C4C8D6"/>
                 </a:solidFill>
@@ -12676,7 +12577,7 @@
                 <a:ea typeface="Be Vietnam Pro" pitchFamily="34" charset="-122"/>
                 <a:cs typeface="Be Vietnam Pro" pitchFamily="34" charset="-120"/>
               </a:rPr>
-              <a:t> rẻ</a:t>
+              <a:t> năm</a:t>
             </a:r>
             <a:r>
               <a:rPr lang="en-US" sz="2850" dirty="0" spc="2" kern="0">
@@ -12687,95 +12588,7 @@
                 <a:ea typeface="Be Vietnam Pro" pitchFamily="34" charset="-122"/>
                 <a:cs typeface="Be Vietnam Pro" pitchFamily="34" charset="-120"/>
               </a:rPr>
-              <a:t> hơn.</a:t>
-            </a:r>
-            <a:r>
-              <a:rPr lang="en-US" sz="2850" dirty="0" spc="7" kern="0">
-                <a:solidFill>
-                  <a:srgbClr val="C4C8D6"/>
-                </a:solidFill>
-                <a:latin typeface="Be Vietnam Pro" pitchFamily="34" charset="0"/>
-                <a:ea typeface="Be Vietnam Pro" pitchFamily="34" charset="-122"/>
-                <a:cs typeface="Be Vietnam Pro" pitchFamily="34" charset="-120"/>
-              </a:rPr>
-              <a:t> Python</a:t>
-            </a:r>
-            <a:r>
-              <a:rPr lang="en-US" sz="2850" dirty="0" spc="-32" kern="0">
-                <a:solidFill>
-                  <a:srgbClr val="C4C8D6"/>
-                </a:solidFill>
-                <a:latin typeface="Be Vietnam Pro" pitchFamily="34" charset="0"/>
-                <a:ea typeface="Be Vietnam Pro" pitchFamily="34" charset="-122"/>
-                <a:cs typeface="Be Vietnam Pro" pitchFamily="34" charset="-120"/>
-              </a:rPr>
-              <a:t> ra</a:t>
-            </a:r>
-            <a:r>
-              <a:rPr lang="en-US" sz="2850" dirty="0" spc="15" kern="0">
-                <a:solidFill>
-                  <a:srgbClr val="C4C8D6"/>
-                </a:solidFill>
-                <a:latin typeface="Be Vietnam Pro" pitchFamily="34" charset="0"/>
-                <a:ea typeface="Be Vietnam Pro" pitchFamily="34" charset="-122"/>
-                <a:cs typeface="Be Vietnam Pro" pitchFamily="34" charset="-120"/>
-              </a:rPr>
-              <a:t> đời</a:t>
-            </a:r>
-            <a:r>
-              <a:rPr lang="en-US" sz="2850" dirty="0" spc="-17" kern="0">
-                <a:solidFill>
-                  <a:srgbClr val="C4C8D6"/>
-                </a:solidFill>
-                <a:latin typeface="Be Vietnam Pro" pitchFamily="34" charset="0"/>
-                <a:ea typeface="Be Vietnam Pro" pitchFamily="34" charset="-122"/>
-                <a:cs typeface="Be Vietnam Pro" pitchFamily="34" charset="-120"/>
-              </a:rPr>
-              <a:t> và</a:t>
-            </a:r>
-            <a:r>
-              <a:rPr lang="en-US" sz="2850" dirty="0" spc="0" kern="0">
-                <a:solidFill>
-                  <a:srgbClr val="C4C8D6"/>
-                </a:solidFill>
-                <a:latin typeface="Be Vietnam Pro" pitchFamily="34" charset="0"/>
-                <a:ea typeface="Be Vietnam Pro" pitchFamily="34" charset="-122"/>
-                <a:cs typeface="Be Vietnam Pro" pitchFamily="34" charset="-120"/>
-              </a:rPr>
-              <a:t> nhanh</a:t>
-            </a:r>
-            <a:r>
-              <a:rPr lang="en-US" sz="2850" dirty="0" spc="9" kern="0">
-                <a:solidFill>
-                  <a:srgbClr val="C4C8D6"/>
-                </a:solidFill>
-                <a:latin typeface="Be Vietnam Pro" pitchFamily="34" charset="0"/>
-                <a:ea typeface="Be Vietnam Pro" pitchFamily="34" charset="-122"/>
-                <a:cs typeface="Be Vietnam Pro" pitchFamily="34" charset="-120"/>
-              </a:rPr>
-              <a:t> được</a:t>
-            </a:r>
-            <a:r>
-              <a:rPr lang="en-US" sz="2850" dirty="0" spc="19" kern="0">
-                <a:solidFill>
-                  <a:srgbClr val="C4C8D6"/>
-                </a:solidFill>
-                <a:latin typeface="Be Vietnam Pro" pitchFamily="34" charset="0"/>
-                <a:ea typeface="Be Vietnam Pro" pitchFamily="34" charset="-122"/>
-                <a:cs typeface="Be Vietnam Pro" pitchFamily="34" charset="-120"/>
-              </a:rPr>
-              <a:t> ưa</a:t>
-            </a:r>
-            <a:r>
-              <a:rPr lang="en-US" sz="2850" dirty="0" spc="-1" kern="0">
-                <a:solidFill>
-                  <a:srgbClr val="C4C8D6"/>
-                </a:solidFill>
-                <a:latin typeface="Be Vietnam Pro" pitchFamily="34" charset="0"/>
-                <a:ea typeface="Be Vietnam Pro" pitchFamily="34" charset="-122"/>
-                <a:cs typeface="Be Vietnam Pro" pitchFamily="34" charset="-120"/>
-              </a:rPr>
-              <a:t> chuộng.</a:t>
+              <a:t> 1995.</a:t>
             </a:r>
             <a:endParaRPr lang="en-US" sz="2850" dirty="0"/>
           </a:p>
@@ -13046,7 +12859,7 @@
               <a:buNone/>
             </a:pPr>
             <a:r>
-              <a:rPr lang="en-US" sz="3300" b="1" dirty="0" spc="4" kern="0">
+              <a:rPr lang="en-US" sz="3300" b="1" dirty="0" spc="-5" kern="0">
                 <a:solidFill>
                   <a:srgbClr val="0F766E"/>
                 </a:solidFill>
@@ -13054,10 +12867,10 @@
                 <a:ea typeface="Be Vietnam Pro" pitchFamily="34" charset="-122"/>
                 <a:cs typeface="Be Vietnam Pro" pitchFamily="34" charset="-120"/>
               </a:rPr>
-              <a:t>Cải</a:t>
-            </a:r>
-            <a:r>
-              <a:rPr lang="en-US" sz="3300" b="1" dirty="0" spc="-5" kern="0">
+              <a:t>Mỗi</a:t>
+            </a:r>
+            <a:r>
+              <a:rPr lang="en-US" sz="3300" b="1" dirty="0" spc="-16" kern="0">
                 <a:solidFill>
                   <a:srgbClr val="0F766E"/>
                 </a:solidFill>
@@ -13065,10 +12878,10 @@
                 <a:ea typeface="Be Vietnam Pro" pitchFamily="34" charset="-122"/>
                 <a:cs typeface="Be Vietnam Pro" pitchFamily="34" charset="-120"/>
               </a:rPr>
-              <a:t> thiện</a:t>
-            </a:r>
-            <a:r>
-              <a:rPr lang="en-US" sz="3300" b="1" dirty="0" spc="-1" kern="0">
+              <a:t> ngôn</a:t>
+            </a:r>
+            <a:r>
+              <a:rPr lang="en-US" sz="3300" b="1" dirty="0" spc="-7" kern="0">
                 <a:solidFill>
                   <a:srgbClr val="0F766E"/>
                 </a:solidFill>
@@ -13076,10 +12889,10 @@
                 <a:ea typeface="Be Vietnam Pro" pitchFamily="34" charset="-122"/>
                 <a:cs typeface="Be Vietnam Pro" pitchFamily="34" charset="-120"/>
               </a:rPr>
-              <a:t> C++</a:t>
-            </a:r>
-            <a:r>
-              <a:rPr lang="en-US" sz="3300" b="1" dirty="0" spc="-6" kern="0">
+              <a:t> ngữ</a:t>
+            </a:r>
+            <a:r>
+              <a:rPr lang="en-US" sz="3300" b="1" dirty="0" spc="-17" kern="0">
                 <a:solidFill>
                   <a:srgbClr val="0F766E"/>
                 </a:solidFill>
@@ -13087,10 +12900,10 @@
                 <a:ea typeface="Be Vietnam Pro" pitchFamily="34" charset="-122"/>
                 <a:cs typeface="Be Vietnam Pro" pitchFamily="34" charset="-120"/>
               </a:rPr>
-              <a:t> hoặc</a:t>
-            </a:r>
-            <a:r>
-              <a:rPr lang="en-US" sz="3300" b="1" dirty="0" spc="-34" kern="0">
+              <a:t> một</a:t>
+            </a:r>
+            <a:r>
+              <a:rPr lang="en-US" sz="3300" b="1" dirty="0" spc="-4" kern="0">
                 <a:solidFill>
                   <a:srgbClr val="0F766E"/>
                 </a:solidFill>
@@ -13098,7 +12911,18 @@
                 <a:ea typeface="Be Vietnam Pro" pitchFamily="34" charset="-122"/>
                 <a:cs typeface="Be Vietnam Pro" pitchFamily="34" charset="-120"/>
               </a:rPr>
-              <a:t> Java</a:t>
+              <a:t> mục</a:t>
+            </a:r>
+            <a:r>
+              <a:rPr lang="en-US" sz="3300" b="1" dirty="0" spc="0" kern="0">
+                <a:solidFill>
+                  <a:srgbClr val="0F766E"/>
+                </a:solidFill>
+                <a:latin typeface="Be Vietnam Pro" pitchFamily="34" charset="0"/>
+                <a:ea typeface="Be Vietnam Pro" pitchFamily="34" charset="-122"/>
+                <a:cs typeface="Be Vietnam Pro" pitchFamily="34" charset="-120"/>
+              </a:rPr>
+              <a:t> tiêu</a:t>
             </a:r>
             <a:endParaRPr lang="en-US" sz="3300" dirty="0"/>
           </a:p>
@@ -13151,18 +12975,62 @@
                 <a:ea typeface="Be Vietnam Pro" pitchFamily="34" charset="-122"/>
                 <a:cs typeface="Be Vietnam Pro" pitchFamily="34" charset="-120"/>
               </a:rPr>
-              <a:t> 2000,</a:t>
-            </a:r>
-            <a:r>
-              <a:rPr lang="en-US" sz="2850" dirty="0" spc="-12" kern="0">
-                <a:solidFill>
-                  <a:srgbClr val="14161C"/>
-                </a:solidFill>
-                <a:latin typeface="Be Vietnam Pro" pitchFamily="34" charset="0"/>
-                <a:ea typeface="Be Vietnam Pro" pitchFamily="34" charset="-122"/>
-                <a:cs typeface="Be Vietnam Pro" pitchFamily="34" charset="-120"/>
-              </a:rPr>
-              <a:t> Microsoft</a:t>
+              <a:t> 2000</a:t>
+            </a:r>
+            <a:r>
+              <a:rPr lang="en-US" sz="2850" dirty="0" spc="0" kern="0">
+                <a:solidFill>
+                  <a:srgbClr val="14161C"/>
+                </a:solidFill>
+                <a:latin typeface="Be Vietnam Pro" pitchFamily="34" charset="0"/>
+                <a:ea typeface="Be Vietnam Pro" pitchFamily="34" charset="-122"/>
+                <a:cs typeface="Be Vietnam Pro" pitchFamily="34" charset="-120"/>
+              </a:rPr>
+              <a:t> có</a:t>
+            </a:r>
+            <a:r>
+              <a:rPr lang="en-US" sz="2850" dirty="0" spc="1" kern="0">
+                <a:solidFill>
+                  <a:srgbClr val="14161C"/>
+                </a:solidFill>
+                <a:latin typeface="Be Vietnam Pro" pitchFamily="34" charset="0"/>
+                <a:ea typeface="Be Vietnam Pro" pitchFamily="34" charset="-122"/>
+                <a:cs typeface="Be Vietnam Pro" pitchFamily="34" charset="-120"/>
+              </a:rPr>
+              <a:t> C#.</a:t>
+            </a:r>
+            <a:r>
+              <a:rPr lang="en-US" sz="2850" dirty="0" spc="0" kern="0">
+                <a:solidFill>
+                  <a:srgbClr val="14161C"/>
+                </a:solidFill>
+                <a:latin typeface="Be Vietnam Pro" pitchFamily="34" charset="0"/>
+                <a:ea typeface="Be Vietnam Pro" pitchFamily="34" charset="-122"/>
+                <a:cs typeface="Be Vietnam Pro" pitchFamily="34" charset="-120"/>
+              </a:rPr>
+              <a:t> Thập niên</a:t>
+            </a:r>
+            <a:r>
+              <a:rPr lang="en-US" sz="2850" dirty="0" spc="2" kern="0">
+                <a:solidFill>
+                  <a:srgbClr val="14161C"/>
+                </a:solidFill>
+                <a:latin typeface="Be Vietnam Pro" pitchFamily="34" charset="0"/>
+                <a:ea typeface="Be Vietnam Pro" pitchFamily="34" charset="-122"/>
+                <a:cs typeface="Be Vietnam Pro" pitchFamily="34" charset="-120"/>
+              </a:rPr>
+              <a:t> 2010</a:t>
+            </a:r>
+            <a:r>
+              <a:rPr lang="en-US" sz="2850" dirty="0" spc="0" kern="0">
+                <a:solidFill>
+                  <a:srgbClr val="14161C"/>
+                </a:solidFill>
+                <a:latin typeface="Be Vietnam Pro" pitchFamily="34" charset="0"/>
+                <a:ea typeface="Be Vietnam Pro" pitchFamily="34" charset="-122"/>
+                <a:cs typeface="Be Vietnam Pro" pitchFamily="34" charset="-120"/>
+              </a:rPr>
+              <a:t> có nhiều</a:t>
             </a:r>
             <a:r>
               <a:rPr lang="en-US" sz="2850" dirty="0" spc="-14" kern="0">
@@ -13173,7 +13041,18 @@
                 <a:ea typeface="Be Vietnam Pro" pitchFamily="34" charset="-122"/>
                 <a:cs typeface="Be Vietnam Pro" pitchFamily="34" charset="-120"/>
               </a:rPr>
-              <a:t> phát</a:t>
+              <a:t> ngôn</a:t>
+            </a:r>
+            <a:r>
+              <a:rPr lang="en-US" sz="2850" dirty="0" spc="-2" kern="0">
+                <a:solidFill>
+                  <a:srgbClr val="14161C"/>
+                </a:solidFill>
+                <a:latin typeface="Be Vietnam Pro" pitchFamily="34" charset="0"/>
+                <a:ea typeface="Be Vietnam Pro" pitchFamily="34" charset="-122"/>
+                <a:cs typeface="Be Vietnam Pro" pitchFamily="34" charset="-120"/>
+              </a:rPr>
+              <a:t> ngữ</a:t>
             </a:r>
             <a:r>
               <a:rPr lang="en-US" sz="2850" dirty="0" spc="0" kern="0">
@@ -13184,18 +13063,18 @@
                 <a:ea typeface="Be Vietnam Pro" pitchFamily="34" charset="-122"/>
                 <a:cs typeface="Be Vietnam Pro" pitchFamily="34" charset="-120"/>
               </a:rPr>
-              <a:t> hành</a:t>
-            </a:r>
-            <a:r>
-              <a:rPr lang="en-US" sz="2850" dirty="0" spc="1" kern="0">
-                <a:solidFill>
-                  <a:srgbClr val="14161C"/>
-                </a:solidFill>
-                <a:latin typeface="Be Vietnam Pro" pitchFamily="34" charset="0"/>
-                <a:ea typeface="Be Vietnam Pro" pitchFamily="34" charset="-122"/>
-                <a:cs typeface="Be Vietnam Pro" pitchFamily="34" charset="-120"/>
-              </a:rPr>
-              <a:t> C#.</a:t>
+              <a:t> mới; mỗi</a:t>
+            </a:r>
+            <a:r>
+              <a:rPr lang="en-US" sz="2850" dirty="0" spc="-1" kern="0">
+                <a:solidFill>
+                  <a:srgbClr val="14161C"/>
+                </a:solidFill>
+                <a:latin typeface="Be Vietnam Pro" pitchFamily="34" charset="0"/>
+                <a:ea typeface="Be Vietnam Pro" pitchFamily="34" charset="-122"/>
+                <a:cs typeface="Be Vietnam Pro" pitchFamily="34" charset="-120"/>
+              </a:rPr>
+              <a:t> dự</a:t>
             </a:r>
             <a:r>
               <a:rPr lang="en-US" sz="2850" dirty="0" spc="0" kern="0">
@@ -13206,18 +13085,7 @@
                 <a:ea typeface="Be Vietnam Pro" pitchFamily="34" charset="-122"/>
                 <a:cs typeface="Be Vietnam Pro" pitchFamily="34" charset="-120"/>
               </a:rPr>
-              <a:t> Thập niên</a:t>
-            </a:r>
-            <a:r>
-              <a:rPr lang="en-US" sz="2850" dirty="0" spc="2" kern="0">
-                <a:solidFill>
-                  <a:srgbClr val="14161C"/>
-                </a:solidFill>
-                <a:latin typeface="Be Vietnam Pro" pitchFamily="34" charset="0"/>
-                <a:ea typeface="Be Vietnam Pro" pitchFamily="34" charset="-122"/>
-                <a:cs typeface="Be Vietnam Pro" pitchFamily="34" charset="-120"/>
-              </a:rPr>
-              <a:t> 2010</a:t>
+              <a:t> án</a:t>
             </a:r>
             <a:r>
               <a:rPr lang="en-US" sz="2850" dirty="0" spc="-1" kern="0">
@@ -13228,7 +13096,7 @@
                 <a:ea typeface="Be Vietnam Pro" pitchFamily="34" charset="-122"/>
                 <a:cs typeface="Be Vietnam Pro" pitchFamily="34" charset="-120"/>
               </a:rPr>
-              <a:t> có</a:t>
+              <a:t> tự</a:t>
             </a:r>
             <a:r>
               <a:rPr lang="en-US" sz="2850" dirty="0" spc="0" kern="0">
@@ -13239,29 +13107,18 @@
                 <a:ea typeface="Be Vietnam Pro" pitchFamily="34" charset="-122"/>
                 <a:cs typeface="Be Vietnam Pro" pitchFamily="34" charset="-120"/>
               </a:rPr>
-              <a:t> nhiều</a:t>
-            </a:r>
-            <a:r>
-              <a:rPr lang="en-US" sz="2850" dirty="0" spc="-13" kern="0">
-                <a:solidFill>
-                  <a:srgbClr val="14161C"/>
-                </a:solidFill>
-                <a:latin typeface="Be Vietnam Pro" pitchFamily="34" charset="0"/>
-                <a:ea typeface="Be Vietnam Pro" pitchFamily="34" charset="-122"/>
-                <a:cs typeface="Be Vietnam Pro" pitchFamily="34" charset="-120"/>
-              </a:rPr>
-              <a:t> ngôn</a:t>
-            </a:r>
-            <a:r>
-              <a:rPr lang="en-US" sz="2850" dirty="0" spc="-2" kern="0">
-                <a:solidFill>
-                  <a:srgbClr val="14161C"/>
-                </a:solidFill>
-                <a:latin typeface="Be Vietnam Pro" pitchFamily="34" charset="0"/>
-                <a:ea typeface="Be Vietnam Pro" pitchFamily="34" charset="-122"/>
-                <a:cs typeface="Be Vietnam Pro" pitchFamily="34" charset="-120"/>
-              </a:rPr>
-              <a:t> ngữ</a:t>
+              <a:t> nêu</a:t>
+            </a:r>
+            <a:r>
+              <a:rPr lang="en-US" sz="2850" dirty="0" spc="-1" kern="0">
+                <a:solidFill>
+                  <a:srgbClr val="14161C"/>
+                </a:solidFill>
+                <a:latin typeface="Be Vietnam Pro" pitchFamily="34" charset="0"/>
+                <a:ea typeface="Be Vietnam Pro" pitchFamily="34" charset="-122"/>
+                <a:cs typeface="Be Vietnam Pro" pitchFamily="34" charset="-120"/>
+              </a:rPr>
+              <a:t> mục</a:t>
             </a:r>
             <a:r>
               <a:rPr lang="en-US" sz="2850" dirty="0" spc="0" kern="0">
@@ -13272,51 +13129,7 @@
                 <a:ea typeface="Be Vietnam Pro" pitchFamily="34" charset="-122"/>
                 <a:cs typeface="Be Vietnam Pro" pitchFamily="34" charset="-120"/>
               </a:rPr>
-              <a:t> mới,</a:t>
-            </a:r>
-            <a:r>
-              <a:rPr lang="en-US" sz="2850" dirty="0" spc="-10" kern="0">
-                <a:solidFill>
-                  <a:srgbClr val="14161C"/>
-                </a:solidFill>
-                <a:latin typeface="Be Vietnam Pro" pitchFamily="34" charset="0"/>
-                <a:ea typeface="Be Vietnam Pro" pitchFamily="34" charset="-122"/>
-                <a:cs typeface="Be Vietnam Pro" pitchFamily="34" charset="-120"/>
-              </a:rPr>
-              <a:t> một số</a:t>
-            </a:r>
-            <a:r>
-              <a:rPr lang="en-US" sz="2850" dirty="0" spc="-3" kern="0">
-                <a:solidFill>
-                  <a:srgbClr val="14161C"/>
-                </a:solidFill>
-                <a:latin typeface="Be Vietnam Pro" pitchFamily="34" charset="0"/>
-                <a:ea typeface="Be Vietnam Pro" pitchFamily="34" charset="-122"/>
-                <a:cs typeface="Be Vietnam Pro" pitchFamily="34" charset="-120"/>
-              </a:rPr>
-              <a:t> theo</a:t>
-            </a:r>
-            <a:r>
-              <a:rPr lang="en-US" sz="2850" dirty="0" spc="6" kern="0">
-                <a:solidFill>
-                  <a:srgbClr val="14161C"/>
-                </a:solidFill>
-                <a:latin typeface="Be Vietnam Pro" pitchFamily="34" charset="0"/>
-                <a:ea typeface="Be Vietnam Pro" pitchFamily="34" charset="-122"/>
-                <a:cs typeface="Be Vietnam Pro" pitchFamily="34" charset="-120"/>
-              </a:rPr>
-              <a:t> hướng</a:t>
-            </a:r>
-            <a:r>
-              <a:rPr lang="en-US" sz="2850" dirty="0" spc="0" kern="0">
-                <a:solidFill>
-                  <a:srgbClr val="14161C"/>
-                </a:solidFill>
-                <a:latin typeface="Be Vietnam Pro" pitchFamily="34" charset="0"/>
-                <a:ea typeface="Be Vietnam Pro" pitchFamily="34" charset="-122"/>
-                <a:cs typeface="Be Vietnam Pro" pitchFamily="34" charset="-120"/>
-              </a:rPr>
-              <a:t> khác.</a:t>
+              <a:t> tiêu.</a:t>
             </a:r>
             <a:endParaRPr lang="en-US" sz="2850" dirty="0"/>
           </a:p>
@@ -13721,61 +13534,6 @@
               <a:buNone/>
             </a:pPr>
             <a:r>
-              <a:rPr lang="en-US" sz="2100" dirty="0" spc="-11" kern="0">
-                <a:solidFill>
-                  <a:srgbClr val="14161C"/>
-                </a:solidFill>
-                <a:latin typeface="Be Vietnam Pro" pitchFamily="34" charset="0"/>
-                <a:ea typeface="Be Vietnam Pro" pitchFamily="34" charset="-122"/>
-                <a:cs typeface="Be Vietnam Pro" pitchFamily="34" charset="-120"/>
-              </a:rPr>
-              <a:t>Microsoft</a:t>
-            </a:r>
-            <a:r>
-              <a:rPr lang="en-US" sz="2100" dirty="0" spc="-12" kern="0">
-                <a:solidFill>
-                  <a:srgbClr val="14161C"/>
-                </a:solidFill>
-                <a:latin typeface="Be Vietnam Pro" pitchFamily="34" charset="0"/>
-                <a:ea typeface="Be Vietnam Pro" pitchFamily="34" charset="-122"/>
-                <a:cs typeface="Be Vietnam Pro" pitchFamily="34" charset="-120"/>
-              </a:rPr>
-              <a:t> phát</a:t>
-            </a:r>
-            <a:r>
-              <a:rPr lang="en-US" sz="2100" dirty="0" spc="-1" kern="0">
-                <a:solidFill>
-                  <a:srgbClr val="14161C"/>
-                </a:solidFill>
-                <a:latin typeface="Be Vietnam Pro" pitchFamily="34" charset="0"/>
-                <a:ea typeface="Be Vietnam Pro" pitchFamily="34" charset="-122"/>
-                <a:cs typeface="Be Vietnam Pro" pitchFamily="34" charset="-120"/>
-              </a:rPr>
-              <a:t> hành,</a:t>
-            </a:r>
-            <a:r>
-              <a:rPr lang="en-US" sz="2100" dirty="0" spc="28" kern="0">
-                <a:solidFill>
-                  <a:srgbClr val="14161C"/>
-                </a:solidFill>
-                <a:latin typeface="Be Vietnam Pro" pitchFamily="34" charset="0"/>
-                <a:ea typeface="Be Vietnam Pro" pitchFamily="34" charset="-122"/>
-                <a:cs typeface="Be Vietnam Pro" pitchFamily="34" charset="-120"/>
-              </a:rPr>
-              <a:t> đi</a:t>
-            </a:r>
-            <a:r>
-              <a:rPr lang="en-US" sz="2100" dirty="0" spc="-23" kern="0">
-                <a:solidFill>
-                  <a:srgbClr val="14161C"/>
-                </a:solidFill>
-                <a:latin typeface="Be Vietnam Pro" pitchFamily="34" charset="0"/>
-                <a:ea typeface="Be Vietnam Pro" pitchFamily="34" charset="-122"/>
-                <a:cs typeface="Be Vietnam Pro" pitchFamily="34" charset="-120"/>
-              </a:rPr>
-              <a:t> kèm</a:t>
-            </a:r>
-            <a:r>
               <a:rPr lang="en-US" sz="2100" dirty="0" spc="1" kern="0">
                 <a:solidFill>
                   <a:srgbClr val="14161C"/>
@@ -13784,40 +13542,62 @@
                 <a:ea typeface="Be Vietnam Pro" pitchFamily="34" charset="-122"/>
                 <a:cs typeface="Be Vietnam Pro" pitchFamily="34" charset="-120"/>
               </a:rPr>
-              <a:t> khung</a:t>
-            </a:r>
-            <a:r>
-              <a:rPr lang="en-US" sz="2100" dirty="0" spc="-32" kern="0">
-                <a:solidFill>
-                  <a:srgbClr val="14161C"/>
-                </a:solidFill>
-                <a:latin typeface="Be Vietnam Pro" pitchFamily="34" charset="0"/>
-                <a:ea typeface="Be Vietnam Pro" pitchFamily="34" charset="-122"/>
-                <a:cs typeface="Be Vietnam Pro" pitchFamily="34" charset="-120"/>
-              </a:rPr>
-              <a:t> .NET,</a:t>
-            </a:r>
-            <a:r>
-              <a:rPr lang="en-US" sz="2100" dirty="0" spc="-4" kern="0">
-                <a:solidFill>
-                  <a:srgbClr val="14161C"/>
-                </a:solidFill>
-                <a:latin typeface="Be Vietnam Pro" pitchFamily="34" charset="0"/>
-                <a:ea typeface="Be Vietnam Pro" pitchFamily="34" charset="-122"/>
-                <a:cs typeface="Be Vietnam Pro" pitchFamily="34" charset="-120"/>
-              </a:rPr>
-              <a:t> có</a:t>
-            </a:r>
-            <a:r>
-              <a:rPr lang="en-US" sz="2100" dirty="0" spc="1" kern="0">
-                <a:solidFill>
-                  <a:srgbClr val="14161C"/>
-                </a:solidFill>
-                <a:latin typeface="Be Vietnam Pro" pitchFamily="34" charset="0"/>
-                <a:ea typeface="Be Vietnam Pro" pitchFamily="34" charset="-122"/>
-                <a:cs typeface="Be Vietnam Pro" pitchFamily="34" charset="-120"/>
-              </a:rPr>
-              <a:t> nhiều tính</a:t>
+              <a:t>Do</a:t>
+            </a:r>
+            <a:r>
+              <a:rPr lang="en-US" sz="2100" dirty="0" spc="-8" kern="0">
+                <a:solidFill>
+                  <a:srgbClr val="14161C"/>
+                </a:solidFill>
+                <a:latin typeface="Be Vietnam Pro" pitchFamily="34" charset="0"/>
+                <a:ea typeface="Be Vietnam Pro" pitchFamily="34" charset="-122"/>
+                <a:cs typeface="Be Vietnam Pro" pitchFamily="34" charset="-120"/>
+              </a:rPr>
+              <a:t> một</a:t>
+            </a:r>
+            <a:r>
+              <a:rPr lang="en-US" sz="2100" dirty="0" spc="-2" kern="0">
+                <a:solidFill>
+                  <a:srgbClr val="14161C"/>
+                </a:solidFill>
+                <a:latin typeface="Be Vietnam Pro" pitchFamily="34" charset="0"/>
+                <a:ea typeface="Be Vietnam Pro" pitchFamily="34" charset="-122"/>
+                <a:cs typeface="Be Vietnam Pro" pitchFamily="34" charset="-120"/>
+              </a:rPr>
+              <a:t> nhóm</a:t>
+            </a:r>
+            <a:r>
+              <a:rPr lang="en-US" sz="2100" dirty="0" spc="-3" kern="0">
+                <a:solidFill>
+                  <a:srgbClr val="14161C"/>
+                </a:solidFill>
+                <a:latin typeface="Be Vietnam Pro" pitchFamily="34" charset="0"/>
+                <a:ea typeface="Be Vietnam Pro" pitchFamily="34" charset="-122"/>
+                <a:cs typeface="Be Vietnam Pro" pitchFamily="34" charset="-120"/>
+              </a:rPr>
+              <a:t> thiết</a:t>
+            </a:r>
+            <a:r>
+              <a:rPr lang="en-US" sz="2100" dirty="0" spc="-31" kern="0">
+                <a:solidFill>
+                  <a:srgbClr val="14161C"/>
+                </a:solidFill>
+                <a:latin typeface="Be Vietnam Pro" pitchFamily="34" charset="0"/>
+                <a:ea typeface="Be Vietnam Pro" pitchFamily="34" charset="-122"/>
+                <a:cs typeface="Be Vietnam Pro" pitchFamily="34" charset="-120"/>
+              </a:rPr>
+              <a:t> kế</a:t>
+            </a:r>
+            <a:r>
+              <a:rPr lang="en-US" sz="2100" dirty="0" spc="-9" kern="0">
+                <a:solidFill>
+                  <a:srgbClr val="14161C"/>
+                </a:solidFill>
+                <a:latin typeface="Be Vietnam Pro" pitchFamily="34" charset="0"/>
+                <a:ea typeface="Be Vietnam Pro" pitchFamily="34" charset="-122"/>
+                <a:cs typeface="Be Vietnam Pro" pitchFamily="34" charset="-120"/>
+              </a:rPr>
+              <a:t> ngôn</a:t>
             </a:r>
             <a:r>
               <a:rPr lang="en-US" sz="2100" dirty="0" spc="0" kern="0">
@@ -13828,18 +13608,7 @@
                 <a:ea typeface="Be Vietnam Pro" pitchFamily="34" charset="-122"/>
                 <a:cs typeface="Be Vietnam Pro" pitchFamily="34" charset="-120"/>
               </a:rPr>
-              <a:t> năng</a:t>
-            </a:r>
-            <a:r>
-              <a:rPr lang="en-US" sz="2100" dirty="0" spc="-1" kern="0">
-                <a:solidFill>
-                  <a:srgbClr val="14161C"/>
-                </a:solidFill>
-                <a:latin typeface="Be Vietnam Pro" pitchFamily="34" charset="0"/>
-                <a:ea typeface="Be Vietnam Pro" pitchFamily="34" charset="-122"/>
-                <a:cs typeface="Be Vietnam Pro" pitchFamily="34" charset="-120"/>
-              </a:rPr>
-              <a:t> nâng</a:t>
+              <a:t> ngữ,</a:t>
             </a:r>
             <a:r>
               <a:rPr lang="en-US" sz="2100" dirty="0" spc="-2" kern="0">
@@ -13850,7 +13619,40 @@
                 <a:ea typeface="Be Vietnam Pro" pitchFamily="34" charset="-122"/>
                 <a:cs typeface="Be Vietnam Pro" pitchFamily="34" charset="-120"/>
               </a:rPr>
-              <a:t> cao</a:t>
+              <a:t> làm việc</a:t>
+            </a:r>
+            <a:r>
+              <a:rPr lang="en-US" sz="2100" dirty="0" spc="-17" kern="0">
+                <a:solidFill>
+                  <a:srgbClr val="14161C"/>
+                </a:solidFill>
+                <a:latin typeface="Be Vietnam Pro" pitchFamily="34" charset="0"/>
+                <a:ea typeface="Be Vietnam Pro" pitchFamily="34" charset="-122"/>
+                <a:cs typeface="Be Vietnam Pro" pitchFamily="34" charset="-120"/>
+              </a:rPr>
+              <a:t> sát</a:t>
+            </a:r>
+            <a:r>
+              <a:rPr lang="en-US" sz="2100" dirty="0" spc="-13" kern="0">
+                <a:solidFill>
+                  <a:srgbClr val="14161C"/>
+                </a:solidFill>
+                <a:latin typeface="Be Vietnam Pro" pitchFamily="34" charset="0"/>
+                <a:ea typeface="Be Vietnam Pro" pitchFamily="34" charset="-122"/>
+                <a:cs typeface="Be Vietnam Pro" pitchFamily="34" charset="-120"/>
+              </a:rPr>
+              <a:t> với</a:t>
+            </a:r>
+            <a:r>
+              <a:rPr lang="en-US" sz="2100" dirty="0" spc="-15" kern="0">
+                <a:solidFill>
+                  <a:srgbClr val="14161C"/>
+                </a:solidFill>
+                <a:latin typeface="Be Vietnam Pro" pitchFamily="34" charset="0"/>
+                <a:ea typeface="Be Vietnam Pro" pitchFamily="34" charset="-122"/>
+                <a:cs typeface="Be Vietnam Pro" pitchFamily="34" charset="-120"/>
+              </a:rPr>
+              <a:t> Roslyn</a:t>
             </a:r>
             <a:endParaRPr lang="en-US" sz="2100" dirty="0"/>
           </a:p>
@@ -13972,10 +13774,10 @@
                 <a:ea typeface="Be Vietnam Pro" pitchFamily="34" charset="-122"/>
                 <a:cs typeface="Be Vietnam Pro" pitchFamily="34" charset="-120"/>
               </a:rPr>
-              <a:t>HỌ</a:t>
-            </a:r>
-            <a:r>
-              <a:rPr lang="en-US" sz="1650" b="1" spc="151" kern="0" dirty="0">
+              <a:t>TỰ</a:t>
+            </a:r>
+            <a:r>
+              <a:rPr lang="en-US" sz="1650" b="1" spc="153" kern="0" dirty="0">
                 <a:solidFill>
                   <a:srgbClr val="0F766E"/>
                 </a:solidFill>
@@ -13983,10 +13785,10 @@
                 <a:ea typeface="Be Vietnam Pro" pitchFamily="34" charset="-122"/>
                 <a:cs typeface="Be Vietnam Pro" pitchFamily="34" charset="-120"/>
               </a:rPr>
-              <a:t> C++</a:t>
-            </a:r>
-            <a:r>
-              <a:rPr lang="en-US" sz="1650" b="1" spc="145" kern="0" dirty="0">
+              <a:t> NÊU MỤC</a:t>
+            </a:r>
+            <a:r>
+              <a:rPr lang="en-US" sz="1650" b="1" spc="152" kern="0" dirty="0">
                 <a:solidFill>
                   <a:srgbClr val="0F766E"/>
                 </a:solidFill>
@@ -13994,18 +13796,7 @@
                 <a:ea typeface="Be Vietnam Pro" pitchFamily="34" charset="-122"/>
                 <a:cs typeface="Be Vietnam Pro" pitchFamily="34" charset="-120"/>
               </a:rPr>
-              <a:t> THEO</a:t>
-            </a:r>
-            <a:r>
-              <a:rPr lang="en-US" sz="1650" b="1" spc="152" kern="0" dirty="0">
-                <a:solidFill>
-                  <a:srgbClr val="0F766E"/>
-                </a:solidFill>
-                <a:latin typeface="Be Vietnam Pro" pitchFamily="34" charset="0"/>
-                <a:ea typeface="Be Vietnam Pro" pitchFamily="34" charset="-122"/>
-                <a:cs typeface="Be Vietnam Pro" pitchFamily="34" charset="-120"/>
-              </a:rPr>
-              <a:t> NGUỒN</a:t>
+              <a:t> TIÊU</a:t>
             </a:r>
             <a:endParaRPr lang="en-US" sz="1650" dirty="0"/>
           </a:p>
@@ -14058,7 +13849,7 @@
               <a:buNone/>
             </a:pPr>
             <a:r>
-              <a:rPr lang="en-US" sz="1650" b="1" spc="150" kern="0" dirty="0">
+              <a:rPr lang="en-US" sz="1650" b="1" spc="149" kern="0" dirty="0">
                 <a:solidFill>
                   <a:srgbClr val="0F766E"/>
                 </a:solidFill>
@@ -14066,10 +13857,10 @@
                 <a:ea typeface="Be Vietnam Pro" pitchFamily="34" charset="-122"/>
                 <a:cs typeface="Be Vietnam Pro" pitchFamily="34" charset="-120"/>
               </a:rPr>
-              <a:t>HỌ</a:t>
-            </a:r>
-            <a:r>
-              <a:rPr lang="en-US" sz="1650" b="1" spc="87" kern="0" dirty="0">
+              <a:t>KẾ</a:t>
+            </a:r>
+            <a:r>
+              <a:rPr lang="en-US" sz="1650" b="1" spc="151" kern="0" dirty="0">
                 <a:solidFill>
                   <a:srgbClr val="0F766E"/>
                 </a:solidFill>
@@ -14077,10 +13868,10 @@
                 <a:ea typeface="Be Vietnam Pro" pitchFamily="34" charset="-122"/>
                 <a:cs typeface="Be Vietnam Pro" pitchFamily="34" charset="-120"/>
               </a:rPr>
-              <a:t> JAVA</a:t>
-            </a:r>
-            <a:r>
-              <a:rPr lang="en-US" sz="1650" b="1" spc="145" kern="0" dirty="0">
+              <a:t> NHIỆM</a:t>
+            </a:r>
+            <a:r>
+              <a:rPr lang="en-US" sz="1650" b="1" spc="152" kern="0" dirty="0">
                 <a:solidFill>
                   <a:srgbClr val="0F766E"/>
                 </a:solidFill>
@@ -14088,18 +13879,7 @@
                 <a:ea typeface="Be Vietnam Pro" pitchFamily="34" charset="-122"/>
                 <a:cs typeface="Be Vietnam Pro" pitchFamily="34" charset="-120"/>
               </a:rPr>
-              <a:t> THEO</a:t>
-            </a:r>
-            <a:r>
-              <a:rPr lang="en-US" sz="1650" b="1" spc="152" kern="0" dirty="0">
-                <a:solidFill>
-                  <a:srgbClr val="0F766E"/>
-                </a:solidFill>
-                <a:latin typeface="Be Vietnam Pro" pitchFamily="34" charset="0"/>
-                <a:ea typeface="Be Vietnam Pro" pitchFamily="34" charset="-122"/>
-                <a:cs typeface="Be Vietnam Pro" pitchFamily="34" charset="-120"/>
-              </a:rPr>
-              <a:t> NGUỒN</a:t>
+              <a:t> C++</a:t>
             </a:r>
             <a:endParaRPr lang="en-US" sz="1650" dirty="0"/>
           </a:p>
@@ -14130,7 +13910,7 @@
               <a:buNone/>
             </a:pPr>
             <a:r>
-              <a:rPr lang="en-US" sz="1800" b="1" spc="227" kern="0" dirty="0">
+              <a:rPr lang="en-US" sz="1800" b="1" spc="226" kern="0" dirty="0">
                 <a:solidFill>
                   <a:srgbClr val="0F766E"/>
                 </a:solidFill>
@@ -14138,10 +13918,10 @@
                 <a:ea typeface="Be Vietnam Pro" pitchFamily="34" charset="-122"/>
                 <a:cs typeface="Be Vietnam Pro" pitchFamily="34" charset="-120"/>
               </a:rPr>
-              <a:t>HƯỚNG</a:t>
-            </a:r>
-            <a:r>
-              <a:rPr lang="en-US" sz="1800" b="1" spc="214" kern="0" dirty="0">
+              <a:t>DỰA</a:t>
+            </a:r>
+            <a:r>
+              <a:rPr lang="en-US" sz="1800" b="1" spc="223" kern="0" dirty="0">
                 <a:solidFill>
                   <a:srgbClr val="0F766E"/>
                 </a:solidFill>
@@ -14149,7 +13929,40 @@
                 <a:ea typeface="Be Vietnam Pro" pitchFamily="34" charset="-122"/>
                 <a:cs typeface="Be Vietnam Pro" pitchFamily="34" charset="-120"/>
               </a:rPr>
-              <a:t> KHÁC</a:t>
+              <a:t> TRÊN</a:t>
+            </a:r>
+            <a:r>
+              <a:rPr lang="en-US" sz="1800" b="1" spc="225" kern="0" dirty="0">
+                <a:solidFill>
+                  <a:srgbClr val="0F766E"/>
+                </a:solidFill>
+                <a:latin typeface="Be Vietnam Pro" pitchFamily="34" charset="0"/>
+                <a:ea typeface="Be Vietnam Pro" pitchFamily="34" charset="-122"/>
+                <a:cs typeface="Be Vietnam Pro" pitchFamily="34" charset="-120"/>
+              </a:rPr>
+              <a:t> NGÔN NGỮ</a:t>
+            </a:r>
+            <a:r>
+              <a:rPr lang="en-US" sz="1800" b="1" spc="228" kern="0" dirty="0">
+                <a:solidFill>
+                  <a:srgbClr val="0F766E"/>
+                </a:solidFill>
+                <a:latin typeface="Be Vietnam Pro" pitchFamily="34" charset="0"/>
+                <a:ea typeface="Be Vietnam Pro" pitchFamily="34" charset="-122"/>
+                <a:cs typeface="Be Vietnam Pro" pitchFamily="34" charset="-120"/>
+              </a:rPr>
+              <a:t> CÓ</a:t>
+            </a:r>
+            <a:r>
+              <a:rPr lang="en-US" sz="1800" b="1" spc="212" kern="0" dirty="0">
+                <a:solidFill>
+                  <a:srgbClr val="0F766E"/>
+                </a:solidFill>
+                <a:latin typeface="Be Vietnam Pro" pitchFamily="34" charset="0"/>
+                <a:ea typeface="Be Vietnam Pro" pitchFamily="34" charset="-122"/>
+                <a:cs typeface="Be Vietnam Pro" pitchFamily="34" charset="-120"/>
+              </a:rPr>
+              <a:t> SẴN</a:t>
             </a:r>
             <a:endParaRPr lang="en-US" sz="1800" dirty="0"/>
           </a:p>
@@ -14244,6 +14057,39 @@
               <a:buNone/>
             </a:pPr>
             <a:r>
+              <a:rPr lang="en-US" sz="1800" dirty="0" spc="-3" kern="0">
+                <a:solidFill>
+                  <a:srgbClr val="6B6A66"/>
+                </a:solidFill>
+                <a:latin typeface="Be Vietnam Pro" pitchFamily="34" charset="0"/>
+                <a:ea typeface="Be Vietnam Pro" pitchFamily="34" charset="-122"/>
+                <a:cs typeface="Be Vietnam Pro" pitchFamily="34" charset="-120"/>
+              </a:rPr>
+              <a:t>kiểu</a:t>
+            </a:r>
+            <a:r>
+              <a:rPr lang="en-US" sz="1800" dirty="0" spc="-2" kern="0">
+                <a:solidFill>
+                  <a:srgbClr val="6B6A66"/>
+                </a:solidFill>
+                <a:latin typeface="Be Vietnam Pro" pitchFamily="34" charset="0"/>
+                <a:ea typeface="Be Vietnam Pro" pitchFamily="34" charset="-122"/>
+                <a:cs typeface="Be Vietnam Pro" pitchFamily="34" charset="-120"/>
+              </a:rPr>
+              <a:t> mạnh,</a:t>
+            </a:r>
+            <a:r>
+              <a:rPr lang="en-US" sz="1800" dirty="0" spc="-20" kern="0">
+                <a:solidFill>
+                  <a:srgbClr val="6B6A66"/>
+                </a:solidFill>
+                <a:latin typeface="Be Vietnam Pro" pitchFamily="34" charset="0"/>
+                <a:ea typeface="Be Vietnam Pro" pitchFamily="34" charset="-122"/>
+                <a:cs typeface="Be Vietnam Pro" pitchFamily="34" charset="-120"/>
+              </a:rPr>
+              <a:t> ra</a:t>
+            </a:r>
+            <a:r>
               <a:rPr lang="en-US" sz="1800" dirty="0" spc="-1" kern="0">
                 <a:solidFill>
                   <a:srgbClr val="6B6A66"/>
@@ -14252,10 +14098,10 @@
                 <a:ea typeface="Be Vietnam Pro" pitchFamily="34" charset="-122"/>
                 <a:cs typeface="Be Vietnam Pro" pitchFamily="34" charset="-120"/>
               </a:rPr>
-              <a:t>phổ</a:t>
-            </a:r>
-            <a:r>
-              <a:rPr lang="en-US" sz="1800" dirty="0" spc="-2" kern="0">
+              <a:t> mã</a:t>
+            </a:r>
+            <a:r>
+              <a:rPr lang="en-US" sz="1800" dirty="0" spc="-8" kern="0">
                 <a:solidFill>
                   <a:srgbClr val="6B6A66"/>
                 </a:solidFill>
@@ -14263,10 +14109,10 @@
                 <a:ea typeface="Be Vietnam Pro" pitchFamily="34" charset="-122"/>
                 <a:cs typeface="Be Vietnam Pro" pitchFamily="34" charset="-120"/>
               </a:rPr>
-              <a:t> biến nhờ</a:t>
-            </a:r>
-            <a:r>
-              <a:rPr lang="en-US" sz="1800" dirty="0" spc="-7" kern="0">
+              <a:t> máy</a:t>
+            </a:r>
+            <a:r>
+              <a:rPr lang="en-US" sz="1800" dirty="0" spc="0" kern="0">
                 <a:solidFill>
                   <a:srgbClr val="6B6A66"/>
                 </a:solidFill>
@@ -14274,7 +14120,18 @@
                 <a:ea typeface="Be Vietnam Pro" pitchFamily="34" charset="-122"/>
                 <a:cs typeface="Be Vietnam Pro" pitchFamily="34" charset="-120"/>
               </a:rPr>
-              <a:t> Flutter</a:t>
+              <a:t> hoặc</a:t>
+            </a:r>
+            <a:r>
+              <a:rPr lang="en-US" sz="1800" dirty="0" spc="-3" kern="0">
+                <a:solidFill>
+                  <a:srgbClr val="6B6A66"/>
+                </a:solidFill>
+                <a:latin typeface="Be Vietnam Pro" pitchFamily="34" charset="0"/>
+                <a:ea typeface="Be Vietnam Pro" pitchFamily="34" charset="-122"/>
+                <a:cs typeface="Be Vietnam Pro" pitchFamily="34" charset="-120"/>
+              </a:rPr>
+              <a:t> JavaScript</a:t>
             </a:r>
             <a:endParaRPr lang="en-US" sz="1800" dirty="0"/>
           </a:p>
@@ -14369,7 +14226,7 @@
               <a:buNone/>
             </a:pPr>
             <a:r>
-              <a:rPr lang="en-US" sz="1800" dirty="0" spc="3" kern="0">
+              <a:rPr lang="en-US" sz="1800" dirty="0" spc="-4" kern="0">
                 <a:solidFill>
                   <a:srgbClr val="6B6A66"/>
                 </a:solidFill>
@@ -14377,7 +14234,7 @@
                 <a:ea typeface="Be Vietnam Pro" pitchFamily="34" charset="-122"/>
                 <a:cs typeface="Be Vietnam Pro" pitchFamily="34" charset="-120"/>
               </a:rPr>
-              <a:t>tương</a:t>
+              <a:t>thêm</a:t>
             </a:r>
             <a:r>
               <a:rPr lang="en-US" sz="1800" dirty="0" spc="-1" kern="0">
@@ -14388,10 +14245,10 @@
                 <a:ea typeface="Be Vietnam Pro" pitchFamily="34" charset="-122"/>
                 <a:cs typeface="Be Vietnam Pro" pitchFamily="34" charset="-120"/>
               </a:rPr>
-              <a:t> thích hoàn</a:t>
-            </a:r>
-            <a:r>
-              <a:rPr lang="en-US" sz="1800" dirty="0" spc="-10" kern="0">
+              <a:t> kiểu tùy chọn</a:t>
+            </a:r>
+            <a:r>
+              <a:rPr lang="en-US" sz="1800" dirty="0" spc="-7" kern="0">
                 <a:solidFill>
                   <a:srgbClr val="6B6A66"/>
                 </a:solidFill>
@@ -14399,18 +14256,7 @@
                 <a:ea typeface="Be Vietnam Pro" pitchFamily="34" charset="-122"/>
                 <a:cs typeface="Be Vietnam Pro" pitchFamily="34" charset="-120"/>
               </a:rPr>
-              <a:t> toàn</a:t>
-            </a:r>
-            <a:r>
-              <a:rPr lang="en-US" sz="1800" dirty="0" spc="-9" kern="0">
-                <a:solidFill>
-                  <a:srgbClr val="6B6A66"/>
-                </a:solidFill>
-                <a:latin typeface="Be Vietnam Pro" pitchFamily="34" charset="0"/>
-                <a:ea typeface="Be Vietnam Pro" pitchFamily="34" charset="-122"/>
-                <a:cs typeface="Be Vietnam Pro" pitchFamily="34" charset="-120"/>
-              </a:rPr>
-              <a:t> với</a:t>
+              <a:t> vào</a:t>
             </a:r>
             <a:r>
               <a:rPr lang="en-US" sz="1800" dirty="0" spc="-3" kern="0">
@@ -14516,7 +14362,7 @@
               <a:buNone/>
             </a:pPr>
             <a:r>
-              <a:rPr lang="en-US" sz="1800" dirty="0" spc="3" kern="0">
+              <a:rPr lang="en-US" sz="1800" dirty="0" spc="0" kern="0">
                 <a:solidFill>
                   <a:srgbClr val="6B6A66"/>
                 </a:solidFill>
@@ -14524,7 +14370,62 @@
                 <a:ea typeface="Be Vietnam Pro" pitchFamily="34" charset="-122"/>
                 <a:cs typeface="Be Vietnam Pro" pitchFamily="34" charset="-120"/>
               </a:rPr>
-              <a:t>của</a:t>
+              <a:t>an</a:t>
+            </a:r>
+            <a:r>
+              <a:rPr lang="en-US" sz="1800" dirty="0" spc="-10" kern="0">
+                <a:solidFill>
+                  <a:srgbClr val="6B6A66"/>
+                </a:solidFill>
+                <a:latin typeface="Be Vietnam Pro" pitchFamily="34" charset="0"/>
+                <a:ea typeface="Be Vietnam Pro" pitchFamily="34" charset="-122"/>
+                <a:cs typeface="Be Vietnam Pro" pitchFamily="34" charset="-120"/>
+              </a:rPr>
+              <a:t> toàn</a:t>
+            </a:r>
+            <a:r>
+              <a:rPr lang="en-US" sz="1800" dirty="0" spc="-3" kern="0">
+                <a:solidFill>
+                  <a:srgbClr val="6B6A66"/>
+                </a:solidFill>
+                <a:latin typeface="Be Vietnam Pro" pitchFamily="34" charset="0"/>
+                <a:ea typeface="Be Vietnam Pro" pitchFamily="34" charset="-122"/>
+                <a:cs typeface="Be Vietnam Pro" pitchFamily="34" charset="-120"/>
+              </a:rPr>
+              <a:t> bộ</a:t>
+            </a:r>
+            <a:r>
+              <a:rPr lang="en-US" sz="1800" dirty="0" spc="-2" kern="0">
+                <a:solidFill>
+                  <a:srgbClr val="6B6A66"/>
+                </a:solidFill>
+                <a:latin typeface="Be Vietnam Pro" pitchFamily="34" charset="0"/>
+                <a:ea typeface="Be Vietnam Pro" pitchFamily="34" charset="-122"/>
+                <a:cs typeface="Be Vietnam Pro" pitchFamily="34" charset="-120"/>
+              </a:rPr>
+              <a:t> nhớ, dùng</a:t>
+            </a:r>
+            <a:r>
+              <a:rPr lang="en-US" sz="1800" dirty="0" spc="7" kern="0">
+                <a:solidFill>
+                  <a:srgbClr val="6B6A66"/>
+                </a:solidFill>
+                <a:latin typeface="Be Vietnam Pro" pitchFamily="34" charset="0"/>
+                <a:ea typeface="Be Vietnam Pro" pitchFamily="34" charset="-122"/>
+                <a:cs typeface="Be Vietnam Pro" pitchFamily="34" charset="-120"/>
+              </a:rPr>
+              <a:t> được</a:t>
+            </a:r>
+            <a:r>
+              <a:rPr lang="en-US" sz="1800" dirty="0" spc="-2" kern="0">
+                <a:solidFill>
+                  <a:srgbClr val="6B6A66"/>
+                </a:solidFill>
+                <a:latin typeface="Be Vietnam Pro" pitchFamily="34" charset="0"/>
+                <a:ea typeface="Be Vietnam Pro" pitchFamily="34" charset="-122"/>
+                <a:cs typeface="Be Vietnam Pro" pitchFamily="34" charset="-120"/>
+              </a:rPr>
+              <a:t> mã</a:t>
             </a:r>
             <a:r>
               <a:rPr lang="en-US" sz="1800" dirty="0" spc="-1" kern="0">
@@ -14535,29 +14436,7 @@
                 <a:ea typeface="Be Vietnam Pro" pitchFamily="34" charset="-122"/>
                 <a:cs typeface="Be Vietnam Pro" pitchFamily="34" charset="-120"/>
               </a:rPr>
-              <a:t> Apple,</a:t>
-            </a:r>
-            <a:r>
-              <a:rPr lang="en-US" sz="1800" dirty="0" spc="-5" kern="0">
-                <a:solidFill>
-                  <a:srgbClr val="6B6A66"/>
-                </a:solidFill>
-                <a:latin typeface="Be Vietnam Pro" pitchFamily="34" charset="0"/>
-                <a:ea typeface="Be Vietnam Pro" pitchFamily="34" charset="-122"/>
-                <a:cs typeface="Be Vietnam Pro" pitchFamily="34" charset="-120"/>
-              </a:rPr>
-              <a:t> thay</a:t>
-            </a:r>
-            <a:r>
-              <a:rPr lang="en-US" sz="1800" dirty="0" spc="-10" kern="0">
-                <a:solidFill>
-                  <a:srgbClr val="6B6A66"/>
-                </a:solidFill>
-                <a:latin typeface="Be Vietnam Pro" pitchFamily="34" charset="0"/>
-                <a:ea typeface="Be Vietnam Pro" pitchFamily="34" charset="-122"/>
-                <a:cs typeface="Be Vietnam Pro" pitchFamily="34" charset="-120"/>
-              </a:rPr>
-              <a:t> Objective-C</a:t>
+              <a:t> C</a:t>
             </a:r>
             <a:endParaRPr lang="en-US" sz="1800" dirty="0"/>
           </a:p>
@@ -14929,6 +14808,17 @@
               <a:buNone/>
             </a:pPr>
             <a:r>
+              <a:rPr lang="en-US" sz="2550" b="1" dirty="0" spc="-34" kern="0">
+                <a:solidFill>
+                  <a:srgbClr val="14161C"/>
+                </a:solidFill>
+                <a:latin typeface="Be Vietnam Pro" pitchFamily="34" charset="0"/>
+                <a:ea typeface="Be Vietnam Pro" pitchFamily="34" charset="-122"/>
+                <a:cs typeface="Be Vietnam Pro" pitchFamily="34" charset="-120"/>
+              </a:rPr>
+              <a:t>Rust,</a:t>
+            </a:r>
+            <a:r>
               <a:rPr lang="en-US" sz="2550" b="1" dirty="0" spc="-1" kern="0">
                 <a:solidFill>
                   <a:srgbClr val="14161C"/>
@@ -14937,29 +14827,7 @@
                 <a:ea typeface="Be Vietnam Pro" pitchFamily="34" charset="-122"/>
                 <a:cs typeface="Be Vietnam Pro" pitchFamily="34" charset="-120"/>
               </a:rPr>
-              <a:t>D,</a:t>
-            </a:r>
-            <a:r>
-              <a:rPr lang="en-US" sz="2550" b="1" dirty="0" spc="-29" kern="0">
-                <a:solidFill>
-                  <a:srgbClr val="14161C"/>
-                </a:solidFill>
-                <a:latin typeface="Be Vietnam Pro" pitchFamily="34" charset="0"/>
-                <a:ea typeface="Be Vietnam Pro" pitchFamily="34" charset="-122"/>
-                <a:cs typeface="Be Vietnam Pro" pitchFamily="34" charset="-120"/>
-              </a:rPr>
-              <a:t> Rust,</a:t>
-            </a:r>
-            <a:r>
-              <a:rPr lang="en-US" sz="2550" b="1" dirty="0" spc="1" kern="0">
-                <a:solidFill>
-                  <a:srgbClr val="14161C"/>
-                </a:solidFill>
-                <a:latin typeface="Be Vietnam Pro" pitchFamily="34" charset="0"/>
-                <a:ea typeface="Be Vietnam Pro" pitchFamily="34" charset="-122"/>
-                <a:cs typeface="Be Vietnam Pro" pitchFamily="34" charset="-120"/>
-              </a:rPr>
-              <a:t> Zig,</a:t>
+              <a:t> Go,</a:t>
             </a:r>
             <a:endParaRPr lang="en-US" sz="2550" dirty="0"/>
           </a:p>
@@ -14968,15 +14836,15 @@
               <a:buNone/>
             </a:pPr>
             <a:r>
-              <a:rPr lang="en-US" sz="2550" b="1" dirty="0" spc="-4" kern="0">
-                <a:solidFill>
-                  <a:srgbClr val="14161C"/>
-                </a:solidFill>
-                <a:latin typeface="Be Vietnam Pro" pitchFamily="34" charset="0"/>
-                <a:ea typeface="Be Vietnam Pro" pitchFamily="34" charset="-122"/>
-                <a:cs typeface="Be Vietnam Pro" pitchFamily="34" charset="-120"/>
-              </a:rPr>
-              <a:t>Carbon</a:t>
+              <a:rPr lang="en-US" sz="2550" b="1" dirty="0" spc="-21" kern="0">
+                <a:solidFill>
+                  <a:srgbClr val="14161C"/>
+                </a:solidFill>
+                <a:latin typeface="Be Vietnam Pro" pitchFamily="34" charset="0"/>
+                <a:ea typeface="Be Vietnam Pro" pitchFamily="34" charset="-122"/>
+                <a:cs typeface="Be Vietnam Pro" pitchFamily="34" charset="-120"/>
+              </a:rPr>
+              <a:t>Kotlin</a:t>
             </a:r>
             <a:endParaRPr lang="en-US" sz="2550" dirty="0"/>
           </a:p>
@@ -15007,7 +14875,7 @@
               <a:buNone/>
             </a:pPr>
             <a:r>
-              <a:rPr lang="en-US" sz="1800" dirty="0" spc="-1" kern="0">
+              <a:rPr lang="en-US" sz="1800" dirty="0" spc="-4" kern="0">
                 <a:solidFill>
                   <a:srgbClr val="6B6A66"/>
                 </a:solidFill>
@@ -15015,10 +14883,10 @@
                 <a:ea typeface="Be Vietnam Pro" pitchFamily="34" charset="-122"/>
                 <a:cs typeface="Be Vietnam Pro" pitchFamily="34" charset="-120"/>
               </a:rPr>
-              <a:t>Carbon</a:t>
-            </a:r>
-            <a:r>
-              <a:rPr lang="en-US" sz="1800" dirty="0" spc="0" kern="0">
+              <a:t>tin</a:t>
+            </a:r>
+            <a:r>
+              <a:rPr lang="en-US" sz="1800" dirty="0" spc="-5" kern="0">
                 <a:solidFill>
                   <a:srgbClr val="6B6A66"/>
                 </a:solidFill>
@@ -15026,10 +14894,10 @@
                 <a:ea typeface="Be Vietnam Pro" pitchFamily="34" charset="-122"/>
                 <a:cs typeface="Be Vietnam Pro" pitchFamily="34" charset="-120"/>
               </a:rPr>
-              <a:t> là</a:t>
-            </a:r>
-            <a:r>
-              <a:rPr lang="en-US" sz="1800" dirty="0" spc="-1" kern="0">
+              <a:t> cậy,</a:t>
+            </a:r>
+            <a:r>
+              <a:rPr lang="en-US" sz="1800" dirty="0" spc="-2" kern="0">
                 <a:solidFill>
                   <a:srgbClr val="6B6A66"/>
                 </a:solidFill>
@@ -15037,10 +14905,10 @@
                 <a:ea typeface="Be Vietnam Pro" pitchFamily="34" charset="-122"/>
                 <a:cs typeface="Be Vietnam Pro" pitchFamily="34" charset="-120"/>
               </a:rPr>
-              <a:t> mới</a:t>
-            </a:r>
-            <a:r>
-              <a:rPr lang="en-US" sz="1800" dirty="0" spc="-9" kern="0">
+              <a:t> hiệu quả,</a:t>
+            </a:r>
+            <a:r>
+              <a:rPr lang="en-US" sz="1800" dirty="0" spc="-10" kern="0">
                 <a:solidFill>
                   <a:srgbClr val="6B6A66"/>
                 </a:solidFill>
@@ -15048,7 +14916,18 @@
                 <a:ea typeface="Be Vietnam Pro" pitchFamily="34" charset="-122"/>
                 <a:cs typeface="Be Vietnam Pro" pitchFamily="34" charset="-120"/>
               </a:rPr>
-              <a:t> nhất</a:t>
+              <a:t> ngắn</a:t>
+            </a:r>
+            <a:r>
+              <a:rPr lang="en-US" sz="1800" dirty="0" spc="-12" kern="0">
+                <a:solidFill>
+                  <a:srgbClr val="6B6A66"/>
+                </a:solidFill>
+                <a:latin typeface="Be Vietnam Pro" pitchFamily="34" charset="0"/>
+                <a:ea typeface="Be Vietnam Pro" pitchFamily="34" charset="-122"/>
+                <a:cs typeface="Be Vietnam Pro" pitchFamily="34" charset="-120"/>
+              </a:rPr>
+              <a:t> gọn</a:t>
             </a:r>
             <a:endParaRPr lang="en-US" sz="1800" dirty="0"/>
           </a:p>
@@ -15079,26 +14958,15 @@
               <a:buNone/>
             </a:pPr>
             <a:r>
-              <a:rPr lang="en-US" sz="2550" b="1" dirty="0" spc="0" kern="0">
-                <a:solidFill>
-                  <a:srgbClr val="14161C"/>
-                </a:solidFill>
-                <a:latin typeface="Be Vietnam Pro" pitchFamily="34" charset="0"/>
-                <a:ea typeface="Be Vietnam Pro" pitchFamily="34" charset="-122"/>
-                <a:cs typeface="Be Vietnam Pro" pitchFamily="34" charset="-120"/>
-              </a:rPr>
-              <a:t>Go,</a:t>
-            </a:r>
-            <a:r>
-              <a:rPr lang="en-US" sz="2550" b="1" dirty="0" spc="-18" kern="0">
-                <a:solidFill>
-                  <a:srgbClr val="14161C"/>
-                </a:solidFill>
-                <a:latin typeface="Be Vietnam Pro" pitchFamily="34" charset="0"/>
-                <a:ea typeface="Be Vietnam Pro" pitchFamily="34" charset="-122"/>
-                <a:cs typeface="Be Vietnam Pro" pitchFamily="34" charset="-120"/>
-              </a:rPr>
-              <a:t> Kotlin</a:t>
+              <a:rPr lang="en-US" sz="2550" b="1" dirty="0" spc="-4" kern="0">
+                <a:solidFill>
+                  <a:srgbClr val="14161C"/>
+                </a:solidFill>
+                <a:latin typeface="Be Vietnam Pro" pitchFamily="34" charset="0"/>
+                <a:ea typeface="Be Vietnam Pro" pitchFamily="34" charset="-122"/>
+                <a:cs typeface="Be Vietnam Pro" pitchFamily="34" charset="-120"/>
+              </a:rPr>
+              <a:t>Carbon</a:t>
             </a:r>
             <a:endParaRPr lang="en-US" sz="2550" dirty="0"/>
           </a:p>
@@ -15129,7 +14997,7 @@
               <a:buNone/>
             </a:pPr>
             <a:r>
-              <a:rPr lang="en-US" sz="1800" dirty="0" spc="2" kern="0">
+              <a:rPr lang="en-US" sz="1800" dirty="0" spc="-1" kern="0">
                 <a:solidFill>
                   <a:srgbClr val="6B6A66"/>
                 </a:solidFill>
@@ -15137,10 +15005,10 @@
                 <a:ea typeface="Be Vietnam Pro" pitchFamily="34" charset="-122"/>
                 <a:cs typeface="Be Vietnam Pro" pitchFamily="34" charset="-120"/>
               </a:rPr>
-              <a:t>cách</a:t>
-            </a:r>
-            <a:r>
-              <a:rPr lang="en-US" sz="1800" dirty="0" spc="-13" kern="0">
+              <a:t>thử</a:t>
+            </a:r>
+            <a:r>
+              <a:rPr lang="en-US" sz="1800" dirty="0" spc="-3" kern="0">
                 <a:solidFill>
                   <a:srgbClr val="6B6A66"/>
                 </a:solidFill>
@@ -15148,10 +15016,10 @@
                 <a:ea typeface="Be Vietnam Pro" pitchFamily="34" charset="-122"/>
                 <a:cs typeface="Be Vietnam Pro" pitchFamily="34" charset="-120"/>
               </a:rPr>
-              <a:t> xếp</a:t>
-            </a:r>
-            <a:r>
-              <a:rPr lang="en-US" sz="1800" dirty="0" spc="3" kern="0">
+              <a:t> nghiệm,</a:t>
+            </a:r>
+            <a:r>
+              <a:rPr lang="en-US" sz="1800" dirty="0" spc="-1" kern="0">
                 <a:solidFill>
                   <a:srgbClr val="6B6A66"/>
                 </a:solidFill>
@@ -15159,10 +15027,10 @@
                 <a:ea typeface="Be Vietnam Pro" pitchFamily="34" charset="-122"/>
                 <a:cs typeface="Be Vietnam Pro" pitchFamily="34" charset="-120"/>
               </a:rPr>
-              <a:t> của</a:t>
-            </a:r>
-            <a:r>
-              <a:rPr lang="en-US" sz="1800" dirty="0" spc="-4" kern="0">
+              <a:t> theo</a:t>
+            </a:r>
+            <a:r>
+              <a:rPr lang="en-US" sz="1800" dirty="0" spc="1" kern="0">
                 <a:solidFill>
                   <a:srgbClr val="6B6A66"/>
                 </a:solidFill>
@@ -15170,7 +15038,7 @@
                 <a:ea typeface="Be Vietnam Pro" pitchFamily="34" charset="-122"/>
                 <a:cs typeface="Be Vietnam Pro" pitchFamily="34" charset="-120"/>
               </a:rPr>
-              <a:t> nguồn</a:t>
+              <a:t> README</a:t>
             </a:r>
             <a:endParaRPr lang="en-US" sz="1800" dirty="0"/>
           </a:p>
@@ -15215,17 +15083,6 @@
               <a:t>TypeScript</a:t>
             </a:r>
             <a:r>
-              <a:rPr lang="en-US" sz="2550" dirty="0" spc="5" kern="0">
-                <a:solidFill>
-                  <a:srgbClr val="14161C"/>
-                </a:solidFill>
-                <a:latin typeface="Be Vietnam Pro" pitchFamily="34" charset="0"/>
-                <a:ea typeface="Be Vietnam Pro" pitchFamily="34" charset="-122"/>
-                <a:cs typeface="Be Vietnam Pro" pitchFamily="34" charset="-120"/>
-              </a:rPr>
-              <a:t> tương</a:t>
-            </a:r>
-            <a:r>
               <a:rPr lang="en-US" sz="2550" dirty="0" spc="1" kern="0">
                 <a:solidFill>
                   <a:srgbClr val="14161C"/>
@@ -15234,40 +15091,18 @@
                 <a:ea typeface="Be Vietnam Pro" pitchFamily="34" charset="-122"/>
                 <a:cs typeface="Be Vietnam Pro" pitchFamily="34" charset="-120"/>
               </a:rPr>
-              <a:t> thích</a:t>
-            </a:r>
-            <a:r>
-              <a:rPr lang="en-US" sz="2550" dirty="0" spc="-2" kern="0">
-                <a:solidFill>
-                  <a:srgbClr val="14161C"/>
-                </a:solidFill>
-                <a:latin typeface="Be Vietnam Pro" pitchFamily="34" charset="0"/>
-                <a:ea typeface="Be Vietnam Pro" pitchFamily="34" charset="-122"/>
-                <a:cs typeface="Be Vietnam Pro" pitchFamily="34" charset="-120"/>
-              </a:rPr>
-              <a:t> hoàn</a:t>
-            </a:r>
-            <a:r>
-              <a:rPr lang="en-US" sz="2550" dirty="0" spc="-12" kern="0">
-                <a:solidFill>
-                  <a:srgbClr val="14161C"/>
-                </a:solidFill>
-                <a:latin typeface="Be Vietnam Pro" pitchFamily="34" charset="0"/>
-                <a:ea typeface="Be Vietnam Pro" pitchFamily="34" charset="-122"/>
-                <a:cs typeface="Be Vietnam Pro" pitchFamily="34" charset="-120"/>
-              </a:rPr>
-              <a:t> toàn</a:t>
-            </a:r>
-            <a:r>
-              <a:rPr lang="en-US" sz="2550" dirty="0" spc="-15" kern="0">
-                <a:solidFill>
-                  <a:srgbClr val="14161C"/>
-                </a:solidFill>
-                <a:latin typeface="Be Vietnam Pro" pitchFamily="34" charset="0"/>
-                <a:ea typeface="Be Vietnam Pro" pitchFamily="34" charset="-122"/>
-                <a:cs typeface="Be Vietnam Pro" pitchFamily="34" charset="-120"/>
-              </a:rPr>
-              <a:t> với</a:t>
+              <a:t> thêm kiểu</a:t>
+            </a:r>
+            <a:r>
+              <a:rPr lang="en-US" sz="2550" dirty="0" spc="-13" kern="0">
+                <a:solidFill>
+                  <a:srgbClr val="14161C"/>
+                </a:solidFill>
+                <a:latin typeface="Be Vietnam Pro" pitchFamily="34" charset="0"/>
+                <a:ea typeface="Be Vietnam Pro" pitchFamily="34" charset="-122"/>
+                <a:cs typeface="Be Vietnam Pro" pitchFamily="34" charset="-120"/>
+              </a:rPr>
+              <a:t> vào</a:t>
             </a:r>
             <a:r>
               <a:rPr lang="en-US" sz="2550" dirty="0" spc="-7" kern="0">
@@ -15292,15 +15127,48 @@
               <a:t> Swift</a:t>
             </a:r>
             <a:r>
-              <a:rPr lang="en-US" sz="2550" dirty="0" spc="-7" kern="0">
-                <a:solidFill>
-                  <a:srgbClr val="14161C"/>
-                </a:solidFill>
-                <a:latin typeface="Be Vietnam Pro" pitchFamily="34" charset="0"/>
-                <a:ea typeface="Be Vietnam Pro" pitchFamily="34" charset="-122"/>
-                <a:cs typeface="Be Vietnam Pro" pitchFamily="34" charset="-120"/>
-              </a:rPr>
-              <a:t> thay</a:t>
+              <a:rPr lang="en-US" sz="2550" dirty="0" spc="-9" kern="0">
+                <a:solidFill>
+                  <a:srgbClr val="14161C"/>
+                </a:solidFill>
+                <a:latin typeface="Be Vietnam Pro" pitchFamily="34" charset="0"/>
+                <a:ea typeface="Be Vietnam Pro" pitchFamily="34" charset="-122"/>
+                <a:cs typeface="Be Vietnam Pro" pitchFamily="34" charset="-120"/>
+              </a:rPr>
+              <a:t> lấy</a:t>
+            </a:r>
+            <a:r>
+              <a:rPr lang="en-US" sz="2550" dirty="0" spc="1" kern="0">
+                <a:solidFill>
+                  <a:srgbClr val="14161C"/>
+                </a:solidFill>
+                <a:latin typeface="Be Vietnam Pro" pitchFamily="34" charset="0"/>
+                <a:ea typeface="Be Vietnam Pro" pitchFamily="34" charset="-122"/>
+                <a:cs typeface="Be Vietnam Pro" pitchFamily="34" charset="-120"/>
+              </a:rPr>
+              <a:t> cảm</a:t>
+            </a:r>
+            <a:r>
+              <a:rPr lang="en-US" sz="2550" dirty="0" spc="19" kern="0">
+                <a:solidFill>
+                  <a:srgbClr val="14161C"/>
+                </a:solidFill>
+                <a:latin typeface="Be Vietnam Pro" pitchFamily="34" charset="0"/>
+                <a:ea typeface="Be Vietnam Pro" pitchFamily="34" charset="-122"/>
+                <a:cs typeface="Be Vietnam Pro" pitchFamily="34" charset="-120"/>
+              </a:rPr>
+              <a:t> hứng</a:t>
+            </a:r>
+            <a:r>
+              <a:rPr lang="en-US" sz="2550" dirty="0" spc="0" kern="0">
+                <a:solidFill>
+                  <a:srgbClr val="14161C"/>
+                </a:solidFill>
+                <a:latin typeface="Be Vietnam Pro" pitchFamily="34" charset="0"/>
+                <a:ea typeface="Be Vietnam Pro" pitchFamily="34" charset="-122"/>
+                <a:cs typeface="Be Vietnam Pro" pitchFamily="34" charset="-120"/>
+              </a:rPr>
+              <a:t> từ</a:t>
             </a:r>
             <a:r>
               <a:rPr lang="en-US" sz="2550" dirty="0" spc="-13" kern="0">
@@ -15496,7 +15364,7 @@
               <a:buNone/>
             </a:pPr>
             <a:r>
-              <a:rPr lang="en-US" sz="7200" dirty="0" spc="5" kern="0">
+              <a:rPr lang="en-US" sz="7200" dirty="0" spc="-2" kern="0">
                 <a:solidFill>
                   <a:srgbClr val="F3EEE3"/>
                 </a:solidFill>
@@ -15504,18 +15372,7 @@
                 <a:ea typeface="Bricolage Grotesque ExtraBold" pitchFamily="34" charset="-122"/>
                 <a:cs typeface="Bricolage Grotesque ExtraBold" pitchFamily="34" charset="-120"/>
               </a:rPr>
-              <a:t>Chỉ</a:t>
-            </a:r>
-            <a:r>
-              <a:rPr lang="en-US" sz="7200" dirty="0" spc="-12" kern="0">
-                <a:solidFill>
-                  <a:srgbClr val="F3EEE3"/>
-                </a:solidFill>
-                <a:latin typeface="Bricolage Grotesque ExtraBold" pitchFamily="34" charset="0"/>
-                <a:ea typeface="Bricolage Grotesque ExtraBold" pitchFamily="34" charset="-122"/>
-                <a:cs typeface="Bricolage Grotesque ExtraBold" pitchFamily="34" charset="-120"/>
-              </a:rPr>
-              <a:t> một</a:t>
+              <a:t>Hai</a:t>
             </a:r>
             <a:r>
               <a:rPr lang="en-US" sz="7200" dirty="0" spc="1" kern="0">
@@ -15602,7 +15459,7 @@
               <a:buNone/>
             </a:pPr>
             <a:r>
-              <a:rPr lang="en-US" sz="3300" b="1" dirty="0" spc="-11" kern="0">
+              <a:rPr lang="en-US" sz="3300" b="1" dirty="0" spc="-2" kern="0">
                 <a:solidFill>
                   <a:srgbClr val="FFB454"/>
                 </a:solidFill>
@@ -15610,10 +15467,10 @@
                 <a:ea typeface="Be Vietnam Pro" pitchFamily="34" charset="-122"/>
                 <a:cs typeface="Be Vietnam Pro" pitchFamily="34" charset="-120"/>
               </a:rPr>
-              <a:t>Mốc</a:t>
-            </a:r>
-            <a:r>
-              <a:rPr lang="en-US" sz="3300" b="1" dirty="0" spc="-1" kern="0">
+              <a:t>Python</a:t>
+            </a:r>
+            <a:r>
+              <a:rPr lang="en-US" sz="3300" b="1" dirty="0" spc="-30" kern="0">
                 <a:solidFill>
                   <a:srgbClr val="FFB454"/>
                 </a:solidFill>
@@ -15621,10 +15478,10 @@
                 <a:ea typeface="Be Vietnam Pro" pitchFamily="34" charset="-122"/>
                 <a:cs typeface="Be Vietnam Pro" pitchFamily="34" charset="-120"/>
               </a:rPr>
-              <a:t> Python,</a:t>
-            </a:r>
-            <a:r>
-              <a:rPr lang="en-US" sz="3300" b="1" dirty="0" spc="-11" kern="0">
+              <a:t> và</a:t>
+            </a:r>
+            <a:r>
+              <a:rPr lang="en-US" sz="3300" b="1" dirty="0" spc="-14" kern="0">
                 <a:solidFill>
                   <a:srgbClr val="FFB454"/>
                 </a:solidFill>
@@ -15632,40 +15489,7 @@
                 <a:ea typeface="Be Vietnam Pro" pitchFamily="34" charset="-122"/>
                 <a:cs typeface="Be Vietnam Pro" pitchFamily="34" charset="-120"/>
               </a:rPr>
-              <a:t> theo</a:t>
-            </a:r>
-            <a:r>
-              <a:rPr lang="en-US" sz="3300" b="1" dirty="0" spc="-6" kern="0">
-                <a:solidFill>
-                  <a:srgbClr val="FFB454"/>
-                </a:solidFill>
-                <a:latin typeface="Be Vietnam Pro" pitchFamily="34" charset="0"/>
-                <a:ea typeface="Be Vietnam Pro" pitchFamily="34" charset="-122"/>
-                <a:cs typeface="Be Vietnam Pro" pitchFamily="34" charset="-120"/>
-              </a:rPr>
-              <a:t> tài</a:t>
-            </a:r>
-            <a:r>
-              <a:rPr lang="en-US" sz="3300" b="1" dirty="0" spc="1" kern="0">
-                <a:solidFill>
-                  <a:srgbClr val="FFB454"/>
-                </a:solidFill>
-                <a:latin typeface="Be Vietnam Pro" pitchFamily="34" charset="0"/>
-                <a:ea typeface="Be Vietnam Pro" pitchFamily="34" charset="-122"/>
-                <a:cs typeface="Be Vietnam Pro" pitchFamily="34" charset="-120"/>
-              </a:rPr>
-              <a:t> liệu</a:t>
-            </a:r>
-            <a:r>
-              <a:rPr lang="en-US" sz="3300" b="1" dirty="0" spc="-2" kern="0">
-                <a:solidFill>
-                  <a:srgbClr val="FFB454"/>
-                </a:solidFill>
-                <a:latin typeface="Be Vietnam Pro" pitchFamily="34" charset="0"/>
-                <a:ea typeface="Be Vietnam Pro" pitchFamily="34" charset="-122"/>
-                <a:cs typeface="Be Vietnam Pro" pitchFamily="34" charset="-120"/>
-              </a:rPr>
-              <a:t> Python</a:t>
+              <a:t> JavaScript</a:t>
             </a:r>
             <a:endParaRPr lang="en-US" sz="3300" dirty="0"/>
           </a:p>
@@ -15908,7 +15732,7 @@
               <a:t> trừ</a:t>
             </a:r>
             <a:r>
-              <a:rPr lang="en-US" sz="2850" dirty="0" spc="-12" kern="0">
+              <a:rPr lang="en-US" sz="2850" dirty="0" spc="-11" kern="0">
                 <a:solidFill>
                   <a:srgbClr val="C4C8D6"/>
                 </a:solidFill>
@@ -15916,29 +15740,7 @@
                 <a:ea typeface="Be Vietnam Pro" pitchFamily="34" charset="-122"/>
                 <a:cs typeface="Be Vietnam Pro" pitchFamily="34" charset="-120"/>
               </a:rPr>
-              <a:t> Microsoft</a:t>
-            </a:r>
-            <a:r>
-              <a:rPr lang="en-US" sz="2850" dirty="0" spc="-17" kern="0">
-                <a:solidFill>
-                  <a:srgbClr val="C4C8D6"/>
-                </a:solidFill>
-                <a:latin typeface="Be Vietnam Pro" pitchFamily="34" charset="0"/>
-                <a:ea typeface="Be Vietnam Pro" pitchFamily="34" charset="-122"/>
-                <a:cs typeface="Be Vietnam Pro" pitchFamily="34" charset="-120"/>
-              </a:rPr>
-              <a:t> và</a:t>
-            </a:r>
-            <a:r>
-              <a:rPr lang="en-US" sz="2850" dirty="0" spc="-1" kern="0">
-                <a:solidFill>
-                  <a:srgbClr val="C4C8D6"/>
-                </a:solidFill>
-                <a:latin typeface="Be Vietnam Pro" pitchFamily="34" charset="0"/>
-                <a:ea typeface="Be Vietnam Pro" pitchFamily="34" charset="-122"/>
-                <a:cs typeface="Be Vietnam Pro" pitchFamily="34" charset="-120"/>
-              </a:rPr>
-              <a:t> Apple.</a:t>
+              <a:t> Microsoft.</a:t>
             </a:r>
             <a:endParaRPr lang="en-US" sz="2850" dirty="0"/>
           </a:p>
@@ -17372,7 +17174,7 @@
               <a:buNone/>
             </a:pPr>
             <a:r>
-              <a:rPr lang="en-US" sz="2550" b="1" dirty="0" spc="2" kern="0">
+              <a:rPr lang="en-US" sz="2550" b="1" dirty="0" spc="-4" kern="0">
                 <a:solidFill>
                   <a:srgbClr val="F3EEE3"/>
                 </a:solidFill>
@@ -17380,7 +17182,51 @@
                 <a:ea typeface="Be Vietnam Pro" pitchFamily="34" charset="-122"/>
                 <a:cs typeface="Be Vietnam Pro" pitchFamily="34" charset="-120"/>
               </a:rPr>
-              <a:t>Go</a:t>
+              <a:t>Họ</a:t>
+            </a:r>
+            <a:r>
+              <a:rPr lang="en-US" sz="2550" b="1" dirty="0" spc="0" kern="0">
+                <a:solidFill>
+                  <a:srgbClr val="F3EEE3"/>
+                </a:solidFill>
+                <a:latin typeface="Be Vietnam Pro" pitchFamily="34" charset="0"/>
+                <a:ea typeface="Be Vietnam Pro" pitchFamily="34" charset="-122"/>
+                <a:cs typeface="Be Vietnam Pro" pitchFamily="34" charset="-120"/>
+              </a:rPr>
+              <a:t> C++</a:t>
+            </a:r>
+            <a:r>
+              <a:rPr lang="en-US" sz="2550" b="1" dirty="0" spc="-21" kern="0">
+                <a:solidFill>
+                  <a:srgbClr val="F3EEE3"/>
+                </a:solidFill>
+                <a:latin typeface="Be Vietnam Pro" pitchFamily="34" charset="0"/>
+                <a:ea typeface="Be Vietnam Pro" pitchFamily="34" charset="-122"/>
+                <a:cs typeface="Be Vietnam Pro" pitchFamily="34" charset="-120"/>
+              </a:rPr>
+              <a:t> và</a:t>
+            </a:r>
+            <a:r>
+              <a:rPr lang="en-US" sz="2550" b="1" dirty="0" spc="-4" kern="0">
+                <a:solidFill>
+                  <a:srgbClr val="F3EEE3"/>
+                </a:solidFill>
+                <a:latin typeface="Be Vietnam Pro" pitchFamily="34" charset="0"/>
+                <a:ea typeface="Be Vietnam Pro" pitchFamily="34" charset="-122"/>
+                <a:cs typeface="Be Vietnam Pro" pitchFamily="34" charset="-120"/>
+              </a:rPr>
+              <a:t> họ</a:t>
+            </a:r>
+            <a:r>
+              <a:rPr lang="en-US" sz="2550" b="1" dirty="0" spc="-22" kern="0">
+                <a:solidFill>
+                  <a:srgbClr val="F3EEE3"/>
+                </a:solidFill>
+                <a:latin typeface="Be Vietnam Pro" pitchFamily="34" charset="0"/>
+                <a:ea typeface="Be Vietnam Pro" pitchFamily="34" charset="-122"/>
+                <a:cs typeface="Be Vietnam Pro" pitchFamily="34" charset="-120"/>
+              </a:rPr>
+              <a:t> Java</a:t>
             </a:r>
             <a:endParaRPr lang="en-US" sz="2550" dirty="0"/>
           </a:p>
@@ -17411,6 +17257,39 @@
               <a:buNone/>
             </a:pPr>
             <a:r>
+              <a:rPr lang="en-US" sz="1950" dirty="0" spc="-4" kern="0">
+                <a:solidFill>
+                  <a:srgbClr val="C4C8D6"/>
+                </a:solidFill>
+                <a:latin typeface="Be Vietnam Pro" pitchFamily="34" charset="0"/>
+                <a:ea typeface="Be Vietnam Pro" pitchFamily="34" charset="-122"/>
+                <a:cs typeface="Be Vietnam Pro" pitchFamily="34" charset="-120"/>
+              </a:rPr>
+              <a:t>bài</a:t>
+            </a:r>
+            <a:r>
+              <a:rPr lang="en-US" sz="1950" dirty="0" spc="0" kern="0">
+                <a:solidFill>
+                  <a:srgbClr val="C4C8D6"/>
+                </a:solidFill>
+                <a:latin typeface="Be Vietnam Pro" pitchFamily="34" charset="0"/>
+                <a:ea typeface="Be Vietnam Pro" pitchFamily="34" charset="-122"/>
+                <a:cs typeface="Be Vietnam Pro" pitchFamily="34" charset="-120"/>
+              </a:rPr>
+              <a:t> không</a:t>
+            </a:r>
+            <a:r>
+              <a:rPr lang="en-US" sz="1950" dirty="0" spc="1" kern="0">
+                <a:solidFill>
+                  <a:srgbClr val="C4C8D6"/>
+                </a:solidFill>
+                <a:latin typeface="Be Vietnam Pro" pitchFamily="34" charset="0"/>
+                <a:ea typeface="Be Vietnam Pro" pitchFamily="34" charset="-122"/>
+                <a:cs typeface="Be Vietnam Pro" pitchFamily="34" charset="-120"/>
+              </a:rPr>
+              <a:t> dùng</a:t>
+            </a:r>
+            <a:r>
               <a:rPr lang="en-US" sz="1950" dirty="0" spc="-3" kern="0">
                 <a:solidFill>
                   <a:srgbClr val="C4C8D6"/>
@@ -17419,10 +17298,10 @@
                 <a:ea typeface="Be Vietnam Pro" pitchFamily="34" charset="-122"/>
                 <a:cs typeface="Be Vietnam Pro" pitchFamily="34" charset="-120"/>
               </a:rPr>
-              <a:t>“họ</a:t>
-            </a:r>
-            <a:r>
-              <a:rPr lang="en-US" sz="1950" dirty="0" spc="-13" kern="0">
+              <a:t> cách</a:t>
+            </a:r>
+            <a:r>
+              <a:rPr lang="en-US" sz="1950" dirty="0" spc="-15" kern="0">
                 <a:solidFill>
                   <a:srgbClr val="C4C8D6"/>
                 </a:solidFill>
@@ -17430,43 +17309,10 @@
                 <a:ea typeface="Be Vietnam Pro" pitchFamily="34" charset="-122"/>
                 <a:cs typeface="Be Vietnam Pro" pitchFamily="34" charset="-120"/>
               </a:rPr>
-              <a:t> Java”</a:t>
+              <a:t> xếp</a:t>
             </a:r>
             <a:r>
               <a:rPr lang="en-US" sz="1950" dirty="0" spc="-1" kern="0">
-                <a:solidFill>
-                  <a:srgbClr val="C4C8D6"/>
-                </a:solidFill>
-                <a:latin typeface="Be Vietnam Pro" pitchFamily="34" charset="0"/>
-                <a:ea typeface="Be Vietnam Pro" pitchFamily="34" charset="-122"/>
-                <a:cs typeface="Be Vietnam Pro" pitchFamily="34" charset="-120"/>
-              </a:rPr>
-              <a:t> là</a:t>
-            </a:r>
-            <a:r>
-              <a:rPr lang="en-US" sz="1950" dirty="0" spc="-3" kern="0">
-                <a:solidFill>
-                  <a:srgbClr val="C4C8D6"/>
-                </a:solidFill>
-                <a:latin typeface="Be Vietnam Pro" pitchFamily="34" charset="0"/>
-                <a:ea typeface="Be Vietnam Pro" pitchFamily="34" charset="-122"/>
-                <a:cs typeface="Be Vietnam Pro" pitchFamily="34" charset="-120"/>
-              </a:rPr>
-              <a:t> cách</a:t>
-            </a:r>
-            <a:r>
-              <a:rPr lang="en-US" sz="1950" dirty="0" spc="-15" kern="0">
-                <a:solidFill>
-                  <a:srgbClr val="C4C8D6"/>
-                </a:solidFill>
-                <a:latin typeface="Be Vietnam Pro" pitchFamily="34" charset="0"/>
-                <a:ea typeface="Be Vietnam Pro" pitchFamily="34" charset="-122"/>
-                <a:cs typeface="Be Vietnam Pro" pitchFamily="34" charset="-120"/>
-              </a:rPr>
-              <a:t> xếp</a:t>
-            </a:r>
-            <a:r>
-              <a:rPr lang="en-US" sz="1950" dirty="0" spc="0" kern="0">
                 <a:solidFill>
                   <a:srgbClr val="C4C8D6"/>
                 </a:solidFill>
@@ -18149,17 +17995,6 @@
               <a:buNone/>
             </a:pPr>
             <a:r>
-              <a:rPr lang="en-US" sz="2550" dirty="0" spc="3" kern="0">
-                <a:solidFill>
-                  <a:srgbClr val="14161C"/>
-                </a:solidFill>
-                <a:latin typeface="Be Vietnam Pro" pitchFamily="34" charset="0"/>
-                <a:ea typeface="Be Vietnam Pro" pitchFamily="34" charset="-122"/>
-                <a:cs typeface="Be Vietnam Pro" pitchFamily="34" charset="-120"/>
-              </a:rPr>
-              <a:t>Năm</a:t>
-            </a:r>
-            <a:r>
               <a:rPr lang="en-US" sz="2550" dirty="0" spc="-4" kern="0">
                 <a:solidFill>
                   <a:srgbClr val="14161C"/>
@@ -18168,7 +18003,62 @@
                 <a:ea typeface="Be Vietnam Pro" pitchFamily="34" charset="-122"/>
                 <a:cs typeface="Be Vietnam Pro" pitchFamily="34" charset="-120"/>
               </a:rPr>
-              <a:t> 1995</a:t>
+              <a:t>Theo</a:t>
+            </a:r>
+            <a:r>
+              <a:rPr lang="en-US" sz="2550" dirty="0" spc="-1" kern="0">
+                <a:solidFill>
+                  <a:srgbClr val="14161C"/>
+                </a:solidFill>
+                <a:latin typeface="Be Vietnam Pro" pitchFamily="34" charset="0"/>
+                <a:ea typeface="Be Vietnam Pro" pitchFamily="34" charset="-122"/>
+                <a:cs typeface="Be Vietnam Pro" pitchFamily="34" charset="-120"/>
+              </a:rPr>
+              <a:t> MDN,</a:t>
+            </a:r>
+            <a:r>
+              <a:rPr lang="en-US" sz="2550" dirty="0" spc="-8" kern="0">
+                <a:solidFill>
+                  <a:srgbClr val="14161C"/>
+                </a:solidFill>
+                <a:latin typeface="Be Vietnam Pro" pitchFamily="34" charset="0"/>
+                <a:ea typeface="Be Vietnam Pro" pitchFamily="34" charset="-122"/>
+                <a:cs typeface="Be Vietnam Pro" pitchFamily="34" charset="-120"/>
+              </a:rPr>
+              <a:t> JavaScript</a:t>
+            </a:r>
+            <a:r>
+              <a:rPr lang="en-US" sz="2550" dirty="0" spc="-15" kern="0">
+                <a:solidFill>
+                  <a:srgbClr val="14161C"/>
+                </a:solidFill>
+                <a:latin typeface="Be Vietnam Pro" pitchFamily="34" charset="0"/>
+                <a:ea typeface="Be Vietnam Pro" pitchFamily="34" charset="-122"/>
+                <a:cs typeface="Be Vietnam Pro" pitchFamily="34" charset="-120"/>
+              </a:rPr>
+              <a:t> vào</a:t>
+            </a:r>
+            <a:r>
+              <a:rPr lang="en-US" sz="2550" dirty="0" spc="9" kern="0">
+                <a:solidFill>
+                  <a:srgbClr val="14161C"/>
+                </a:solidFill>
+                <a:latin typeface="Be Vietnam Pro" pitchFamily="34" charset="0"/>
+                <a:ea typeface="Be Vietnam Pro" pitchFamily="34" charset="-122"/>
+                <a:cs typeface="Be Vietnam Pro" pitchFamily="34" charset="-120"/>
+              </a:rPr>
+              <a:t> trình</a:t>
+            </a:r>
+            <a:r>
+              <a:rPr lang="en-US" sz="2550" dirty="0" spc="-17" kern="0">
+                <a:solidFill>
+                  <a:srgbClr val="14161C"/>
+                </a:solidFill>
+                <a:latin typeface="Be Vietnam Pro" pitchFamily="34" charset="0"/>
+                <a:ea typeface="Be Vietnam Pro" pitchFamily="34" charset="-122"/>
+                <a:cs typeface="Be Vietnam Pro" pitchFamily="34" charset="-120"/>
+              </a:rPr>
+              <a:t> duyệt</a:t>
             </a:r>
             <a:r>
               <a:rPr lang="en-US" sz="2550" dirty="0" spc="0" kern="0">
@@ -18179,40 +18069,18 @@
                 <a:ea typeface="Be Vietnam Pro" pitchFamily="34" charset="-122"/>
                 <a:cs typeface="Be Vietnam Pro" pitchFamily="34" charset="-120"/>
               </a:rPr>
-              <a:t> có</a:t>
-            </a:r>
-            <a:r>
-              <a:rPr lang="en-US" sz="2550" dirty="0" spc="-3" kern="0">
-                <a:solidFill>
-                  <a:srgbClr val="14161C"/>
-                </a:solidFill>
-                <a:latin typeface="Be Vietnam Pro" pitchFamily="34" charset="0"/>
-                <a:ea typeface="Be Vietnam Pro" pitchFamily="34" charset="-122"/>
-                <a:cs typeface="Be Vietnam Pro" pitchFamily="34" charset="-120"/>
-              </a:rPr>
-              <a:t> bốn</a:t>
-            </a:r>
-            <a:r>
-              <a:rPr lang="en-US" sz="2550" dirty="0" spc="-11" kern="0">
-                <a:solidFill>
-                  <a:srgbClr val="14161C"/>
-                </a:solidFill>
-                <a:latin typeface="Be Vietnam Pro" pitchFamily="34" charset="0"/>
-                <a:ea typeface="Be Vietnam Pro" pitchFamily="34" charset="-122"/>
-                <a:cs typeface="Be Vietnam Pro" pitchFamily="34" charset="-120"/>
-              </a:rPr>
-              <a:t> ngôn</a:t>
-            </a:r>
-            <a:r>
-              <a:rPr lang="en-US" sz="2550" dirty="0" spc="-1" kern="0">
-                <a:solidFill>
-                  <a:srgbClr val="14161C"/>
-                </a:solidFill>
-                <a:latin typeface="Be Vietnam Pro" pitchFamily="34" charset="0"/>
-                <a:ea typeface="Be Vietnam Pro" pitchFamily="34" charset="-122"/>
-                <a:cs typeface="Be Vietnam Pro" pitchFamily="34" charset="-120"/>
-              </a:rPr>
-              <a:t> ngữ</a:t>
+              <a:t> nào,</a:t>
+            </a:r>
+            <a:r>
+              <a:rPr lang="en-US" sz="2550" dirty="0" spc="-2" kern="0">
+                <a:solidFill>
+                  <a:srgbClr val="14161C"/>
+                </a:solidFill>
+                <a:latin typeface="Be Vietnam Pro" pitchFamily="34" charset="0"/>
+                <a:ea typeface="Be Vietnam Pro" pitchFamily="34" charset="-122"/>
+                <a:cs typeface="Be Vietnam Pro" pitchFamily="34" charset="-120"/>
+              </a:rPr>
+              <a:t> lúc</a:t>
             </a:r>
             <a:r>
               <a:rPr lang="en-US" sz="2550" dirty="0" spc="0" kern="0">
@@ -18223,51 +18091,7 @@
                 <a:ea typeface="Be Vietnam Pro" pitchFamily="34" charset="-122"/>
                 <a:cs typeface="Be Vietnam Pro" pitchFamily="34" charset="-120"/>
               </a:rPr>
-              <a:t> nào</a:t>
-            </a:r>
-            <a:r>
-              <a:rPr lang="en-US" sz="2550" dirty="0" spc="-35" kern="0">
-                <a:solidFill>
-                  <a:srgbClr val="14161C"/>
-                </a:solidFill>
-                <a:latin typeface="Be Vietnam Pro" pitchFamily="34" charset="0"/>
-                <a:ea typeface="Be Vietnam Pro" pitchFamily="34" charset="-122"/>
-                <a:cs typeface="Be Vietnam Pro" pitchFamily="34" charset="-120"/>
-              </a:rPr>
-              <a:t> ra</a:t>
-            </a:r>
-            <a:r>
-              <a:rPr lang="en-US" sz="2550" dirty="0" spc="12" kern="0">
-                <a:solidFill>
-                  <a:srgbClr val="14161C"/>
-                </a:solidFill>
-                <a:latin typeface="Be Vietnam Pro" pitchFamily="34" charset="0"/>
-                <a:ea typeface="Be Vietnam Pro" pitchFamily="34" charset="-122"/>
-                <a:cs typeface="Be Vietnam Pro" pitchFamily="34" charset="-120"/>
-              </a:rPr>
-              <a:t> đời</a:t>
-            </a:r>
-            <a:r>
-              <a:rPr lang="en-US" sz="2550" dirty="0" spc="-1" kern="0">
-                <a:solidFill>
-                  <a:srgbClr val="14161C"/>
-                </a:solidFill>
-                <a:latin typeface="Be Vietnam Pro" pitchFamily="34" charset="0"/>
-                <a:ea typeface="Be Vietnam Pro" pitchFamily="34" charset="-122"/>
-                <a:cs typeface="Be Vietnam Pro" pitchFamily="34" charset="-120"/>
-              </a:rPr>
-              <a:t> theo</a:t>
-            </a:r>
-            <a:r>
-              <a:rPr lang="en-US" sz="2550" dirty="0" spc="0" kern="0">
-                <a:solidFill>
-                  <a:srgbClr val="14161C"/>
-                </a:solidFill>
-                <a:latin typeface="Be Vietnam Pro" pitchFamily="34" charset="0"/>
-                <a:ea typeface="Be Vietnam Pro" pitchFamily="34" charset="-122"/>
-                <a:cs typeface="Be Vietnam Pro" pitchFamily="34" charset="-120"/>
-              </a:rPr>
-              <a:t> nguồn?</a:t>
+              <a:t> nào?</a:t>
             </a:r>
             <a:endParaRPr lang="en-US" sz="2550" dirty="0"/>
           </a:p>
@@ -18399,15 +18223,48 @@
               <a:t> đời</a:t>
             </a:r>
             <a:r>
-              <a:rPr lang="en-US" sz="2550" dirty="0" spc="-16" kern="0">
-                <a:solidFill>
-                  <a:srgbClr val="14161C"/>
-                </a:solidFill>
-                <a:latin typeface="Be Vietnam Pro" pitchFamily="34" charset="0"/>
-                <a:ea typeface="Be Vietnam Pro" pitchFamily="34" charset="-122"/>
-                <a:cs typeface="Be Vietnam Pro" pitchFamily="34" charset="-120"/>
-              </a:rPr>
-              <a:t> trong</a:t>
+              <a:rPr lang="en-US" sz="2550" dirty="0" spc="0" kern="0">
+                <a:solidFill>
+                  <a:srgbClr val="14161C"/>
+                </a:solidFill>
+                <a:latin typeface="Be Vietnam Pro" pitchFamily="34" charset="0"/>
+                <a:ea typeface="Be Vietnam Pro" pitchFamily="34" charset="-122"/>
+                <a:cs typeface="Be Vietnam Pro" pitchFamily="34" charset="-120"/>
+              </a:rPr>
+              <a:t> khi nào</a:t>
+            </a:r>
+            <a:r>
+              <a:rPr lang="en-US" sz="2550" dirty="0" spc="-18" kern="0">
+                <a:solidFill>
+                  <a:srgbClr val="14161C"/>
+                </a:solidFill>
+                <a:latin typeface="Be Vietnam Pro" pitchFamily="34" charset="0"/>
+                <a:ea typeface="Be Vietnam Pro" pitchFamily="34" charset="-122"/>
+                <a:cs typeface="Be Vietnam Pro" pitchFamily="34" charset="-120"/>
+              </a:rPr>
+              <a:t> và</a:t>
+            </a:r>
+            <a:r>
+              <a:rPr lang="en-US" sz="2550" dirty="0" spc="-37" kern="0">
+                <a:solidFill>
+                  <a:srgbClr val="14161C"/>
+                </a:solidFill>
+                <a:latin typeface="Be Vietnam Pro" pitchFamily="34" charset="0"/>
+                <a:ea typeface="Be Vietnam Pro" pitchFamily="34" charset="-122"/>
+                <a:cs typeface="Be Vietnam Pro" pitchFamily="34" charset="-120"/>
+              </a:rPr>
+              <a:t> kế</a:t>
+            </a:r>
+            <a:r>
+              <a:rPr lang="en-US" sz="2550" dirty="0" spc="0" kern="0">
+                <a:solidFill>
+                  <a:srgbClr val="14161C"/>
+                </a:solidFill>
+                <a:latin typeface="Be Vietnam Pro" pitchFamily="34" charset="0"/>
+                <a:ea typeface="Be Vietnam Pro" pitchFamily="34" charset="-122"/>
+                <a:cs typeface="Be Vietnam Pro" pitchFamily="34" charset="-120"/>
+              </a:rPr>
+              <a:t> nhiệm</a:t>
             </a:r>
             <a:r>
               <a:rPr lang="en-US" sz="2550" dirty="0" spc="1" kern="0">
@@ -18418,29 +18275,7 @@
                 <a:ea typeface="Be Vietnam Pro" pitchFamily="34" charset="-122"/>
                 <a:cs typeface="Be Vietnam Pro" pitchFamily="34" charset="-120"/>
               </a:rPr>
-              <a:t> thập</a:t>
-            </a:r>
-            <a:r>
-              <a:rPr lang="en-US" sz="2550" dirty="0" spc="-1" kern="0">
-                <a:solidFill>
-                  <a:srgbClr val="14161C"/>
-                </a:solidFill>
-                <a:latin typeface="Be Vietnam Pro" pitchFamily="34" charset="0"/>
-                <a:ea typeface="Be Vietnam Pro" pitchFamily="34" charset="-122"/>
-                <a:cs typeface="Be Vietnam Pro" pitchFamily="34" charset="-120"/>
-              </a:rPr>
-              <a:t> niên</a:t>
-            </a:r>
-            <a:r>
-              <a:rPr lang="en-US" sz="2550" dirty="0" spc="0" kern="0">
-                <a:solidFill>
-                  <a:srgbClr val="14161C"/>
-                </a:solidFill>
-                <a:latin typeface="Be Vietnam Pro" pitchFamily="34" charset="0"/>
-                <a:ea typeface="Be Vietnam Pro" pitchFamily="34" charset="-122"/>
-                <a:cs typeface="Be Vietnam Pro" pitchFamily="34" charset="-120"/>
-              </a:rPr>
-              <a:t> nào,</a:t>
+              <a:t> gì,</a:t>
             </a:r>
             <a:r>
               <a:rPr lang="en-US" sz="2550" dirty="0" spc="-2" kern="0">
@@ -18454,6 +18289,17 @@
               <a:t> theo</a:t>
             </a:r>
             <a:r>
+              <a:rPr lang="en-US" sz="2550" dirty="0" spc="-12" kern="0">
+                <a:solidFill>
+                  <a:srgbClr val="14161C"/>
+                </a:solidFill>
+                <a:latin typeface="Be Vietnam Pro" pitchFamily="34" charset="0"/>
+                <a:ea typeface="Be Vietnam Pro" pitchFamily="34" charset="-122"/>
+                <a:cs typeface="Be Vietnam Pro" pitchFamily="34" charset="-120"/>
+              </a:rPr>
+              <a:t> tài</a:t>
+            </a:r>
+            <a:r>
               <a:rPr lang="en-US" sz="2550" dirty="0" spc="1" kern="0">
                 <a:solidFill>
                   <a:srgbClr val="14161C"/>
@@ -18462,62 +18308,7 @@
                 <a:ea typeface="Be Vietnam Pro" pitchFamily="34" charset="-122"/>
                 <a:cs typeface="Be Vietnam Pro" pitchFamily="34" charset="-120"/>
               </a:rPr>
-              <a:t> nguồn</a:t>
-            </a:r>
-            <a:r>
-              <a:rPr lang="en-US" sz="2550" dirty="0" spc="-19" kern="0">
-                <a:solidFill>
-                  <a:srgbClr val="14161C"/>
-                </a:solidFill>
-                <a:latin typeface="Be Vietnam Pro" pitchFamily="34" charset="0"/>
-                <a:ea typeface="Be Vietnam Pro" pitchFamily="34" charset="-122"/>
-                <a:cs typeface="Be Vietnam Pro" pitchFamily="34" charset="-120"/>
-              </a:rPr>
-              <a:t> và</a:t>
-            </a:r>
-            <a:r>
-              <a:rPr lang="en-US" sz="2550" dirty="0" spc="-2" kern="0">
-                <a:solidFill>
-                  <a:srgbClr val="14161C"/>
-                </a:solidFill>
-                <a:latin typeface="Be Vietnam Pro" pitchFamily="34" charset="0"/>
-                <a:ea typeface="Be Vietnam Pro" pitchFamily="34" charset="-122"/>
-                <a:cs typeface="Be Vietnam Pro" pitchFamily="34" charset="-120"/>
-              </a:rPr>
-              <a:t> theo</a:t>
-            </a:r>
-            <a:r>
-              <a:rPr lang="en-US" sz="2550" dirty="0" spc="-12" kern="0">
-                <a:solidFill>
-                  <a:srgbClr val="14161C"/>
-                </a:solidFill>
-                <a:latin typeface="Be Vietnam Pro" pitchFamily="34" charset="0"/>
-                <a:ea typeface="Be Vietnam Pro" pitchFamily="34" charset="-122"/>
-                <a:cs typeface="Be Vietnam Pro" pitchFamily="34" charset="-120"/>
-              </a:rPr>
-              <a:t> tài</a:t>
-            </a:r>
-            <a:r>
-              <a:rPr lang="en-US" sz="2550" dirty="0" spc="1" kern="0">
-                <a:solidFill>
-                  <a:srgbClr val="14161C"/>
-                </a:solidFill>
-                <a:latin typeface="Be Vietnam Pro" pitchFamily="34" charset="0"/>
-                <a:ea typeface="Be Vietnam Pro" pitchFamily="34" charset="-122"/>
-                <a:cs typeface="Be Vietnam Pro" pitchFamily="34" charset="-120"/>
-              </a:rPr>
               <a:t> liệu</a:t>
-            </a:r>
-            <a:r>
-              <a:rPr lang="en-US" sz="2550" dirty="0" spc="-1" kern="0">
-                <a:solidFill>
-                  <a:srgbClr val="14161C"/>
-                </a:solidFill>
-                <a:latin typeface="Be Vietnam Pro" pitchFamily="34" charset="0"/>
-                <a:ea typeface="Be Vietnam Pro" pitchFamily="34" charset="-122"/>
-                <a:cs typeface="Be Vietnam Pro" pitchFamily="34" charset="-120"/>
-              </a:rPr>
-              <a:t> của</a:t>
             </a:r>
             <a:r>
               <a:rPr lang="en-US" sz="2550" dirty="0" spc="7" kern="0">
@@ -18627,6 +18418,17 @@
               <a:buNone/>
             </a:pPr>
             <a:r>
+              <a:rPr lang="en-US" sz="2550" dirty="0" spc="-2" kern="0">
+                <a:solidFill>
+                  <a:srgbClr val="14161C"/>
+                </a:solidFill>
+                <a:latin typeface="Be Vietnam Pro" pitchFamily="34" charset="0"/>
+                <a:ea typeface="Be Vietnam Pro" pitchFamily="34" charset="-122"/>
+                <a:cs typeface="Be Vietnam Pro" pitchFamily="34" charset="-120"/>
+              </a:rPr>
+              <a:t>Carbon tự</a:t>
+            </a:r>
+            <a:r>
               <a:rPr lang="en-US" sz="2550" dirty="0" spc="0" kern="0">
                 <a:solidFill>
                   <a:srgbClr val="14161C"/>
@@ -18635,18 +18437,7 @@
                 <a:ea typeface="Be Vietnam Pro" pitchFamily="34" charset="-122"/>
                 <a:cs typeface="Be Vietnam Pro" pitchFamily="34" charset="-120"/>
               </a:rPr>
-              <a:t>Swift</a:t>
-            </a:r>
-            <a:r>
-              <a:rPr lang="en-US" sz="2550" dirty="0" spc="6" kern="0">
-                <a:solidFill>
-                  <a:srgbClr val="14161C"/>
-                </a:solidFill>
-                <a:latin typeface="Be Vietnam Pro" pitchFamily="34" charset="0"/>
-                <a:ea typeface="Be Vietnam Pro" pitchFamily="34" charset="-122"/>
-                <a:cs typeface="Be Vietnam Pro" pitchFamily="34" charset="-120"/>
-              </a:rPr>
-              <a:t> được</a:t>
+              <a:t> nhận mình</a:t>
             </a:r>
             <a:r>
               <a:rPr lang="en-US" sz="2550" dirty="0" spc="1" kern="0">
@@ -18657,51 +18448,18 @@
                 <a:ea typeface="Be Vietnam Pro" pitchFamily="34" charset="-122"/>
                 <a:cs typeface="Be Vietnam Pro" pitchFamily="34" charset="-120"/>
               </a:rPr>
-              <a:t> Apple</a:t>
-            </a:r>
-            <a:r>
-              <a:rPr lang="en-US" sz="2550" dirty="0" spc="-12" kern="0">
-                <a:solidFill>
-                  <a:srgbClr val="14161C"/>
-                </a:solidFill>
-                <a:latin typeface="Be Vietnam Pro" pitchFamily="34" charset="0"/>
-                <a:ea typeface="Be Vietnam Pro" pitchFamily="34" charset="-122"/>
-                <a:cs typeface="Be Vietnam Pro" pitchFamily="34" charset="-120"/>
-              </a:rPr>
-              <a:t> tạo</a:t>
-            </a:r>
-            <a:r>
-              <a:rPr lang="en-US" sz="2550" dirty="0" spc="-34" kern="0">
-                <a:solidFill>
-                  <a:srgbClr val="14161C"/>
-                </a:solidFill>
-                <a:latin typeface="Be Vietnam Pro" pitchFamily="34" charset="0"/>
-                <a:ea typeface="Be Vietnam Pro" pitchFamily="34" charset="-122"/>
-                <a:cs typeface="Be Vietnam Pro" pitchFamily="34" charset="-120"/>
-              </a:rPr>
-              <a:t> ra</a:t>
-            </a:r>
-            <a:r>
-              <a:rPr lang="en-US" sz="2550" dirty="0" spc="18" kern="0">
-                <a:solidFill>
-                  <a:srgbClr val="14161C"/>
-                </a:solidFill>
-                <a:latin typeface="Be Vietnam Pro" pitchFamily="34" charset="0"/>
-                <a:ea typeface="Be Vietnam Pro" pitchFamily="34" charset="-122"/>
-                <a:cs typeface="Be Vietnam Pro" pitchFamily="34" charset="-120"/>
-              </a:rPr>
-              <a:t> để</a:t>
-            </a:r>
-            <a:r>
-              <a:rPr lang="en-US" sz="2550" dirty="0" spc="-8" kern="0">
-                <a:solidFill>
-                  <a:srgbClr val="14161C"/>
-                </a:solidFill>
-                <a:latin typeface="Be Vietnam Pro" pitchFamily="34" charset="0"/>
-                <a:ea typeface="Be Vietnam Pro" pitchFamily="34" charset="-122"/>
-                <a:cs typeface="Be Vietnam Pro" pitchFamily="34" charset="-120"/>
-              </a:rPr>
-              <a:t> thay</a:t>
+              <a:t> là</a:t>
+            </a:r>
+            <a:r>
+              <a:rPr lang="en-US" sz="2550" dirty="0" spc="2" kern="0">
+                <a:solidFill>
+                  <a:srgbClr val="14161C"/>
+                </a:solidFill>
+                <a:latin typeface="Be Vietnam Pro" pitchFamily="34" charset="0"/>
+                <a:ea typeface="Be Vietnam Pro" pitchFamily="34" charset="-122"/>
+                <a:cs typeface="Be Vietnam Pro" pitchFamily="34" charset="-120"/>
+              </a:rPr>
+              <a:t> gì</a:t>
             </a:r>
             <a:r>
               <a:rPr lang="en-US" sz="2550" dirty="0" spc="-10" kern="0">
@@ -18712,18 +18470,18 @@
                 <a:ea typeface="Be Vietnam Pro" pitchFamily="34" charset="-122"/>
                 <a:cs typeface="Be Vietnam Pro" pitchFamily="34" charset="-120"/>
               </a:rPr>
-              <a:t> ngôn</a:t>
-            </a:r>
-            <a:r>
-              <a:rPr lang="en-US" sz="2550" dirty="0" spc="-2" kern="0">
-                <a:solidFill>
-                  <a:srgbClr val="14161C"/>
-                </a:solidFill>
-                <a:latin typeface="Be Vietnam Pro" pitchFamily="34" charset="0"/>
-                <a:ea typeface="Be Vietnam Pro" pitchFamily="34" charset="-122"/>
-                <a:cs typeface="Be Vietnam Pro" pitchFamily="34" charset="-120"/>
-              </a:rPr>
-              <a:t> ngữ</a:t>
+              <a:t> so</a:t>
+            </a:r>
+            <a:r>
+              <a:rPr lang="en-US" sz="2550" dirty="0" spc="-15" kern="0">
+                <a:solidFill>
+                  <a:srgbClr val="14161C"/>
+                </a:solidFill>
+                <a:latin typeface="Be Vietnam Pro" pitchFamily="34" charset="0"/>
+                <a:ea typeface="Be Vietnam Pro" pitchFamily="34" charset="-122"/>
+                <a:cs typeface="Be Vietnam Pro" pitchFamily="34" charset="-120"/>
+              </a:rPr>
+              <a:t> với</a:t>
             </a:r>
             <a:r>
               <a:rPr lang="en-US" sz="2550" dirty="0" spc="0" kern="0">
@@ -18734,7 +18492,7 @@
                 <a:ea typeface="Be Vietnam Pro" pitchFamily="34" charset="-122"/>
                 <a:cs typeface="Be Vietnam Pro" pitchFamily="34" charset="-120"/>
               </a:rPr>
-              <a:t> nào?</a:t>
+              <a:t> C++?</a:t>
             </a:r>
             <a:endParaRPr lang="en-US" sz="2550" dirty="0"/>
           </a:p>
@@ -18907,59 +18665,37 @@
               <a:buNone/>
             </a:pPr>
             <a:r>
-              <a:rPr lang="en-US" sz="2700" b="1" dirty="0" spc="-24" kern="0">
-                <a:solidFill>
-                  <a:srgbClr val="14161C"/>
-                </a:solidFill>
-                <a:latin typeface="Be Vietnam Pro" pitchFamily="34" charset="0"/>
-                <a:ea typeface="Be Vietnam Pro" pitchFamily="34" charset="-122"/>
-                <a:cs typeface="Be Vietnam Pro" pitchFamily="34" charset="-120"/>
-              </a:rPr>
-              <a:t>Java,</a:t>
-            </a:r>
-            <a:r>
-              <a:rPr lang="en-US" sz="2700" b="1" dirty="0" spc="-10" kern="0">
-                <a:solidFill>
-                  <a:srgbClr val="14161C"/>
-                </a:solidFill>
-                <a:latin typeface="Be Vietnam Pro" pitchFamily="34" charset="0"/>
-                <a:ea typeface="Be Vietnam Pro" pitchFamily="34" charset="-122"/>
-                <a:cs typeface="Be Vietnam Pro" pitchFamily="34" charset="-120"/>
-              </a:rPr>
-              <a:t> JavaScript,</a:t>
-            </a:r>
-            <a:r>
-              <a:rPr lang="en-US" sz="2700" b="1" dirty="0" spc="-3" kern="0">
-                <a:solidFill>
-                  <a:srgbClr val="14161C"/>
-                </a:solidFill>
-                <a:latin typeface="Be Vietnam Pro" pitchFamily="34" charset="0"/>
-                <a:ea typeface="Be Vietnam Pro" pitchFamily="34" charset="-122"/>
-                <a:cs typeface="Be Vietnam Pro" pitchFamily="34" charset="-120"/>
-              </a:rPr>
-              <a:t> PHP</a:t>
-            </a:r>
-            <a:r>
-              <a:rPr lang="en-US" sz="2700" b="1" dirty="0" spc="-23" kern="0">
-                <a:solidFill>
-                  <a:srgbClr val="14161C"/>
-                </a:solidFill>
-                <a:latin typeface="Be Vietnam Pro" pitchFamily="34" charset="0"/>
-                <a:ea typeface="Be Vietnam Pro" pitchFamily="34" charset="-122"/>
-                <a:cs typeface="Be Vietnam Pro" pitchFamily="34" charset="-120"/>
-              </a:rPr>
-              <a:t> và</a:t>
-            </a:r>
-            <a:r>
-              <a:rPr lang="en-US" sz="2700" b="1" dirty="0" spc="-47" kern="0">
-                <a:solidFill>
-                  <a:srgbClr val="14161C"/>
-                </a:solidFill>
-                <a:latin typeface="Be Vietnam Pro" pitchFamily="34" charset="0"/>
-                <a:ea typeface="Be Vietnam Pro" pitchFamily="34" charset="-122"/>
-                <a:cs typeface="Be Vietnam Pro" pitchFamily="34" charset="-120"/>
-              </a:rPr>
-              <a:t> Ruby</a:t>
+              <a:rPr lang="en-US" sz="2700" b="1" dirty="0" spc="-8" kern="0">
+                <a:solidFill>
+                  <a:srgbClr val="14161C"/>
+                </a:solidFill>
+                <a:latin typeface="Be Vietnam Pro" pitchFamily="34" charset="0"/>
+                <a:ea typeface="Be Vietnam Pro" pitchFamily="34" charset="-122"/>
+                <a:cs typeface="Be Vietnam Pro" pitchFamily="34" charset="-120"/>
+              </a:rPr>
+              <a:t>Netscape</a:t>
+            </a:r>
+            <a:r>
+              <a:rPr lang="en-US" sz="2700" b="1" dirty="0" spc="-14" kern="0">
+                <a:solidFill>
+                  <a:srgbClr val="14161C"/>
+                </a:solidFill>
+                <a:latin typeface="Be Vietnam Pro" pitchFamily="34" charset="0"/>
+                <a:ea typeface="Be Vietnam Pro" pitchFamily="34" charset="-122"/>
+                <a:cs typeface="Be Vietnam Pro" pitchFamily="34" charset="-120"/>
+              </a:rPr>
+              <a:t> Navigator</a:t>
+            </a:r>
+            <a:r>
+              <a:rPr lang="en-US" sz="2700" b="1" dirty="0" spc="1" kern="0">
+                <a:solidFill>
+                  <a:srgbClr val="14161C"/>
+                </a:solidFill>
+                <a:latin typeface="Be Vietnam Pro" pitchFamily="34" charset="0"/>
+                <a:ea typeface="Be Vietnam Pro" pitchFamily="34" charset="-122"/>
+                <a:cs typeface="Be Vietnam Pro" pitchFamily="34" charset="-120"/>
+              </a:rPr>
+              <a:t> 2.0</a:t>
             </a:r>
             <a:endParaRPr lang="en-US" sz="2700" dirty="0"/>
           </a:p>
@@ -18993,7 +18729,7 @@
               <a:buNone/>
             </a:pPr>
             <a:r>
-              <a:rPr lang="en-US" sz="2250" dirty="0" spc="3" kern="0">
+              <a:rPr lang="en-US" sz="2250" dirty="0" spc="-2" kern="0">
                 <a:solidFill>
                   <a:srgbClr val="6B6A66"/>
                 </a:solidFill>
@@ -19001,10 +18737,10 @@
                 <a:ea typeface="Be Vietnam Pro" pitchFamily="34" charset="-122"/>
                 <a:cs typeface="Be Vietnam Pro" pitchFamily="34" charset="-120"/>
               </a:rPr>
-              <a:t>Bốn</a:t>
-            </a:r>
-            <a:r>
-              <a:rPr lang="en-US" sz="2250" dirty="0" spc="-7" kern="0">
+              <a:t>Tháng</a:t>
+            </a:r>
+            <a:r>
+              <a:rPr lang="en-US" sz="2250" dirty="0" spc="6" kern="0">
                 <a:solidFill>
                   <a:srgbClr val="6B6A66"/>
                 </a:solidFill>
@@ -19012,7 +18748,18 @@
                 <a:ea typeface="Be Vietnam Pro" pitchFamily="34" charset="-122"/>
                 <a:cs typeface="Be Vietnam Pro" pitchFamily="34" charset="-120"/>
               </a:rPr>
-              <a:t> ngôn</a:t>
+              <a:t> 9</a:t>
+            </a:r>
+            <a:r>
+              <a:rPr lang="en-US" sz="2250" dirty="0" spc="-1" kern="0">
+                <a:solidFill>
+                  <a:srgbClr val="6B6A66"/>
+                </a:solidFill>
+                <a:latin typeface="Be Vietnam Pro" pitchFamily="34" charset="0"/>
+                <a:ea typeface="Be Vietnam Pro" pitchFamily="34" charset="-122"/>
+                <a:cs typeface="Be Vietnam Pro" pitchFamily="34" charset="-120"/>
+              </a:rPr>
+              <a:t> năm</a:t>
             </a:r>
             <a:r>
               <a:rPr lang="en-US" sz="2250" dirty="0" spc="2" kern="0">
@@ -19023,10 +18770,10 @@
                 <a:ea typeface="Be Vietnam Pro" pitchFamily="34" charset="-122"/>
                 <a:cs typeface="Be Vietnam Pro" pitchFamily="34" charset="-120"/>
               </a:rPr>
-              <a:t> ngữ</a:t>
-            </a:r>
-            <a:r>
-              <a:rPr lang="en-US" sz="2250" dirty="0" spc="-32" kern="0">
+              <a:t> 1995,</a:t>
+            </a:r>
+            <a:r>
+              <a:rPr lang="en-US" sz="2250" dirty="0" spc="-3" kern="0">
                 <a:solidFill>
                   <a:srgbClr val="6B6A66"/>
                 </a:solidFill>
@@ -19034,10 +18781,10 @@
                 <a:ea typeface="Be Vietnam Pro" pitchFamily="34" charset="-122"/>
                 <a:cs typeface="Be Vietnam Pro" pitchFamily="34" charset="-120"/>
               </a:rPr>
-              <a:t> ra</a:t>
-            </a:r>
-            <a:r>
-              <a:rPr lang="en-US" sz="2250" dirty="0" spc="13" kern="0">
+              <a:t> theo</a:t>
+            </a:r>
+            <a:r>
+              <a:rPr lang="en-US" sz="2250" dirty="0" spc="-1" kern="0">
                 <a:solidFill>
                   <a:srgbClr val="6B6A66"/>
                 </a:solidFill>
@@ -19045,29 +18792,7 @@
                 <a:ea typeface="Be Vietnam Pro" pitchFamily="34" charset="-122"/>
                 <a:cs typeface="Be Vietnam Pro" pitchFamily="34" charset="-120"/>
               </a:rPr>
-              <a:t> đời</a:t>
-            </a:r>
-            <a:r>
-              <a:rPr lang="en-US" sz="2250" dirty="0" spc="-1" kern="0">
-                <a:solidFill>
-                  <a:srgbClr val="6B6A66"/>
-                </a:solidFill>
-                <a:latin typeface="Be Vietnam Pro" pitchFamily="34" charset="0"/>
-                <a:ea typeface="Be Vietnam Pro" pitchFamily="34" charset="-122"/>
-                <a:cs typeface="Be Vietnam Pro" pitchFamily="34" charset="-120"/>
-              </a:rPr>
-              <a:t> năm</a:t>
-            </a:r>
-            <a:r>
-              <a:rPr lang="en-US" sz="2250" dirty="0" spc="4" kern="0">
-                <a:solidFill>
-                  <a:srgbClr val="6B6A66"/>
-                </a:solidFill>
-                <a:latin typeface="Be Vietnam Pro" pitchFamily="34" charset="0"/>
-                <a:ea typeface="Be Vietnam Pro" pitchFamily="34" charset="-122"/>
-                <a:cs typeface="Be Vietnam Pro" pitchFamily="34" charset="-120"/>
-              </a:rPr>
-              <a:t> 1995</a:t>
+              <a:t> MDN</a:t>
             </a:r>
             <a:endParaRPr lang="en-US" sz="2250" dirty="0"/>
           </a:p>
@@ -19163,6 +18888,28 @@
               <a:buNone/>
             </a:pPr>
             <a:r>
+              <a:rPr lang="en-US" sz="2700" b="1" dirty="0" spc="8" kern="0">
+                <a:solidFill>
+                  <a:srgbClr val="14161C"/>
+                </a:solidFill>
+                <a:latin typeface="Be Vietnam Pro" pitchFamily="34" charset="0"/>
+                <a:ea typeface="Be Vietnam Pro" pitchFamily="34" charset="-122"/>
+                <a:cs typeface="Be Vietnam Pro" pitchFamily="34" charset="-120"/>
+              </a:rPr>
+              <a:t>Đầu</a:t>
+            </a:r>
+            <a:r>
+              <a:rPr lang="en-US" sz="2700" b="1" dirty="0" spc="-2" kern="0">
+                <a:solidFill>
+                  <a:srgbClr val="14161C"/>
+                </a:solidFill>
+                <a:latin typeface="Be Vietnam Pro" pitchFamily="34" charset="0"/>
+                <a:ea typeface="Be Vietnam Pro" pitchFamily="34" charset="-122"/>
+                <a:cs typeface="Be Vietnam Pro" pitchFamily="34" charset="-120"/>
+              </a:rPr>
+              <a:t> thập niên</a:t>
+            </a:r>
+            <a:r>
               <a:rPr lang="en-US" sz="2700" b="1" dirty="0" spc="1" kern="0">
                 <a:solidFill>
                   <a:srgbClr val="14161C"/>
@@ -19171,51 +18918,7 @@
                 <a:ea typeface="Be Vietnam Pro" pitchFamily="34" charset="-122"/>
                 <a:cs typeface="Be Vietnam Pro" pitchFamily="34" charset="-120"/>
               </a:rPr>
-              <a:t>Thập</a:t>
-            </a:r>
-            <a:r>
-              <a:rPr lang="en-US" sz="2700" b="1" dirty="0" spc="-2" kern="0">
-                <a:solidFill>
-                  <a:srgbClr val="14161C"/>
-                </a:solidFill>
-                <a:latin typeface="Be Vietnam Pro" pitchFamily="34" charset="0"/>
-                <a:ea typeface="Be Vietnam Pro" pitchFamily="34" charset="-122"/>
-                <a:cs typeface="Be Vietnam Pro" pitchFamily="34" charset="-120"/>
-              </a:rPr>
-              <a:t> niên</a:t>
-            </a:r>
-            <a:r>
-              <a:rPr lang="en-US" sz="2700" b="1" dirty="0" spc="0" kern="0">
-                <a:solidFill>
-                  <a:srgbClr val="14161C"/>
-                </a:solidFill>
-                <a:latin typeface="Be Vietnam Pro" pitchFamily="34" charset="0"/>
-                <a:ea typeface="Be Vietnam Pro" pitchFamily="34" charset="-122"/>
-                <a:cs typeface="Be Vietnam Pro" pitchFamily="34" charset="-120"/>
-              </a:rPr>
-              <a:t> 1990,</a:t>
-            </a:r>
-            <a:r>
-              <a:rPr lang="en-US" sz="2700" b="1" dirty="0" spc="-5" kern="0">
-                <a:solidFill>
-                  <a:srgbClr val="14161C"/>
-                </a:solidFill>
-                <a:latin typeface="Be Vietnam Pro" pitchFamily="34" charset="0"/>
-                <a:ea typeface="Be Vietnam Pro" pitchFamily="34" charset="-122"/>
-                <a:cs typeface="Be Vietnam Pro" pitchFamily="34" charset="-120"/>
-              </a:rPr>
-              <a:t> theo</a:t>
-            </a:r>
-            <a:r>
-              <a:rPr lang="en-US" sz="2700" b="1" dirty="0" spc="-4" kern="0">
-                <a:solidFill>
-                  <a:srgbClr val="14161C"/>
-                </a:solidFill>
-                <a:latin typeface="Be Vietnam Pro" pitchFamily="34" charset="0"/>
-                <a:ea typeface="Be Vietnam Pro" pitchFamily="34" charset="-122"/>
-                <a:cs typeface="Be Vietnam Pro" pitchFamily="34" charset="-120"/>
-              </a:rPr>
-              <a:t> nguồn</a:t>
+              <a:t> 1990</a:t>
             </a:r>
             <a:endParaRPr lang="en-US" sz="2700" dirty="0"/>
           </a:p>
@@ -19249,7 +18952,7 @@
               <a:buNone/>
             </a:pPr>
             <a:r>
-              <a:rPr lang="en-US" sz="2250" dirty="0" spc="-71" kern="0">
+              <a:rPr lang="en-US" sz="2250" dirty="0" spc="-3" kern="0">
                 <a:solidFill>
                   <a:srgbClr val="6B6A66"/>
                 </a:solidFill>
@@ -19257,10 +18960,10 @@
                 <a:ea typeface="Be Vietnam Pro" pitchFamily="34" charset="-122"/>
                 <a:cs typeface="Be Vietnam Pro" pitchFamily="34" charset="-120"/>
               </a:rPr>
-              <a:t>Tài</a:t>
-            </a:r>
-            <a:r>
-              <a:rPr lang="en-US" sz="2250" dirty="0" spc="-2" kern="0">
+              <a:t>Do</a:t>
+            </a:r>
+            <a:r>
+              <a:rPr lang="en-US" sz="2250" dirty="0" spc="-1" kern="0">
                 <a:solidFill>
                   <a:srgbClr val="6B6A66"/>
                 </a:solidFill>
@@ -19268,10 +18971,10 @@
                 <a:ea typeface="Be Vietnam Pro" pitchFamily="34" charset="-122"/>
                 <a:cs typeface="Be Vietnam Pro" pitchFamily="34" charset="-120"/>
               </a:rPr>
-              <a:t> liệu</a:t>
-            </a:r>
-            <a:r>
-              <a:rPr lang="en-US" sz="2250" dirty="0" spc="6" kern="0">
+              <a:t> Guido</a:t>
+            </a:r>
+            <a:r>
+              <a:rPr lang="en-US" sz="2250" dirty="0" spc="-11" kern="0">
                 <a:solidFill>
                   <a:srgbClr val="6B6A66"/>
                 </a:solidFill>
@@ -19279,10 +18982,10 @@
                 <a:ea typeface="Be Vietnam Pro" pitchFamily="34" charset="-122"/>
                 <a:cs typeface="Be Vietnam Pro" pitchFamily="34" charset="-120"/>
               </a:rPr>
-              <a:t> Python:</a:t>
-            </a:r>
-            <a:r>
-              <a:rPr lang="en-US" sz="2250" dirty="0" spc="12" kern="0">
+              <a:t> van</a:t>
+            </a:r>
+            <a:r>
+              <a:rPr lang="en-US" sz="2250" dirty="0" spc="-15" kern="0">
                 <a:solidFill>
                   <a:srgbClr val="6B6A66"/>
                 </a:solidFill>
@@ -19290,10 +18993,10 @@
                 <a:ea typeface="Be Vietnam Pro" pitchFamily="34" charset="-122"/>
                 <a:cs typeface="Be Vietnam Pro" pitchFamily="34" charset="-120"/>
               </a:rPr>
-              <a:t> đầu</a:t>
-            </a:r>
-            <a:r>
-              <a:rPr lang="en-US" sz="2250" dirty="0" spc="1" kern="0">
+              <a:t> Rossum</a:t>
+            </a:r>
+            <a:r>
+              <a:rPr lang="en-US" sz="2250" dirty="0" spc="-13" kern="0">
                 <a:solidFill>
                   <a:srgbClr val="6B6A66"/>
                 </a:solidFill>
@@ -19301,7 +19004,29 @@
                 <a:ea typeface="Be Vietnam Pro" pitchFamily="34" charset="-122"/>
                 <a:cs typeface="Be Vietnam Pro" pitchFamily="34" charset="-120"/>
               </a:rPr>
-              <a:t> thập</a:t>
+              <a:t> tạo</a:t>
+            </a:r>
+            <a:r>
+              <a:rPr lang="en-US" sz="2250" dirty="0" spc="-25" kern="0">
+                <a:solidFill>
+                  <a:srgbClr val="6B6A66"/>
+                </a:solidFill>
+                <a:latin typeface="Be Vietnam Pro" pitchFamily="34" charset="0"/>
+                <a:ea typeface="Be Vietnam Pro" pitchFamily="34" charset="-122"/>
+                <a:cs typeface="Be Vietnam Pro" pitchFamily="34" charset="-120"/>
+              </a:rPr>
+              <a:t> ra,</a:t>
+            </a:r>
+            <a:r>
+              <a:rPr lang="en-US" sz="2250" dirty="0" spc="-34" kern="0">
+                <a:solidFill>
+                  <a:srgbClr val="6B6A66"/>
+                </a:solidFill>
+                <a:latin typeface="Be Vietnam Pro" pitchFamily="34" charset="0"/>
+                <a:ea typeface="Be Vietnam Pro" pitchFamily="34" charset="-122"/>
+                <a:cs typeface="Be Vietnam Pro" pitchFamily="34" charset="-120"/>
+              </a:rPr>
+              <a:t> kế</a:t>
             </a:r>
             <a:r>
               <a:rPr lang="en-US" sz="2250" dirty="0" spc="-1" kern="0">
@@ -19312,7 +19037,29 @@
                 <a:ea typeface="Be Vietnam Pro" pitchFamily="34" charset="-122"/>
                 <a:cs typeface="Be Vietnam Pro" pitchFamily="34" charset="-120"/>
               </a:rPr>
-              <a:t> niên</a:t>
+              <a:t> nhiệm</a:t>
+            </a:r>
+            <a:r>
+              <a:rPr lang="en-US" sz="2250" dirty="0" spc="-5" kern="0">
+                <a:solidFill>
+                  <a:srgbClr val="6B6A66"/>
+                </a:solidFill>
+                <a:latin typeface="Be Vietnam Pro" pitchFamily="34" charset="0"/>
+                <a:ea typeface="Be Vietnam Pro" pitchFamily="34" charset="-122"/>
+                <a:cs typeface="Be Vietnam Pro" pitchFamily="34" charset="-120"/>
+              </a:rPr>
+              <a:t> một</a:t>
+            </a:r>
+            <a:r>
+              <a:rPr lang="en-US" sz="2250" dirty="0" spc="-7" kern="0">
+                <a:solidFill>
+                  <a:srgbClr val="6B6A66"/>
+                </a:solidFill>
+                <a:latin typeface="Be Vietnam Pro" pitchFamily="34" charset="0"/>
+                <a:ea typeface="Be Vietnam Pro" pitchFamily="34" charset="-122"/>
+                <a:cs typeface="Be Vietnam Pro" pitchFamily="34" charset="-120"/>
+              </a:rPr>
+              <a:t> ngôn</a:t>
             </a:r>
             <a:r>
               <a:rPr lang="en-US" sz="2250" dirty="0" spc="2" kern="0">
@@ -19323,10 +19070,10 @@
                 <a:ea typeface="Be Vietnam Pro" pitchFamily="34" charset="-122"/>
                 <a:cs typeface="Be Vietnam Pro" pitchFamily="34" charset="-120"/>
               </a:rPr>
-              <a:t> 1990,</a:t>
-            </a:r>
-            <a:r>
-              <a:rPr lang="en-US" sz="2250" dirty="0" spc="0" kern="0">
+              <a:t> ngữ</a:t>
+            </a:r>
+            <a:r>
+              <a:rPr lang="en-US" sz="2250" dirty="0" spc="5" kern="0">
                 <a:solidFill>
                   <a:srgbClr val="6B6A66"/>
                 </a:solidFill>
@@ -19334,51 +19081,7 @@
                 <a:ea typeface="Be Vietnam Pro" pitchFamily="34" charset="-122"/>
                 <a:cs typeface="Be Vietnam Pro" pitchFamily="34" charset="-120"/>
               </a:rPr>
-              <a:t> do Guido</a:t>
-            </a:r>
-            <a:r>
-              <a:rPr lang="en-US" sz="2250" dirty="0" spc="-13" kern="0">
-                <a:solidFill>
-                  <a:srgbClr val="6B6A66"/>
-                </a:solidFill>
-                <a:latin typeface="Be Vietnam Pro" pitchFamily="34" charset="0"/>
-                <a:ea typeface="Be Vietnam Pro" pitchFamily="34" charset="-122"/>
-                <a:cs typeface="Be Vietnam Pro" pitchFamily="34" charset="-120"/>
-              </a:rPr>
-              <a:t> van</a:t>
-            </a:r>
-            <a:r>
-              <a:rPr lang="en-US" sz="2250" dirty="0" spc="-15" kern="0">
-                <a:solidFill>
-                  <a:srgbClr val="6B6A66"/>
-                </a:solidFill>
-                <a:latin typeface="Be Vietnam Pro" pitchFamily="34" charset="0"/>
-                <a:ea typeface="Be Vietnam Pro" pitchFamily="34" charset="-122"/>
-                <a:cs typeface="Be Vietnam Pro" pitchFamily="34" charset="-120"/>
-              </a:rPr>
-              <a:t> Rossum</a:t>
-            </a:r>
-            <a:r>
-              <a:rPr lang="en-US" sz="2250" dirty="0" spc="-12" kern="0">
-                <a:solidFill>
-                  <a:srgbClr val="6B6A66"/>
-                </a:solidFill>
-                <a:latin typeface="Be Vietnam Pro" pitchFamily="34" charset="0"/>
-                <a:ea typeface="Be Vietnam Pro" pitchFamily="34" charset="-122"/>
-                <a:cs typeface="Be Vietnam Pro" pitchFamily="34" charset="-120"/>
-              </a:rPr>
-              <a:t> tạo</a:t>
-            </a:r>
-            <a:r>
-              <a:rPr lang="en-US" sz="2250" dirty="0" spc="-32" kern="0">
-                <a:solidFill>
-                  <a:srgbClr val="6B6A66"/>
-                </a:solidFill>
-                <a:latin typeface="Be Vietnam Pro" pitchFamily="34" charset="0"/>
-                <a:ea typeface="Be Vietnam Pro" pitchFamily="34" charset="-122"/>
-                <a:cs typeface="Be Vietnam Pro" pitchFamily="34" charset="-120"/>
-              </a:rPr>
-              <a:t> ra</a:t>
+              <a:t> cũ</a:t>
             </a:r>
             <a:endParaRPr lang="en-US" sz="2250" dirty="0"/>
           </a:p>
@@ -19474,15 +19177,37 @@
               <a:buNone/>
             </a:pPr>
             <a:r>
-              <a:rPr lang="en-US" sz="2700" b="1" dirty="0" spc="-10" kern="0">
-                <a:solidFill>
-                  <a:srgbClr val="14161C"/>
-                </a:solidFill>
-                <a:latin typeface="Be Vietnam Pro" pitchFamily="34" charset="0"/>
-                <a:ea typeface="Be Vietnam Pro" pitchFamily="34" charset="-122"/>
-                <a:cs typeface="Be Vietnam Pro" pitchFamily="34" charset="-120"/>
-              </a:rPr>
-              <a:t>Objective-C</a:t>
+              <a:rPr lang="en-US" sz="2700" b="1" dirty="0" spc="-59" kern="0">
+                <a:solidFill>
+                  <a:srgbClr val="14161C"/>
+                </a:solidFill>
+                <a:latin typeface="Be Vietnam Pro" pitchFamily="34" charset="0"/>
+                <a:ea typeface="Be Vietnam Pro" pitchFamily="34" charset="-122"/>
+                <a:cs typeface="Be Vietnam Pro" pitchFamily="34" charset="-120"/>
+              </a:rPr>
+              <a:t>Kế</a:t>
+            </a:r>
+            <a:r>
+              <a:rPr lang="en-US" sz="2700" b="1" dirty="0" spc="-2" kern="0">
+                <a:solidFill>
+                  <a:srgbClr val="14161C"/>
+                </a:solidFill>
+                <a:latin typeface="Be Vietnam Pro" pitchFamily="34" charset="0"/>
+                <a:ea typeface="Be Vietnam Pro" pitchFamily="34" charset="-122"/>
+                <a:cs typeface="Be Vietnam Pro" pitchFamily="34" charset="-120"/>
+              </a:rPr>
+              <a:t> nhiệm</a:t>
+            </a:r>
+            <a:r>
+              <a:rPr lang="en-US" sz="2700" b="1" dirty="0" spc="-1" kern="0">
+                <a:solidFill>
+                  <a:srgbClr val="14161C"/>
+                </a:solidFill>
+                <a:latin typeface="Be Vietnam Pro" pitchFamily="34" charset="0"/>
+                <a:ea typeface="Be Vietnam Pro" pitchFamily="34" charset="-122"/>
+                <a:cs typeface="Be Vietnam Pro" pitchFamily="34" charset="-120"/>
+              </a:rPr>
+              <a:t> C++</a:t>
             </a:r>
             <a:endParaRPr lang="en-US" sz="2700" dirty="0"/>
           </a:p>
@@ -19516,6 +19241,17 @@
               <a:buNone/>
             </a:pPr>
             <a:r>
+              <a:rPr lang="en-US" sz="2250" dirty="0" spc="-11" kern="0">
+                <a:solidFill>
+                  <a:srgbClr val="6B6A66"/>
+                </a:solidFill>
+                <a:latin typeface="Be Vietnam Pro" pitchFamily="34" charset="0"/>
+                <a:ea typeface="Be Vietnam Pro" pitchFamily="34" charset="-122"/>
+                <a:cs typeface="Be Vietnam Pro" pitchFamily="34" charset="-120"/>
+              </a:rPr>
+              <a:t>Ngôn</a:t>
+            </a:r>
+            <a:r>
               <a:rPr lang="en-US" sz="2250" dirty="0" spc="2" kern="0">
                 <a:solidFill>
                   <a:srgbClr val="6B6A66"/>
@@ -19524,10 +19260,10 @@
                 <a:ea typeface="Be Vietnam Pro" pitchFamily="34" charset="-122"/>
                 <a:cs typeface="Be Vietnam Pro" pitchFamily="34" charset="-120"/>
               </a:rPr>
-              <a:t>Apple</a:t>
-            </a:r>
-            <a:r>
-              <a:rPr lang="en-US" sz="2250" dirty="0" spc="-12" kern="0">
+              <a:t> ngữ</a:t>
+            </a:r>
+            <a:r>
+              <a:rPr lang="en-US" sz="2250" dirty="0" spc="-34" kern="0">
                 <a:solidFill>
                   <a:srgbClr val="6B6A66"/>
                 </a:solidFill>
@@ -19535,10 +19271,10 @@
                 <a:ea typeface="Be Vietnam Pro" pitchFamily="34" charset="-122"/>
                 <a:cs typeface="Be Vietnam Pro" pitchFamily="34" charset="-120"/>
               </a:rPr>
-              <a:t> tạo</a:t>
-            </a:r>
-            <a:r>
-              <a:rPr lang="en-US" sz="2250" dirty="0" spc="-32" kern="0">
+              <a:t> kế</a:t>
+            </a:r>
+            <a:r>
+              <a:rPr lang="en-US" sz="2250" dirty="0" spc="-2" kern="0">
                 <a:solidFill>
                   <a:srgbClr val="6B6A66"/>
                 </a:solidFill>
@@ -19546,7 +19282,40 @@
                 <a:ea typeface="Be Vietnam Pro" pitchFamily="34" charset="-122"/>
                 <a:cs typeface="Be Vietnam Pro" pitchFamily="34" charset="-120"/>
               </a:rPr>
-              <a:t> ra</a:t>
+              <a:t> nhiệm</a:t>
+            </a:r>
+            <a:r>
+              <a:rPr lang="en-US" sz="2250" dirty="0" spc="3" kern="0">
+                <a:solidFill>
+                  <a:srgbClr val="6B6A66"/>
+                </a:solidFill>
+                <a:latin typeface="Be Vietnam Pro" pitchFamily="34" charset="0"/>
+                <a:ea typeface="Be Vietnam Pro" pitchFamily="34" charset="-122"/>
+                <a:cs typeface="Be Vietnam Pro" pitchFamily="34" charset="-120"/>
+              </a:rPr>
+              <a:t> thử</a:t>
+            </a:r>
+            <a:r>
+              <a:rPr lang="en-US" sz="2250" dirty="0" spc="-2" kern="0">
+                <a:solidFill>
+                  <a:srgbClr val="6B6A66"/>
+                </a:solidFill>
+                <a:latin typeface="Be Vietnam Pro" pitchFamily="34" charset="0"/>
+                <a:ea typeface="Be Vietnam Pro" pitchFamily="34" charset="-122"/>
+                <a:cs typeface="Be Vietnam Pro" pitchFamily="34" charset="-120"/>
+              </a:rPr>
+              <a:t> nghiệm,</a:t>
+            </a:r>
+            <a:r>
+              <a:rPr lang="en-US" sz="2250" dirty="0" spc="-3" kern="0">
+                <a:solidFill>
+                  <a:srgbClr val="6B6A66"/>
+                </a:solidFill>
+                <a:latin typeface="Be Vietnam Pro" pitchFamily="34" charset="0"/>
+                <a:ea typeface="Be Vietnam Pro" pitchFamily="34" charset="-122"/>
+                <a:cs typeface="Be Vietnam Pro" pitchFamily="34" charset="-120"/>
+              </a:rPr>
+              <a:t> theo</a:t>
             </a:r>
             <a:r>
               <a:rPr lang="en-US" sz="2250" dirty="0" spc="0" kern="0">
@@ -19557,51 +19326,7 @@
                 <a:ea typeface="Be Vietnam Pro" pitchFamily="34" charset="-122"/>
                 <a:cs typeface="Be Vietnam Pro" pitchFamily="34" charset="-120"/>
               </a:rPr>
-              <a:t> Swift</a:t>
-            </a:r>
-            <a:r>
-              <a:rPr lang="en-US" sz="2250" dirty="0" spc="17" kern="0">
-                <a:solidFill>
-                  <a:srgbClr val="6B6A66"/>
-                </a:solidFill>
-                <a:latin typeface="Be Vietnam Pro" pitchFamily="34" charset="0"/>
-                <a:ea typeface="Be Vietnam Pro" pitchFamily="34" charset="-122"/>
-                <a:cs typeface="Be Vietnam Pro" pitchFamily="34" charset="-120"/>
-              </a:rPr>
-              <a:t> để</a:t>
-            </a:r>
-            <a:r>
-              <a:rPr lang="en-US" sz="2250" dirty="0" spc="-7" kern="0">
-                <a:solidFill>
-                  <a:srgbClr val="6B6A66"/>
-                </a:solidFill>
-                <a:latin typeface="Be Vietnam Pro" pitchFamily="34" charset="0"/>
-                <a:ea typeface="Be Vietnam Pro" pitchFamily="34" charset="-122"/>
-                <a:cs typeface="Be Vietnam Pro" pitchFamily="34" charset="-120"/>
-              </a:rPr>
-              <a:t> thay ngôn</a:t>
-            </a:r>
-            <a:r>
-              <a:rPr lang="en-US" sz="2250" dirty="0" spc="2" kern="0">
-                <a:solidFill>
-                  <a:srgbClr val="6B6A66"/>
-                </a:solidFill>
-                <a:latin typeface="Be Vietnam Pro" pitchFamily="34" charset="0"/>
-                <a:ea typeface="Be Vietnam Pro" pitchFamily="34" charset="-122"/>
-                <a:cs typeface="Be Vietnam Pro" pitchFamily="34" charset="-120"/>
-              </a:rPr>
-              <a:t> ngữ</a:t>
-            </a:r>
-            <a:r>
-              <a:rPr lang="en-US" sz="2250" dirty="0" spc="-9" kern="0">
-                <a:solidFill>
-                  <a:srgbClr val="6B6A66"/>
-                </a:solidFill>
-                <a:latin typeface="Be Vietnam Pro" pitchFamily="34" charset="0"/>
-                <a:ea typeface="Be Vietnam Pro" pitchFamily="34" charset="-122"/>
-                <a:cs typeface="Be Vietnam Pro" pitchFamily="34" charset="-120"/>
-              </a:rPr>
-              <a:t> này</a:t>
+              <a:t> README</a:t>
             </a:r>
             <a:endParaRPr lang="en-US" sz="2250" dirty="0"/>
           </a:p>
@@ -20127,7 +19852,7 @@
               <a:buNone/>
             </a:pPr>
             <a:r>
-              <a:rPr lang="en-US" sz="7500" dirty="0" spc="-2" kern="0">
+              <a:rPr lang="en-US" sz="7500" dirty="0" spc="-64" kern="0">
                 <a:solidFill>
                   <a:srgbClr val="F3EEE3"/>
                 </a:solidFill>
@@ -20135,10 +19860,10 @@
                 <a:ea typeface="Bricolage Grotesque ExtraBold" pitchFamily="34" charset="-122"/>
                 <a:cs typeface="Bricolage Grotesque ExtraBold" pitchFamily="34" charset="-120"/>
               </a:rPr>
-              <a:t>Ba</a:t>
-            </a:r>
-            <a:r>
-              <a:rPr lang="en-US" sz="7500" dirty="0" spc="-3" kern="0">
+              <a:t>Từ</a:t>
+            </a:r>
+            <a:r>
+              <a:rPr lang="en-US" sz="7500" dirty="0" spc="1" kern="0">
                 <a:solidFill>
                   <a:srgbClr val="F3EEE3"/>
                 </a:solidFill>
@@ -20146,10 +19871,10 @@
                 <a:ea typeface="Bricolage Grotesque ExtraBold" pitchFamily="34" charset="-122"/>
                 <a:cs typeface="Bricolage Grotesque ExtraBold" pitchFamily="34" charset="-120"/>
               </a:rPr>
-              <a:t> từ</a:t>
-            </a:r>
-            <a:r>
-              <a:rPr lang="en-US" sz="7500" dirty="0" spc="1" kern="0">
+              <a:t> viết</a:t>
+            </a:r>
+            <a:r>
+              <a:rPr lang="en-US" sz="7500" dirty="0" spc="-9" kern="0">
                 <a:solidFill>
                   <a:srgbClr val="F3EEE3"/>
                 </a:solidFill>
@@ -20157,10 +19882,10 @@
                 <a:ea typeface="Bricolage Grotesque ExtraBold" pitchFamily="34" charset="-122"/>
                 <a:cs typeface="Bricolage Grotesque ExtraBold" pitchFamily="34" charset="-120"/>
               </a:rPr>
-              <a:t> viết</a:t>
-            </a:r>
-            <a:r>
-              <a:rPr lang="en-US" sz="7500" dirty="0" spc="-9" kern="0">
+              <a:t> tắt</a:t>
+            </a:r>
+            <a:r>
+              <a:rPr lang="en-US" sz="7500" dirty="0" spc="3" kern="0">
                 <a:solidFill>
                   <a:srgbClr val="F3EEE3"/>
                 </a:solidFill>
@@ -20168,7 +19893,7 @@
                 <a:ea typeface="Bricolage Grotesque ExtraBold" pitchFamily="34" charset="-122"/>
                 <a:cs typeface="Bricolage Grotesque ExtraBold" pitchFamily="34" charset="-120"/>
               </a:rPr>
-              <a:t> tắt</a:t>
+              <a:t> chính</a:t>
             </a:r>
             <a:endParaRPr lang="en-US" sz="7500" dirty="0"/>
           </a:p>
@@ -21276,6 +21001,28 @@
               <a:buNone/>
             </a:pPr>
             <a:r>
+              <a:rPr lang="en-US" sz="2550" b="1" dirty="0" spc="0" kern="0">
+                <a:solidFill>
+                  <a:srgbClr val="F3EEE3"/>
+                </a:solidFill>
+                <a:latin typeface="Be Vietnam Pro" pitchFamily="34" charset="0"/>
+                <a:ea typeface="Be Vietnam Pro" pitchFamily="34" charset="-122"/>
+                <a:cs typeface="Be Vietnam Pro" pitchFamily="34" charset="-120"/>
+              </a:rPr>
+              <a:t>Python,</a:t>
+            </a:r>
+            <a:r>
+              <a:rPr lang="en-US" sz="2550" b="1" dirty="0" spc="-1" kern="0">
+                <a:solidFill>
+                  <a:srgbClr val="F3EEE3"/>
+                </a:solidFill>
+                <a:latin typeface="Be Vietnam Pro" pitchFamily="34" charset="0"/>
+                <a:ea typeface="Be Vietnam Pro" pitchFamily="34" charset="-122"/>
+                <a:cs typeface="Be Vietnam Pro" pitchFamily="34" charset="-120"/>
+              </a:rPr>
+              <a:t> MDN,</a:t>
+            </a:r>
+            <a:r>
               <a:rPr lang="en-US" sz="2550" b="1" dirty="0" spc="1" kern="0">
                 <a:solidFill>
                   <a:srgbClr val="F3EEE3"/>
@@ -21284,7 +21031,7 @@
                 <a:ea typeface="Be Vietnam Pro" pitchFamily="34" charset="-122"/>
                 <a:cs typeface="Be Vietnam Pro" pitchFamily="34" charset="-120"/>
               </a:rPr>
-              <a:t>Python</a:t>
+              <a:t> README</a:t>
             </a:r>
             <a:endParaRPr lang="en-US" sz="2550" dirty="0"/>
           </a:p>
@@ -21318,6 +21065,61 @@
               <a:buNone/>
             </a:pPr>
             <a:r>
+              <a:rPr lang="en-US" sz="2100" dirty="0" spc="-8" kern="0">
+                <a:solidFill>
+                  <a:srgbClr val="C4C8D6"/>
+                </a:solidFill>
+                <a:latin typeface="Be Vietnam Pro" pitchFamily="34" charset="0"/>
+                <a:ea typeface="Be Vietnam Pro" pitchFamily="34" charset="-122"/>
+                <a:cs typeface="Be Vietnam Pro" pitchFamily="34" charset="-120"/>
+              </a:rPr>
+              <a:t>giấy</a:t>
+            </a:r>
+            <a:r>
+              <a:rPr lang="en-US" sz="2100" dirty="0" spc="-2" kern="0">
+                <a:solidFill>
+                  <a:srgbClr val="C4C8D6"/>
+                </a:solidFill>
+                <a:latin typeface="Be Vietnam Pro" pitchFamily="34" charset="0"/>
+                <a:ea typeface="Be Vietnam Pro" pitchFamily="34" charset="-122"/>
+                <a:cs typeface="Be Vietnam Pro" pitchFamily="34" charset="-120"/>
+              </a:rPr>
+              <a:t> phép</a:t>
+            </a:r>
+            <a:r>
+              <a:rPr lang="en-US" sz="2100" dirty="0" spc="4" kern="0">
+                <a:solidFill>
+                  <a:srgbClr val="C4C8D6"/>
+                </a:solidFill>
+                <a:latin typeface="Be Vietnam Pro" pitchFamily="34" charset="0"/>
+                <a:ea typeface="Be Vietnam Pro" pitchFamily="34" charset="-122"/>
+                <a:cs typeface="Be Vietnam Pro" pitchFamily="34" charset="-120"/>
+              </a:rPr>
+              <a:t> Python,</a:t>
+            </a:r>
+            <a:r>
+              <a:rPr lang="en-US" sz="2100" dirty="0" spc="-8" kern="0">
+                <a:solidFill>
+                  <a:srgbClr val="C4C8D6"/>
+                </a:solidFill>
+                <a:latin typeface="Be Vietnam Pro" pitchFamily="34" charset="0"/>
+                <a:ea typeface="Be Vietnam Pro" pitchFamily="34" charset="-122"/>
+                <a:cs typeface="Be Vietnam Pro" pitchFamily="34" charset="-120"/>
+              </a:rPr>
+              <a:t> thuật</a:t>
+            </a:r>
+            <a:r>
+              <a:rPr lang="en-US" sz="2100" dirty="0" spc="1" kern="0">
+                <a:solidFill>
+                  <a:srgbClr val="C4C8D6"/>
+                </a:solidFill>
+                <a:latin typeface="Be Vietnam Pro" pitchFamily="34" charset="0"/>
+                <a:ea typeface="Be Vietnam Pro" pitchFamily="34" charset="-122"/>
+                <a:cs typeface="Be Vietnam Pro" pitchFamily="34" charset="-120"/>
+              </a:rPr>
+              <a:t> ngữ</a:t>
+            </a:r>
+            <a:r>
               <a:rPr lang="en-US" sz="2100" dirty="0" spc="0" kern="0">
                 <a:solidFill>
                   <a:srgbClr val="C4C8D6"/>
@@ -21326,10 +21128,10 @@
                 <a:ea typeface="Be Vietnam Pro" pitchFamily="34" charset="-122"/>
                 <a:cs typeface="Be Vietnam Pro" pitchFamily="34" charset="-120"/>
               </a:rPr>
-              <a:t>lịch</a:t>
-            </a:r>
-            <a:r>
-              <a:rPr lang="en-US" sz="2100" dirty="0" spc="2" kern="0">
+              <a:t> MDN,</a:t>
+            </a:r>
+            <a:r>
+              <a:rPr lang="en-US" sz="2100" dirty="0" spc="1" kern="0">
                 <a:solidFill>
                   <a:srgbClr val="C4C8D6"/>
                 </a:solidFill>
@@ -21337,10 +21139,10 @@
                 <a:ea typeface="Be Vietnam Pro" pitchFamily="34" charset="-122"/>
                 <a:cs typeface="Be Vietnam Pro" pitchFamily="34" charset="-120"/>
               </a:rPr>
-              <a:t> sử</a:t>
-            </a:r>
-            <a:r>
-              <a:rPr lang="en-US" sz="2100" dirty="0" spc="-2" kern="0">
+              <a:t> README</a:t>
+            </a:r>
+            <a:r>
+              <a:rPr lang="en-US" sz="2100" dirty="0" spc="17" kern="0">
                 <a:solidFill>
                   <a:srgbClr val="C4C8D6"/>
                 </a:solidFill>
@@ -21348,10 +21150,10 @@
                 <a:ea typeface="Be Vietnam Pro" pitchFamily="34" charset="-122"/>
                 <a:cs typeface="Be Vietnam Pro" pitchFamily="34" charset="-120"/>
               </a:rPr>
-              <a:t> phần</a:t>
-            </a:r>
-            <a:r>
-              <a:rPr lang="en-US" sz="2100" dirty="0" spc="-1" kern="0">
+              <a:t> từng</a:t>
+            </a:r>
+            <a:r>
+              <a:rPr lang="en-US" sz="2100" dirty="0" spc="-9" kern="0">
                 <a:solidFill>
                   <a:srgbClr val="C4C8D6"/>
                 </a:solidFill>
@@ -21359,10 +21161,10 @@
                 <a:ea typeface="Be Vietnam Pro" pitchFamily="34" charset="-122"/>
                 <a:cs typeface="Be Vietnam Pro" pitchFamily="34" charset="-120"/>
               </a:rPr>
-              <a:t> mềm</a:t>
-            </a:r>
-            <a:r>
-              <a:rPr lang="en-US" sz="2100" dirty="0" spc="-15" kern="0">
+              <a:t> ngôn</a:t>
+            </a:r>
+            <a:r>
+              <a:rPr lang="en-US" sz="2100" dirty="0" spc="0" kern="0">
                 <a:solidFill>
                   <a:srgbClr val="C4C8D6"/>
                 </a:solidFill>
@@ -21370,172 +21172,7 @@
                 <a:ea typeface="Be Vietnam Pro" pitchFamily="34" charset="-122"/>
                 <a:cs typeface="Be Vietnam Pro" pitchFamily="34" charset="-120"/>
               </a:rPr>
-              <a:t> trong</a:t>
-            </a:r>
-            <a:r>
-              <a:rPr lang="en-US" sz="2100" dirty="0" spc="-11" kern="0">
-                <a:solidFill>
-                  <a:srgbClr val="C4C8D6"/>
-                </a:solidFill>
-                <a:latin typeface="Be Vietnam Pro" pitchFamily="34" charset="0"/>
-                <a:ea typeface="Be Vietnam Pro" pitchFamily="34" charset="-122"/>
-                <a:cs typeface="Be Vietnam Pro" pitchFamily="34" charset="-120"/>
-              </a:rPr>
-              <a:t> tài</a:t>
-            </a:r>
-            <a:r>
-              <a:rPr lang="en-US" sz="2100" dirty="0" spc="0" kern="0">
-                <a:solidFill>
-                  <a:srgbClr val="C4C8D6"/>
-                </a:solidFill>
-                <a:latin typeface="Be Vietnam Pro" pitchFamily="34" charset="0"/>
-                <a:ea typeface="Be Vietnam Pro" pitchFamily="34" charset="-122"/>
-                <a:cs typeface="Be Vietnam Pro" pitchFamily="34" charset="-120"/>
-              </a:rPr>
-              <a:t> liệu</a:t>
-            </a:r>
-            <a:r>
-              <a:rPr lang="en-US" sz="2100" dirty="0" spc="-7" kern="0">
-                <a:solidFill>
-                  <a:srgbClr val="C4C8D6"/>
-                </a:solidFill>
-                <a:latin typeface="Be Vietnam Pro" pitchFamily="34" charset="0"/>
-                <a:ea typeface="Be Vietnam Pro" pitchFamily="34" charset="-122"/>
-                <a:cs typeface="Be Vietnam Pro" pitchFamily="34" charset="-120"/>
-              </a:rPr>
-              <a:t> giấy</a:t>
-            </a:r>
-            <a:r>
-              <a:rPr lang="en-US" sz="2100" dirty="0" spc="-2" kern="0">
-                <a:solidFill>
-                  <a:srgbClr val="C4C8D6"/>
-                </a:solidFill>
-                <a:latin typeface="Be Vietnam Pro" pitchFamily="34" charset="0"/>
-                <a:ea typeface="Be Vietnam Pro" pitchFamily="34" charset="-122"/>
-                <a:cs typeface="Be Vietnam Pro" pitchFamily="34" charset="-120"/>
-              </a:rPr>
-              <a:t> phép:</a:t>
-            </a:r>
-            <a:r>
-              <a:rPr lang="en-US" sz="2100" dirty="0" spc="-4" kern="0">
-                <a:solidFill>
-                  <a:srgbClr val="C4C8D6"/>
-                </a:solidFill>
-                <a:latin typeface="Be Vietnam Pro" pitchFamily="34" charset="0"/>
-                <a:ea typeface="Be Vietnam Pro" pitchFamily="34" charset="-122"/>
-                <a:cs typeface="Be Vietnam Pro" pitchFamily="34" charset="-120"/>
-              </a:rPr>
-              <a:t> do</a:t>
-            </a:r>
-            <a:r>
-              <a:rPr lang="en-US" sz="2100" dirty="0" spc="-2" kern="0">
-                <a:solidFill>
-                  <a:srgbClr val="C4C8D6"/>
-                </a:solidFill>
-                <a:latin typeface="Be Vietnam Pro" pitchFamily="34" charset="0"/>
-                <a:ea typeface="Be Vietnam Pro" pitchFamily="34" charset="-122"/>
-                <a:cs typeface="Be Vietnam Pro" pitchFamily="34" charset="-120"/>
-              </a:rPr>
-              <a:t> Guido</a:t>
-            </a:r>
-            <a:r>
-              <a:rPr lang="en-US" sz="2100" dirty="0" spc="-12" kern="0">
-                <a:solidFill>
-                  <a:srgbClr val="C4C8D6"/>
-                </a:solidFill>
-                <a:latin typeface="Be Vietnam Pro" pitchFamily="34" charset="0"/>
-                <a:ea typeface="Be Vietnam Pro" pitchFamily="34" charset="-122"/>
-                <a:cs typeface="Be Vietnam Pro" pitchFamily="34" charset="-120"/>
-              </a:rPr>
-              <a:t> van</a:t>
-            </a:r>
-            <a:r>
-              <a:rPr lang="en-US" sz="2100" dirty="0" spc="-14" kern="0">
-                <a:solidFill>
-                  <a:srgbClr val="C4C8D6"/>
-                </a:solidFill>
-                <a:latin typeface="Be Vietnam Pro" pitchFamily="34" charset="0"/>
-                <a:ea typeface="Be Vietnam Pro" pitchFamily="34" charset="-122"/>
-                <a:cs typeface="Be Vietnam Pro" pitchFamily="34" charset="-120"/>
-              </a:rPr>
-              <a:t> Rossum</a:t>
-            </a:r>
-            <a:r>
-              <a:rPr lang="en-US" sz="2100" dirty="0" spc="-13" kern="0">
-                <a:solidFill>
-                  <a:srgbClr val="C4C8D6"/>
-                </a:solidFill>
-                <a:latin typeface="Be Vietnam Pro" pitchFamily="34" charset="0"/>
-                <a:ea typeface="Be Vietnam Pro" pitchFamily="34" charset="-122"/>
-                <a:cs typeface="Be Vietnam Pro" pitchFamily="34" charset="-120"/>
-              </a:rPr>
-              <a:t> tạo</a:t>
-            </a:r>
-            <a:r>
-              <a:rPr lang="en-US" sz="2100" dirty="0" spc="-31" kern="0">
-                <a:solidFill>
-                  <a:srgbClr val="C4C8D6"/>
-                </a:solidFill>
-                <a:latin typeface="Be Vietnam Pro" pitchFamily="34" charset="0"/>
-                <a:ea typeface="Be Vietnam Pro" pitchFamily="34" charset="-122"/>
-                <a:cs typeface="Be Vietnam Pro" pitchFamily="34" charset="-120"/>
-              </a:rPr>
-              <a:t> ra</a:t>
-            </a:r>
-            <a:r>
-              <a:rPr lang="en-US" sz="2100" dirty="0" spc="-1" kern="0">
-                <a:solidFill>
-                  <a:srgbClr val="C4C8D6"/>
-                </a:solidFill>
-                <a:latin typeface="Be Vietnam Pro" pitchFamily="34" charset="0"/>
-                <a:ea typeface="Be Vietnam Pro" pitchFamily="34" charset="-122"/>
-                <a:cs typeface="Be Vietnam Pro" pitchFamily="34" charset="-120"/>
-              </a:rPr>
-              <a:t> từ</a:t>
-            </a:r>
-            <a:r>
-              <a:rPr lang="en-US" sz="2100" dirty="0" spc="10" kern="0">
-                <a:solidFill>
-                  <a:srgbClr val="C4C8D6"/>
-                </a:solidFill>
-                <a:latin typeface="Be Vietnam Pro" pitchFamily="34" charset="0"/>
-                <a:ea typeface="Be Vietnam Pro" pitchFamily="34" charset="-122"/>
-                <a:cs typeface="Be Vietnam Pro" pitchFamily="34" charset="-120"/>
-              </a:rPr>
-              <a:t> đầu</a:t>
-            </a:r>
-            <a:r>
-              <a:rPr lang="en-US" sz="2100" dirty="0" spc="-4" kern="0">
-                <a:solidFill>
-                  <a:srgbClr val="C4C8D6"/>
-                </a:solidFill>
-                <a:latin typeface="Be Vietnam Pro" pitchFamily="34" charset="0"/>
-                <a:ea typeface="Be Vietnam Pro" pitchFamily="34" charset="-122"/>
-                <a:cs typeface="Be Vietnam Pro" pitchFamily="34" charset="-120"/>
-              </a:rPr>
-              <a:t> thập</a:t>
-            </a:r>
-            <a:r>
-              <a:rPr lang="en-US" sz="2100" dirty="0" spc="3" kern="0">
-                <a:solidFill>
-                  <a:srgbClr val="C4C8D6"/>
-                </a:solidFill>
-                <a:latin typeface="Be Vietnam Pro" pitchFamily="34" charset="0"/>
-                <a:ea typeface="Be Vietnam Pro" pitchFamily="34" charset="-122"/>
-                <a:cs typeface="Be Vietnam Pro" pitchFamily="34" charset="-120"/>
-              </a:rPr>
-              <a:t> niên</a:t>
-            </a:r>
-            <a:r>
-              <a:rPr lang="en-US" sz="2100" dirty="0" spc="-2" kern="0">
-                <a:solidFill>
-                  <a:srgbClr val="C4C8D6"/>
-                </a:solidFill>
-                <a:latin typeface="Be Vietnam Pro" pitchFamily="34" charset="0"/>
-                <a:ea typeface="Be Vietnam Pro" pitchFamily="34" charset="-122"/>
-                <a:cs typeface="Be Vietnam Pro" pitchFamily="34" charset="-120"/>
-              </a:rPr>
-              <a:t> 1990</a:t>
+              <a:t> ngữ</a:t>
             </a:r>
             <a:endParaRPr lang="en-US" sz="2100" dirty="0"/>
           </a:p>
@@ -21610,7 +21247,7 @@
               <a:t> ngày</a:t>
             </a:r>
             <a:r>
-              <a:rPr lang="en-US" sz="2100" dirty="0" spc="-1" kern="0">
+              <a:rPr lang="en-US" sz="2100" dirty="0" spc="0" kern="0">
                 <a:solidFill>
                   <a:srgbClr val="C4C8D6"/>
                 </a:solidFill>
@@ -21618,10 +21255,10 @@
                 <a:ea typeface="Be Vietnam Pro" pitchFamily="34" charset="-122"/>
                 <a:cs typeface="Be Vietnam Pro" pitchFamily="34" charset="-120"/>
               </a:rPr>
-              <a:t> 2026-10-18.</a:t>
-            </a:r>
-            <a:r>
-              <a:rPr lang="en-US" sz="2100" dirty="0" spc="0" kern="0">
+              <a:t> 2026-10-19. Hình minh</a:t>
+            </a:r>
+            <a:r>
+              <a:rPr lang="en-US" sz="2100" dirty="0" spc="-5" kern="0">
                 <a:solidFill>
                   <a:srgbClr val="C4C8D6"/>
                 </a:solidFill>
@@ -21629,10 +21266,10 @@
                 <a:ea typeface="Be Vietnam Pro" pitchFamily="34" charset="-122"/>
                 <a:cs typeface="Be Vietnam Pro" pitchFamily="34" charset="-120"/>
               </a:rPr>
-              <a:t> Hình</a:t>
-            </a:r>
-            <a:r>
-              <a:rPr lang="en-US" sz="2100" dirty="0" spc="1" kern="0">
+              <a:t> họa</a:t>
+            </a:r>
+            <a:r>
+              <a:rPr lang="en-US" sz="2100" dirty="0" spc="-4" kern="0">
                 <a:solidFill>
                   <a:srgbClr val="C4C8D6"/>
                 </a:solidFill>
@@ -21640,10 +21277,10 @@
                 <a:ea typeface="Be Vietnam Pro" pitchFamily="34" charset="-122"/>
                 <a:cs typeface="Be Vietnam Pro" pitchFamily="34" charset="-120"/>
               </a:rPr>
-              <a:t> minh</a:t>
-            </a:r>
-            <a:r>
-              <a:rPr lang="en-US" sz="2100" dirty="0" spc="-6" kern="0">
+              <a:t> là</a:t>
+            </a:r>
+            <a:r>
+              <a:rPr lang="en-US" sz="2100" dirty="0" spc="-3" kern="0">
                 <a:solidFill>
                   <a:srgbClr val="C4C8D6"/>
                 </a:solidFill>
@@ -21651,32 +21288,10 @@
                 <a:ea typeface="Be Vietnam Pro" pitchFamily="34" charset="-122"/>
                 <a:cs typeface="Be Vietnam Pro" pitchFamily="34" charset="-120"/>
               </a:rPr>
-              <a:t> họa</a:t>
-            </a:r>
-            <a:r>
-              <a:rPr lang="en-US" sz="2100" dirty="0" spc="-3" kern="0">
-                <a:solidFill>
-                  <a:srgbClr val="C4C8D6"/>
-                </a:solidFill>
-                <a:latin typeface="Be Vietnam Pro" pitchFamily="34" charset="0"/>
-                <a:ea typeface="Be Vietnam Pro" pitchFamily="34" charset="-122"/>
-                <a:cs typeface="Be Vietnam Pro" pitchFamily="34" charset="-120"/>
-              </a:rPr>
-              <a:t> là</a:t>
-            </a:r>
-            <a:r>
-              <a:rPr lang="en-US" sz="2100" dirty="0" spc="-4" kern="0">
-                <a:solidFill>
-                  <a:srgbClr val="C4C8D6"/>
-                </a:solidFill>
-                <a:latin typeface="Be Vietnam Pro" pitchFamily="34" charset="0"/>
-                <a:ea typeface="Be Vietnam Pro" pitchFamily="34" charset="-122"/>
-                <a:cs typeface="Be Vietnam Pro" pitchFamily="34" charset="-120"/>
-              </a:rPr>
               <a:t> thiết</a:t>
             </a:r>
             <a:r>
-              <a:rPr lang="en-US" sz="2100" dirty="0" spc="-30" kern="0">
+              <a:rPr lang="en-US" sz="2100" dirty="0" spc="-31" kern="0">
                 <a:solidFill>
                   <a:srgbClr val="C4C8D6"/>
                 </a:solidFill>

</xml_diff>

<commit_message>
Lessons sd-10-017, 020: qualify the provenance claims on the decks' sources slides to match the lessons
Co-Authored-By: Claude Sonnet 5.5 <noreply@anthropic.com>
Claude-Session: https://claude.ai/code/session_011dmt3ZFdN8sjiTfDnyUVN7
</commit_message>
<xml_diff>
--- a/system-design-101/vi/lessons/sd-10-017/slides/sd-10-017.pptx
+++ b/system-design-101/vi/lessons/sd-10-017/slides/sd-10-017.pptx
@@ -15846,6 +15846,28 @@
               <a:buNone/>
             </a:pPr>
             <a:r>
+              <a:rPr lang="en-US" sz="2550" dirty="0" spc="-4" kern="0">
+                <a:solidFill>
+                  <a:srgbClr val="F3EEE3"/>
+                </a:solidFill>
+                <a:latin typeface="Be Vietnam Pro" pitchFamily="34" charset="0"/>
+                <a:ea typeface="Be Vietnam Pro" pitchFamily="34" charset="-122"/>
+                <a:cs typeface="Be Vietnam Pro" pitchFamily="34" charset="-120"/>
+              </a:rPr>
+              <a:t>Mốc</a:t>
+            </a:r>
+            <a:r>
+              <a:rPr lang="en-US" sz="2550" dirty="0" spc="-18" kern="0">
+                <a:solidFill>
+                  <a:srgbClr val="F3EEE3"/>
+                </a:solidFill>
+                <a:latin typeface="Be Vietnam Pro" pitchFamily="34" charset="0"/>
+                <a:ea typeface="Be Vietnam Pro" pitchFamily="34" charset="-122"/>
+                <a:cs typeface="Be Vietnam Pro" pitchFamily="34" charset="-120"/>
+              </a:rPr>
+              <a:t> và</a:t>
+            </a:r>
+            <a:r>
               <a:rPr lang="en-US" sz="2550" dirty="0" spc="-1" kern="0">
                 <a:solidFill>
                   <a:srgbClr val="F3EEE3"/>
@@ -15854,7 +15876,40 @@
                 <a:ea typeface="Be Vietnam Pro" pitchFamily="34" charset="-122"/>
                 <a:cs typeface="Be Vietnam Pro" pitchFamily="34" charset="-120"/>
               </a:rPr>
-              <a:t>Mọi</a:t>
+              <a:t> nhận</a:t>
+            </a:r>
+            <a:r>
+              <a:rPr lang="en-US" sz="2550" dirty="0" spc="21" kern="0">
+                <a:solidFill>
+                  <a:srgbClr val="F3EEE3"/>
+                </a:solidFill>
+                <a:latin typeface="Be Vietnam Pro" pitchFamily="34" charset="0"/>
+                <a:ea typeface="Be Vietnam Pro" pitchFamily="34" charset="-122"/>
+                <a:cs typeface="Be Vietnam Pro" pitchFamily="34" charset="-120"/>
+              </a:rPr>
+              <a:t> định</a:t>
+            </a:r>
+            <a:r>
+              <a:rPr lang="en-US" sz="2550" dirty="0" spc="1" kern="0">
+                <a:solidFill>
+                  <a:srgbClr val="F3EEE3"/>
+                </a:solidFill>
+                <a:latin typeface="Be Vietnam Pro" pitchFamily="34" charset="0"/>
+                <a:ea typeface="Be Vietnam Pro" pitchFamily="34" charset="-122"/>
+                <a:cs typeface="Be Vietnam Pro" pitchFamily="34" charset="-120"/>
+              </a:rPr>
+              <a:t> khác</a:t>
+            </a:r>
+            <a:r>
+              <a:rPr lang="en-US" sz="2550" dirty="0" spc="0" kern="0">
+                <a:solidFill>
+                  <a:srgbClr val="F3EEE3"/>
+                </a:solidFill>
+                <a:latin typeface="Be Vietnam Pro" pitchFamily="34" charset="0"/>
+                <a:ea typeface="Be Vietnam Pro" pitchFamily="34" charset="-122"/>
+                <a:cs typeface="Be Vietnam Pro" pitchFamily="34" charset="-120"/>
+              </a:rPr>
+              <a:t> là lời</a:t>
             </a:r>
             <a:r>
               <a:rPr lang="en-US" sz="2550" dirty="0" spc="-2" kern="0">
@@ -15865,7 +15920,117 @@
                 <a:ea typeface="Be Vietnam Pro" pitchFamily="34" charset="-122"/>
                 <a:cs typeface="Be Vietnam Pro" pitchFamily="34" charset="-120"/>
               </a:rPr>
-              <a:t> mốc,</a:t>
+              <a:t> của</a:t>
+            </a:r>
+            <a:r>
+              <a:rPr lang="en-US" sz="2550" dirty="0" spc="0" kern="0">
+                <a:solidFill>
+                  <a:srgbClr val="F3EEE3"/>
+                </a:solidFill>
+                <a:latin typeface="Be Vietnam Pro" pitchFamily="34" charset="0"/>
+                <a:ea typeface="Be Vietnam Pro" pitchFamily="34" charset="-122"/>
+                <a:cs typeface="Be Vietnam Pro" pitchFamily="34" charset="-120"/>
+              </a:rPr>
+              <a:t> nguồn,</a:t>
+            </a:r>
+            <a:r>
+              <a:rPr lang="en-US" sz="2550" dirty="0" spc="7" kern="0">
+                <a:solidFill>
+                  <a:srgbClr val="F3EEE3"/>
+                </a:solidFill>
+                <a:latin typeface="Be Vietnam Pro" pitchFamily="34" charset="0"/>
+                <a:ea typeface="Be Vietnam Pro" pitchFamily="34" charset="-122"/>
+                <a:cs typeface="Be Vietnam Pro" pitchFamily="34" charset="-120"/>
+              </a:rPr>
+              <a:t> chưa</a:t>
+            </a:r>
+            <a:r>
+              <a:rPr lang="en-US" sz="2550" dirty="0" spc="1" kern="0">
+                <a:solidFill>
+                  <a:srgbClr val="F3EEE3"/>
+                </a:solidFill>
+                <a:latin typeface="Be Vietnam Pro" pitchFamily="34" charset="0"/>
+                <a:ea typeface="Be Vietnam Pro" pitchFamily="34" charset="-122"/>
+                <a:cs typeface="Be Vietnam Pro" pitchFamily="34" charset="-120"/>
+              </a:rPr>
+              <a:t> kiểm</a:t>
+            </a:r>
+            <a:r>
+              <a:rPr lang="en-US" sz="2550" dirty="0" spc="-21" kern="0">
+                <a:solidFill>
+                  <a:srgbClr val="F3EEE3"/>
+                </a:solidFill>
+                <a:latin typeface="Be Vietnam Pro" pitchFamily="34" charset="0"/>
+                <a:ea typeface="Be Vietnam Pro" pitchFamily="34" charset="-122"/>
+                <a:cs typeface="Be Vietnam Pro" pitchFamily="34" charset="-120"/>
+              </a:rPr>
+              <a:t> tra;</a:t>
+            </a:r>
+            <a:r>
+              <a:rPr lang="en-US" sz="2550" dirty="0" spc="1" kern="0">
+                <a:solidFill>
+                  <a:srgbClr val="F3EEE3"/>
+                </a:solidFill>
+                <a:latin typeface="Be Vietnam Pro" pitchFamily="34" charset="0"/>
+                <a:ea typeface="Be Vietnam Pro" pitchFamily="34" charset="-122"/>
+                <a:cs typeface="Be Vietnam Pro" pitchFamily="34" charset="-120"/>
+              </a:rPr>
+              <a:t> mô</a:t>
+            </a:r>
+            <a:r>
+              <a:rPr lang="en-US" sz="2550" dirty="0" spc="-16" kern="0">
+                <a:solidFill>
+                  <a:srgbClr val="F3EEE3"/>
+                </a:solidFill>
+                <a:latin typeface="Be Vietnam Pro" pitchFamily="34" charset="0"/>
+                <a:ea typeface="Be Vietnam Pro" pitchFamily="34" charset="-122"/>
+                <a:cs typeface="Be Vietnam Pro" pitchFamily="34" charset="-120"/>
+              </a:rPr>
+              <a:t> tả</a:t>
+            </a:r>
+            <a:r>
+              <a:rPr lang="en-US" sz="2550" dirty="0" spc="-10" kern="0">
+                <a:solidFill>
+                  <a:srgbClr val="F3EEE3"/>
+                </a:solidFill>
+                <a:latin typeface="Be Vietnam Pro" pitchFamily="34" charset="0"/>
+                <a:ea typeface="Be Vietnam Pro" pitchFamily="34" charset="-122"/>
+                <a:cs typeface="Be Vietnam Pro" pitchFamily="34" charset="-120"/>
+              </a:rPr>
+              <a:t> ngôn</a:t>
+            </a:r>
+            <a:r>
+              <a:rPr lang="en-US" sz="2550" dirty="0" spc="-2" kern="0">
+                <a:solidFill>
+                  <a:srgbClr val="F3EEE3"/>
+                </a:solidFill>
+                <a:latin typeface="Be Vietnam Pro" pitchFamily="34" charset="0"/>
+                <a:ea typeface="Be Vietnam Pro" pitchFamily="34" charset="-122"/>
+                <a:cs typeface="Be Vietnam Pro" pitchFamily="34" charset="-120"/>
+              </a:rPr>
+              <a:t> ngữ</a:t>
+            </a:r>
+            <a:r>
+              <a:rPr lang="en-US" sz="2550" dirty="0" spc="10" kern="0">
+                <a:solidFill>
+                  <a:srgbClr val="F3EEE3"/>
+                </a:solidFill>
+                <a:latin typeface="Be Vietnam Pro" pitchFamily="34" charset="0"/>
+                <a:ea typeface="Be Vietnam Pro" pitchFamily="34" charset="-122"/>
+                <a:cs typeface="Be Vietnam Pro" pitchFamily="34" charset="-120"/>
+              </a:rPr>
+              <a:t> đọc</a:t>
+            </a:r>
+            <a:r>
+              <a:rPr lang="en-US" sz="2550" dirty="0" spc="-1" kern="0">
+                <a:solidFill>
+                  <a:srgbClr val="F3EEE3"/>
+                </a:solidFill>
+                <a:latin typeface="Be Vietnam Pro" pitchFamily="34" charset="0"/>
+                <a:ea typeface="Be Vietnam Pro" pitchFamily="34" charset="-122"/>
+                <a:cs typeface="Be Vietnam Pro" pitchFamily="34" charset="-120"/>
+              </a:rPr>
+              <a:t> từ</a:t>
             </a:r>
             <a:r>
               <a:rPr lang="en-US" sz="2550" dirty="0" spc="-12" kern="0">
@@ -15876,10 +16041,10 @@
                 <a:ea typeface="Be Vietnam Pro" pitchFamily="34" charset="-122"/>
                 <a:cs typeface="Be Vietnam Pro" pitchFamily="34" charset="-120"/>
               </a:rPr>
-              <a:t> tên</a:t>
-            </a:r>
-            <a:r>
-              <a:rPr lang="en-US" sz="2550" dirty="0" spc="-19" kern="0">
+              <a:t> tài</a:t>
+            </a:r>
+            <a:r>
+              <a:rPr lang="en-US" sz="2550" dirty="0" spc="1" kern="0">
                 <a:solidFill>
                   <a:srgbClr val="F3EEE3"/>
                 </a:solidFill>
@@ -15887,10 +16052,10 @@
                 <a:ea typeface="Be Vietnam Pro" pitchFamily="34" charset="-122"/>
                 <a:cs typeface="Be Vietnam Pro" pitchFamily="34" charset="-120"/>
               </a:rPr>
-              <a:t> và</a:t>
-            </a:r>
-            <a:r>
-              <a:rPr lang="en-US" sz="2550" dirty="0" spc="0" kern="0">
+              <a:t> liệu</a:t>
+            </a:r>
+            <a:r>
+              <a:rPr lang="en-US" sz="2550" dirty="0" spc="-1" kern="0">
                 <a:solidFill>
                   <a:srgbClr val="F3EEE3"/>
                 </a:solidFill>
@@ -15898,10 +16063,10 @@
                 <a:ea typeface="Be Vietnam Pro" pitchFamily="34" charset="-122"/>
                 <a:cs typeface="Be Vietnam Pro" pitchFamily="34" charset="-120"/>
               </a:rPr>
-              <a:t> nhận</a:t>
-            </a:r>
-            <a:r>
-              <a:rPr lang="en-US" sz="2550" dirty="0" spc="20" kern="0">
+              <a:t> dự</a:t>
+            </a:r>
+            <a:r>
+              <a:rPr lang="en-US" sz="2550" dirty="0" spc="1" kern="0">
                 <a:solidFill>
                   <a:srgbClr val="F3EEE3"/>
                 </a:solidFill>
@@ -15909,95 +16074,7 @@
                 <a:ea typeface="Be Vietnam Pro" pitchFamily="34" charset="-122"/>
                 <a:cs typeface="Be Vietnam Pro" pitchFamily="34" charset="-120"/>
               </a:rPr>
-              <a:t> định</a:t>
-            </a:r>
-            <a:r>
-              <a:rPr lang="en-US" sz="2550" dirty="0" spc="0" kern="0">
-                <a:solidFill>
-                  <a:srgbClr val="F3EEE3"/>
-                </a:solidFill>
-                <a:latin typeface="Be Vietnam Pro" pitchFamily="34" charset="0"/>
-                <a:ea typeface="Be Vietnam Pro" pitchFamily="34" charset="-122"/>
-                <a:cs typeface="Be Vietnam Pro" pitchFamily="34" charset="-120"/>
-              </a:rPr>
-              <a:t> còn lại</a:t>
-            </a:r>
-            <a:r>
-              <a:rPr lang="en-US" sz="2550" dirty="0" spc="1" kern="0">
-                <a:solidFill>
-                  <a:srgbClr val="F3EEE3"/>
-                </a:solidFill>
-                <a:latin typeface="Be Vietnam Pro" pitchFamily="34" charset="0"/>
-                <a:ea typeface="Be Vietnam Pro" pitchFamily="34" charset="-122"/>
-                <a:cs typeface="Be Vietnam Pro" pitchFamily="34" charset="-120"/>
-              </a:rPr>
-              <a:t> là</a:t>
-            </a:r>
-            <a:r>
-              <a:rPr lang="en-US" sz="2550" dirty="0" spc="-1" kern="0">
-                <a:solidFill>
-                  <a:srgbClr val="F3EEE3"/>
-                </a:solidFill>
-                <a:latin typeface="Be Vietnam Pro" pitchFamily="34" charset="0"/>
-                <a:ea typeface="Be Vietnam Pro" pitchFamily="34" charset="-122"/>
-                <a:cs typeface="Be Vietnam Pro" pitchFamily="34" charset="-120"/>
-              </a:rPr>
-              <a:t> lời của</a:t>
-            </a:r>
-            <a:r>
-              <a:rPr lang="en-US" sz="2550" dirty="0" spc="0" kern="0">
-                <a:solidFill>
-                  <a:srgbClr val="F3EEE3"/>
-                </a:solidFill>
-                <a:latin typeface="Be Vietnam Pro" pitchFamily="34" charset="0"/>
-                <a:ea typeface="Be Vietnam Pro" pitchFamily="34" charset="-122"/>
-                <a:cs typeface="Be Vietnam Pro" pitchFamily="34" charset="-120"/>
-              </a:rPr>
-              <a:t> nguồn,</a:t>
-            </a:r>
-            <a:r>
-              <a:rPr lang="en-US" sz="2550" dirty="0" spc="-3" kern="0">
-                <a:solidFill>
-                  <a:srgbClr val="F3EEE3"/>
-                </a:solidFill>
-                <a:latin typeface="Be Vietnam Pro" pitchFamily="34" charset="0"/>
-                <a:ea typeface="Be Vietnam Pro" pitchFamily="34" charset="-122"/>
-                <a:cs typeface="Be Vietnam Pro" pitchFamily="34" charset="-120"/>
-              </a:rPr>
-              <a:t> bài</a:t>
-            </a:r>
-            <a:r>
-              <a:rPr lang="en-US" sz="2550" dirty="0" spc="6" kern="0">
-                <a:solidFill>
-                  <a:srgbClr val="F3EEE3"/>
-                </a:solidFill>
-                <a:latin typeface="Be Vietnam Pro" pitchFamily="34" charset="0"/>
-                <a:ea typeface="Be Vietnam Pro" pitchFamily="34" charset="-122"/>
-                <a:cs typeface="Be Vietnam Pro" pitchFamily="34" charset="-120"/>
-              </a:rPr>
-              <a:t> chưa</a:t>
-            </a:r>
-            <a:r>
-              <a:rPr lang="en-US" sz="2550" dirty="0" spc="1" kern="0">
-                <a:solidFill>
-                  <a:srgbClr val="F3EEE3"/>
-                </a:solidFill>
-                <a:latin typeface="Be Vietnam Pro" pitchFamily="34" charset="0"/>
-                <a:ea typeface="Be Vietnam Pro" pitchFamily="34" charset="-122"/>
-                <a:cs typeface="Be Vietnam Pro" pitchFamily="34" charset="-120"/>
-              </a:rPr>
-              <a:t> kiểm</a:t>
-            </a:r>
-            <a:r>
-              <a:rPr lang="en-US" sz="2550" dirty="0" spc="-19" kern="0">
-                <a:solidFill>
-                  <a:srgbClr val="F3EEE3"/>
-                </a:solidFill>
-                <a:latin typeface="Be Vietnam Pro" pitchFamily="34" charset="0"/>
-                <a:ea typeface="Be Vietnam Pro" pitchFamily="34" charset="-122"/>
-                <a:cs typeface="Be Vietnam Pro" pitchFamily="34" charset="-120"/>
-              </a:rPr>
-              <a:t> tra.</a:t>
+              <a:t> án.</a:t>
             </a:r>
             <a:endParaRPr lang="en-US" sz="2550" dirty="0"/>
           </a:p>

</xml_diff>

<commit_message>
Lesson sd-10-017: say the 2010s grouping is the source's and that Go and Carbon fall outside it, in the lesson, figure, metadata and deck
Co-Authored-By: Claude Sonnet 5.5 <noreply@anthropic.com>
Claude-Session: https://claude.ai/code/session_011dmt3ZFdN8sjiTfDnyUVN7
</commit_message>
<xml_diff>
--- a/system-design-101/vi/lessons/sd-10-017/slides/sd-10-017.pptx
+++ b/system-design-101/vi/lessons/sd-10-017/slides/sd-10-017.pptx
@@ -13000,6 +13000,28 @@
               <a:t> C#.</a:t>
             </a:r>
             <a:r>
+              <a:rPr lang="en-US" sz="2850" dirty="0" spc="-1" kern="0">
+                <a:solidFill>
+                  <a:srgbClr val="14161C"/>
+                </a:solidFill>
+                <a:latin typeface="Be Vietnam Pro" pitchFamily="34" charset="0"/>
+                <a:ea typeface="Be Vietnam Pro" pitchFamily="34" charset="-122"/>
+                <a:cs typeface="Be Vietnam Pro" pitchFamily="34" charset="-120"/>
+              </a:rPr>
+              <a:t> Nguồn</a:t>
+            </a:r>
+            <a:r>
+              <a:rPr lang="en-US" sz="2850" dirty="0" spc="-21" kern="0">
+                <a:solidFill>
+                  <a:srgbClr val="14161C"/>
+                </a:solidFill>
+                <a:latin typeface="Be Vietnam Pro" pitchFamily="34" charset="0"/>
+                <a:ea typeface="Be Vietnam Pro" pitchFamily="34" charset="-122"/>
+                <a:cs typeface="Be Vietnam Pro" pitchFamily="34" charset="-120"/>
+              </a:rPr>
+              <a:t> xếp</a:t>
+            </a:r>
+            <a:r>
               <a:rPr lang="en-US" sz="2850" dirty="0" spc="0" kern="0">
                 <a:solidFill>
                   <a:srgbClr val="14161C"/>
@@ -13008,7 +13030,62 @@
                 <a:ea typeface="Be Vietnam Pro" pitchFamily="34" charset="-122"/>
                 <a:cs typeface="Be Vietnam Pro" pitchFamily="34" charset="-120"/>
               </a:rPr>
-              <a:t> Thập niên</a:t>
+              <a:t> nhiều</a:t>
+            </a:r>
+            <a:r>
+              <a:rPr lang="en-US" sz="2850" dirty="0" spc="-13" kern="0">
+                <a:solidFill>
+                  <a:srgbClr val="14161C"/>
+                </a:solidFill>
+                <a:latin typeface="Be Vietnam Pro" pitchFamily="34" charset="0"/>
+                <a:ea typeface="Be Vietnam Pro" pitchFamily="34" charset="-122"/>
+                <a:cs typeface="Be Vietnam Pro" pitchFamily="34" charset="-120"/>
+              </a:rPr>
+              <a:t> ngôn</a:t>
+            </a:r>
+            <a:r>
+              <a:rPr lang="en-US" sz="2850" dirty="0" spc="-2" kern="0">
+                <a:solidFill>
+                  <a:srgbClr val="14161C"/>
+                </a:solidFill>
+                <a:latin typeface="Be Vietnam Pro" pitchFamily="34" charset="0"/>
+                <a:ea typeface="Be Vietnam Pro" pitchFamily="34" charset="-122"/>
+                <a:cs typeface="Be Vietnam Pro" pitchFamily="34" charset="-120"/>
+              </a:rPr>
+              <a:t> ngữ</a:t>
+            </a:r>
+            <a:r>
+              <a:rPr lang="en-US" sz="2850" dirty="0" spc="-11" kern="0">
+                <a:solidFill>
+                  <a:srgbClr val="14161C"/>
+                </a:solidFill>
+                <a:latin typeface="Be Vietnam Pro" pitchFamily="34" charset="0"/>
+                <a:ea typeface="Be Vietnam Pro" pitchFamily="34" charset="-122"/>
+                <a:cs typeface="Be Vietnam Pro" pitchFamily="34" charset="-120"/>
+              </a:rPr>
+              <a:t> vào</a:t>
+            </a:r>
+            <a:r>
+              <a:rPr lang="en-US" sz="2850" dirty="0" spc="-2" kern="0">
+                <a:solidFill>
+                  <a:srgbClr val="14161C"/>
+                </a:solidFill>
+                <a:latin typeface="Be Vietnam Pro" pitchFamily="34" charset="0"/>
+                <a:ea typeface="Be Vietnam Pro" pitchFamily="34" charset="-122"/>
+                <a:cs typeface="Be Vietnam Pro" pitchFamily="34" charset="-120"/>
+              </a:rPr>
+              <a:t> thập</a:t>
+            </a:r>
+            <a:r>
+              <a:rPr lang="en-US" sz="2850" dirty="0" spc="0" kern="0">
+                <a:solidFill>
+                  <a:srgbClr val="14161C"/>
+                </a:solidFill>
+                <a:latin typeface="Be Vietnam Pro" pitchFamily="34" charset="0"/>
+                <a:ea typeface="Be Vietnam Pro" pitchFamily="34" charset="-122"/>
+                <a:cs typeface="Be Vietnam Pro" pitchFamily="34" charset="-120"/>
+              </a:rPr>
+              <a:t> niên</a:t>
             </a:r>
             <a:r>
               <a:rPr lang="en-US" sz="2850" dirty="0" spc="2" kern="0">
@@ -13019,29 +13096,62 @@
                 <a:ea typeface="Be Vietnam Pro" pitchFamily="34" charset="-122"/>
                 <a:cs typeface="Be Vietnam Pro" pitchFamily="34" charset="-120"/>
               </a:rPr>
-              <a:t> 2010</a:t>
-            </a:r>
-            <a:r>
-              <a:rPr lang="en-US" sz="2850" dirty="0" spc="0" kern="0">
-                <a:solidFill>
-                  <a:srgbClr val="14161C"/>
-                </a:solidFill>
-                <a:latin typeface="Be Vietnam Pro" pitchFamily="34" charset="0"/>
-                <a:ea typeface="Be Vietnam Pro" pitchFamily="34" charset="-122"/>
-                <a:cs typeface="Be Vietnam Pro" pitchFamily="34" charset="-120"/>
-              </a:rPr>
-              <a:t> có nhiều</a:t>
-            </a:r>
-            <a:r>
-              <a:rPr lang="en-US" sz="2850" dirty="0" spc="-14" kern="0">
-                <a:solidFill>
-                  <a:srgbClr val="14161C"/>
-                </a:solidFill>
-                <a:latin typeface="Be Vietnam Pro" pitchFamily="34" charset="0"/>
-                <a:ea typeface="Be Vietnam Pro" pitchFamily="34" charset="-122"/>
-                <a:cs typeface="Be Vietnam Pro" pitchFamily="34" charset="-120"/>
-              </a:rPr>
-              <a:t> ngôn</a:t>
+              <a:t> 2010;</a:t>
+            </a:r>
+            <a:r>
+              <a:rPr lang="en-US" sz="2850" dirty="0" spc="1" kern="0">
+                <a:solidFill>
+                  <a:srgbClr val="14161C"/>
+                </a:solidFill>
+                <a:latin typeface="Be Vietnam Pro" pitchFamily="34" charset="0"/>
+                <a:ea typeface="Be Vietnam Pro" pitchFamily="34" charset="-122"/>
+                <a:cs typeface="Be Vietnam Pro" pitchFamily="34" charset="-120"/>
+              </a:rPr>
+              <a:t> Go</a:t>
+            </a:r>
+            <a:r>
+              <a:rPr lang="en-US" sz="2850" dirty="0" spc="3" kern="0">
+                <a:solidFill>
+                  <a:srgbClr val="14161C"/>
+                </a:solidFill>
+                <a:latin typeface="Be Vietnam Pro" pitchFamily="34" charset="0"/>
+                <a:ea typeface="Be Vietnam Pro" pitchFamily="34" charset="-122"/>
+                <a:cs typeface="Be Vietnam Pro" pitchFamily="34" charset="-120"/>
+              </a:rPr>
+              <a:t> (2009)</a:t>
+            </a:r>
+            <a:r>
+              <a:rPr lang="en-US" sz="2850" dirty="0" spc="-17" kern="0">
+                <a:solidFill>
+                  <a:srgbClr val="14161C"/>
+                </a:solidFill>
+                <a:latin typeface="Be Vietnam Pro" pitchFamily="34" charset="0"/>
+                <a:ea typeface="Be Vietnam Pro" pitchFamily="34" charset="-122"/>
+                <a:cs typeface="Be Vietnam Pro" pitchFamily="34" charset="-120"/>
+              </a:rPr>
+              <a:t> và</a:t>
+            </a:r>
+            <a:r>
+              <a:rPr lang="en-US" sz="2850" dirty="0" spc="-1" kern="0">
+                <a:solidFill>
+                  <a:srgbClr val="14161C"/>
+                </a:solidFill>
+                <a:latin typeface="Be Vietnam Pro" pitchFamily="34" charset="0"/>
+                <a:ea typeface="Be Vietnam Pro" pitchFamily="34" charset="-122"/>
+                <a:cs typeface="Be Vietnam Pro" pitchFamily="34" charset="-120"/>
+              </a:rPr>
+              <a:t> Carbon</a:t>
+            </a:r>
+            <a:r>
+              <a:rPr lang="en-US" sz="2850" dirty="0" spc="3" kern="0">
+                <a:solidFill>
+                  <a:srgbClr val="14161C"/>
+                </a:solidFill>
+                <a:latin typeface="Be Vietnam Pro" pitchFamily="34" charset="0"/>
+                <a:ea typeface="Be Vietnam Pro" pitchFamily="34" charset="-122"/>
+                <a:cs typeface="Be Vietnam Pro" pitchFamily="34" charset="-120"/>
+              </a:rPr>
+              <a:t> (2022)</a:t>
             </a:r>
             <a:r>
               <a:rPr lang="en-US" sz="2850" dirty="0" spc="-2" kern="0">
@@ -13052,84 +13162,18 @@
                 <a:ea typeface="Be Vietnam Pro" pitchFamily="34" charset="-122"/>
                 <a:cs typeface="Be Vietnam Pro" pitchFamily="34" charset="-120"/>
               </a:rPr>
-              <a:t> ngữ</a:t>
-            </a:r>
-            <a:r>
-              <a:rPr lang="en-US" sz="2850" dirty="0" spc="0" kern="0">
-                <a:solidFill>
-                  <a:srgbClr val="14161C"/>
-                </a:solidFill>
-                <a:latin typeface="Be Vietnam Pro" pitchFamily="34" charset="0"/>
-                <a:ea typeface="Be Vietnam Pro" pitchFamily="34" charset="-122"/>
-                <a:cs typeface="Be Vietnam Pro" pitchFamily="34" charset="-120"/>
-              </a:rPr>
-              <a:t> mới; mỗi</a:t>
-            </a:r>
-            <a:r>
-              <a:rPr lang="en-US" sz="2850" dirty="0" spc="-1" kern="0">
-                <a:solidFill>
-                  <a:srgbClr val="14161C"/>
-                </a:solidFill>
-                <a:latin typeface="Be Vietnam Pro" pitchFamily="34" charset="0"/>
-                <a:ea typeface="Be Vietnam Pro" pitchFamily="34" charset="-122"/>
-                <a:cs typeface="Be Vietnam Pro" pitchFamily="34" charset="-120"/>
-              </a:rPr>
-              <a:t> dự</a:t>
-            </a:r>
-            <a:r>
-              <a:rPr lang="en-US" sz="2850" dirty="0" spc="0" kern="0">
-                <a:solidFill>
-                  <a:srgbClr val="14161C"/>
-                </a:solidFill>
-                <a:latin typeface="Be Vietnam Pro" pitchFamily="34" charset="0"/>
-                <a:ea typeface="Be Vietnam Pro" pitchFamily="34" charset="-122"/>
-                <a:cs typeface="Be Vietnam Pro" pitchFamily="34" charset="-120"/>
-              </a:rPr>
-              <a:t> án</a:t>
-            </a:r>
-            <a:r>
-              <a:rPr lang="en-US" sz="2850" dirty="0" spc="-1" kern="0">
-                <a:solidFill>
-                  <a:srgbClr val="14161C"/>
-                </a:solidFill>
-                <a:latin typeface="Be Vietnam Pro" pitchFamily="34" charset="0"/>
-                <a:ea typeface="Be Vietnam Pro" pitchFamily="34" charset="-122"/>
-                <a:cs typeface="Be Vietnam Pro" pitchFamily="34" charset="-120"/>
-              </a:rPr>
-              <a:t> tự</a:t>
-            </a:r>
-            <a:r>
-              <a:rPr lang="en-US" sz="2850" dirty="0" spc="0" kern="0">
-                <a:solidFill>
-                  <a:srgbClr val="14161C"/>
-                </a:solidFill>
-                <a:latin typeface="Be Vietnam Pro" pitchFamily="34" charset="0"/>
-                <a:ea typeface="Be Vietnam Pro" pitchFamily="34" charset="-122"/>
-                <a:cs typeface="Be Vietnam Pro" pitchFamily="34" charset="-120"/>
-              </a:rPr>
-              <a:t> nêu</a:t>
-            </a:r>
-            <a:r>
-              <a:rPr lang="en-US" sz="2850" dirty="0" spc="-1" kern="0">
-                <a:solidFill>
-                  <a:srgbClr val="14161C"/>
-                </a:solidFill>
-                <a:latin typeface="Be Vietnam Pro" pitchFamily="34" charset="0"/>
-                <a:ea typeface="Be Vietnam Pro" pitchFamily="34" charset="-122"/>
-                <a:cs typeface="Be Vietnam Pro" pitchFamily="34" charset="-120"/>
-              </a:rPr>
-              <a:t> mục</a:t>
-            </a:r>
-            <a:r>
-              <a:rPr lang="en-US" sz="2850" dirty="0" spc="0" kern="0">
-                <a:solidFill>
-                  <a:srgbClr val="14161C"/>
-                </a:solidFill>
-                <a:latin typeface="Be Vietnam Pro" pitchFamily="34" charset="0"/>
-                <a:ea typeface="Be Vietnam Pro" pitchFamily="34" charset="-122"/>
-                <a:cs typeface="Be Vietnam Pro" pitchFamily="34" charset="-120"/>
-              </a:rPr>
-              <a:t> tiêu.</a:t>
+              <a:t> lệch</a:t>
+            </a:r>
+            <a:r>
+              <a:rPr lang="en-US" sz="2850" dirty="0" spc="-4" kern="0">
+                <a:solidFill>
+                  <a:srgbClr val="14161C"/>
+                </a:solidFill>
+                <a:latin typeface="Be Vietnam Pro" pitchFamily="34" charset="0"/>
+                <a:ea typeface="Be Vietnam Pro" pitchFamily="34" charset="-122"/>
+                <a:cs typeface="Be Vietnam Pro" pitchFamily="34" charset="-120"/>
+              </a:rPr>
+              <a:t> mốc.</a:t>
             </a:r>
             <a:endParaRPr lang="en-US" sz="2850" dirty="0"/>
           </a:p>
@@ -13683,7 +13727,7 @@
               <a:buNone/>
             </a:pPr>
             <a:r>
-              <a:rPr lang="en-US" sz="4200" dirty="0" spc="2" kern="0">
+              <a:rPr lang="en-US" sz="4200" dirty="0" spc="-29" kern="0">
                 <a:solidFill>
                   <a:srgbClr val="0F766E"/>
                 </a:solidFill>
@@ -13691,10 +13735,10 @@
                 <a:ea typeface="Bricolage Grotesque ExtraBold" pitchFamily="34" charset="-122"/>
                 <a:cs typeface="Bricolage Grotesque ExtraBold" pitchFamily="34" charset="-120"/>
               </a:rPr>
-              <a:t>Thập</a:t>
-            </a:r>
-            <a:r>
-              <a:rPr lang="en-US" sz="4200" dirty="0" spc="1" kern="0">
+              <a:t>2010,</a:t>
+            </a:r>
+            <a:r>
+              <a:rPr lang="en-US" sz="4200" dirty="0" spc="-1" kern="0">
                 <a:solidFill>
                   <a:srgbClr val="0F766E"/>
                 </a:solidFill>
@@ -13702,10 +13746,10 @@
                 <a:ea typeface="Bricolage Grotesque ExtraBold" pitchFamily="34" charset="-122"/>
                 <a:cs typeface="Bricolage Grotesque ExtraBold" pitchFamily="34" charset="-120"/>
               </a:rPr>
-              <a:t> niên</a:t>
-            </a:r>
-            <a:r>
-              <a:rPr lang="en-US" sz="4200" dirty="0" spc="-8" kern="0">
+              <a:t> theo</a:t>
+            </a:r>
+            <a:r>
+              <a:rPr lang="en-US" sz="4200" dirty="0" spc="0" kern="0">
                 <a:solidFill>
                   <a:srgbClr val="0F766E"/>
                 </a:solidFill>
@@ -13713,7 +13757,7 @@
                 <a:ea typeface="Bricolage Grotesque ExtraBold" pitchFamily="34" charset="-122"/>
                 <a:cs typeface="Bricolage Grotesque ExtraBold" pitchFamily="34" charset="-120"/>
               </a:rPr>
-              <a:t> 2010</a:t>
+              <a:t> nguồn</a:t>
             </a:r>
             <a:endParaRPr lang="en-US" sz="4200" dirty="0"/>
           </a:p>

</xml_diff>

<commit_message>
Lessons sd-10-017, 018, 019, 021: define the abbreviations the decks use and drop the unsupported all-engineers line from the 021 deck
Co-Authored-By: Claude Sonnet 5.5 <noreply@anthropic.com>
Claude-Session: https://claude.ai/code/session_011dmt3ZFdN8sjiTfDnyUVN7
</commit_message>
<xml_diff>
--- a/system-design-101/vi/lessons/sd-10-017/slides/sd-10-017.pptx
+++ b/system-design-101/vi/lessons/sd-10-017/slides/sd-10-017.pptx
@@ -21307,8 +21307,8 @@
         </p:nvSpPr>
         <p:spPr>
           <a:xfrm>
-            <a:off x="914400" y="8705850"/>
-            <a:ext cx="16459200" cy="381000"/>
+            <a:off x="914400" y="8439150"/>
+            <a:ext cx="16459200" cy="857250"/>
           </a:xfrm>
           <a:prstGeom prst="rect">
             <a:avLst/>
@@ -21432,6 +21432,177 @@
                 <a:cs typeface="Be Vietnam Pro" pitchFamily="34" charset="-120"/>
               </a:rPr>
               <a:t> mới.</a:t>
+            </a:r>
+            <a:endParaRPr lang="en-US" sz="2100" dirty="0"/>
+          </a:p>
+          <a:p>
+            <a:pPr algn="l" indent="0" marL="0">
+              <a:buNone/>
+            </a:pPr>
+            <a:r>
+              <a:rPr lang="en-US" sz="2100" dirty="0" spc="2" kern="0">
+                <a:solidFill>
+                  <a:srgbClr val="C4C8D6"/>
+                </a:solidFill>
+                <a:latin typeface="Be Vietnam Pro" pitchFamily="34" charset="0"/>
+                <a:ea typeface="Be Vietnam Pro" pitchFamily="34" charset="-122"/>
+                <a:cs typeface="Be Vietnam Pro" pitchFamily="34" charset="-120"/>
+              </a:rPr>
+              <a:t>PC:</a:t>
+            </a:r>
+            <a:r>
+              <a:rPr lang="en-US" sz="2100" dirty="0" spc="-8" kern="0">
+                <a:solidFill>
+                  <a:srgbClr val="C4C8D6"/>
+                </a:solidFill>
+                <a:latin typeface="Be Vietnam Pro" pitchFamily="34" charset="0"/>
+                <a:ea typeface="Be Vietnam Pro" pitchFamily="34" charset="-122"/>
+                <a:cs typeface="Be Vietnam Pro" pitchFamily="34" charset="-120"/>
+              </a:rPr>
+              <a:t> Personal</a:t>
+            </a:r>
+            <a:r>
+              <a:rPr lang="en-US" sz="2100" dirty="0" spc="-6" kern="0">
+                <a:solidFill>
+                  <a:srgbClr val="C4C8D6"/>
+                </a:solidFill>
+                <a:latin typeface="Be Vietnam Pro" pitchFamily="34" charset="0"/>
+                <a:ea typeface="Be Vietnam Pro" pitchFamily="34" charset="-122"/>
+                <a:cs typeface="Be Vietnam Pro" pitchFamily="34" charset="-120"/>
+              </a:rPr>
+              <a:t> Computer,</a:t>
+            </a:r>
+            <a:r>
+              <a:rPr lang="en-US" sz="2100" dirty="0" spc="-9" kern="0">
+                <a:solidFill>
+                  <a:srgbClr val="C4C8D6"/>
+                </a:solidFill>
+                <a:latin typeface="Be Vietnam Pro" pitchFamily="34" charset="0"/>
+                <a:ea typeface="Be Vietnam Pro" pitchFamily="34" charset="-122"/>
+                <a:cs typeface="Be Vietnam Pro" pitchFamily="34" charset="-120"/>
+              </a:rPr>
+              <a:t> máy</a:t>
+            </a:r>
+            <a:r>
+              <a:rPr lang="en-US" sz="2100" dirty="0" spc="0" kern="0">
+                <a:solidFill>
+                  <a:srgbClr val="C4C8D6"/>
+                </a:solidFill>
+                <a:latin typeface="Be Vietnam Pro" pitchFamily="34" charset="0"/>
+                <a:ea typeface="Be Vietnam Pro" pitchFamily="34" charset="-122"/>
+                <a:cs typeface="Be Vietnam Pro" pitchFamily="34" charset="-120"/>
+              </a:rPr>
+              <a:t> tính</a:t>
+            </a:r>
+            <a:r>
+              <a:rPr lang="en-US" sz="2100" dirty="0" spc="-3" kern="0">
+                <a:solidFill>
+                  <a:srgbClr val="C4C8D6"/>
+                </a:solidFill>
+                <a:latin typeface="Be Vietnam Pro" pitchFamily="34" charset="0"/>
+                <a:ea typeface="Be Vietnam Pro" pitchFamily="34" charset="-122"/>
+                <a:cs typeface="Be Vietnam Pro" pitchFamily="34" charset="-120"/>
+              </a:rPr>
+              <a:t> cá</a:t>
+            </a:r>
+            <a:r>
+              <a:rPr lang="en-US" sz="2100" dirty="0" spc="0" kern="0">
+                <a:solidFill>
+                  <a:srgbClr val="C4C8D6"/>
+                </a:solidFill>
+                <a:latin typeface="Be Vietnam Pro" pitchFamily="34" charset="0"/>
+                <a:ea typeface="Be Vietnam Pro" pitchFamily="34" charset="-122"/>
+                <a:cs typeface="Be Vietnam Pro" pitchFamily="34" charset="-120"/>
+              </a:rPr>
+              <a:t> nhân</a:t>
+            </a:r>
+            <a:r>
+              <a:rPr lang="en-US" sz="2100" dirty="0" spc="-4" kern="0">
+                <a:solidFill>
+                  <a:srgbClr val="C4C8D6"/>
+                </a:solidFill>
+                <a:latin typeface="Be Vietnam Pro" pitchFamily="34" charset="0"/>
+                <a:ea typeface="Be Vietnam Pro" pitchFamily="34" charset="-122"/>
+                <a:cs typeface="Be Vietnam Pro" pitchFamily="34" charset="-120"/>
+              </a:rPr>
+              <a:t> ·</a:t>
+            </a:r>
+            <a:r>
+              <a:rPr lang="en-US" sz="2100" dirty="0" spc="1" kern="0">
+                <a:solidFill>
+                  <a:srgbClr val="C4C8D6"/>
+                </a:solidFill>
+                <a:latin typeface="Be Vietnam Pro" pitchFamily="34" charset="0"/>
+                <a:ea typeface="Be Vietnam Pro" pitchFamily="34" charset="-122"/>
+                <a:cs typeface="Be Vietnam Pro" pitchFamily="34" charset="-120"/>
+              </a:rPr>
+              <a:t> MDN:</a:t>
+            </a:r>
+            <a:r>
+              <a:rPr lang="en-US" sz="2100" dirty="0" spc="0" kern="0">
+                <a:solidFill>
+                  <a:srgbClr val="C4C8D6"/>
+                </a:solidFill>
+                <a:latin typeface="Be Vietnam Pro" pitchFamily="34" charset="0"/>
+                <a:ea typeface="Be Vietnam Pro" pitchFamily="34" charset="-122"/>
+                <a:cs typeface="Be Vietnam Pro" pitchFamily="34" charset="-120"/>
+              </a:rPr>
+              <a:t> Mozilla</a:t>
+            </a:r>
+            <a:r>
+              <a:rPr lang="en-US" sz="2100" dirty="0" spc="-12" kern="0">
+                <a:solidFill>
+                  <a:srgbClr val="C4C8D6"/>
+                </a:solidFill>
+                <a:latin typeface="Be Vietnam Pro" pitchFamily="34" charset="0"/>
+                <a:ea typeface="Be Vietnam Pro" pitchFamily="34" charset="-122"/>
+                <a:cs typeface="Be Vietnam Pro" pitchFamily="34" charset="-120"/>
+              </a:rPr>
+              <a:t> Developer</a:t>
+            </a:r>
+            <a:r>
+              <a:rPr lang="en-US" sz="2100" dirty="0" spc="-9" kern="0">
+                <a:solidFill>
+                  <a:srgbClr val="C4C8D6"/>
+                </a:solidFill>
+                <a:latin typeface="Be Vietnam Pro" pitchFamily="34" charset="0"/>
+                <a:ea typeface="Be Vietnam Pro" pitchFamily="34" charset="-122"/>
+                <a:cs typeface="Be Vietnam Pro" pitchFamily="34" charset="-120"/>
+              </a:rPr>
+              <a:t> Network,</a:t>
+            </a:r>
+            <a:r>
+              <a:rPr lang="en-US" sz="2100" dirty="0" spc="-11" kern="0">
+                <a:solidFill>
+                  <a:srgbClr val="C4C8D6"/>
+                </a:solidFill>
+                <a:latin typeface="Be Vietnam Pro" pitchFamily="34" charset="0"/>
+                <a:ea typeface="Be Vietnam Pro" pitchFamily="34" charset="-122"/>
+                <a:cs typeface="Be Vietnam Pro" pitchFamily="34" charset="-120"/>
+              </a:rPr>
+              <a:t> tài</a:t>
+            </a:r>
+            <a:r>
+              <a:rPr lang="en-US" sz="2100" dirty="0" spc="1" kern="0">
+                <a:solidFill>
+                  <a:srgbClr val="C4C8D6"/>
+                </a:solidFill>
+                <a:latin typeface="Be Vietnam Pro" pitchFamily="34" charset="0"/>
+                <a:ea typeface="Be Vietnam Pro" pitchFamily="34" charset="-122"/>
+                <a:cs typeface="Be Vietnam Pro" pitchFamily="34" charset="-120"/>
+              </a:rPr>
+              <a:t> liệu</a:t>
+            </a:r>
+            <a:r>
+              <a:rPr lang="en-US" sz="2100" dirty="0" spc="-14" kern="0">
+                <a:solidFill>
+                  <a:srgbClr val="C4C8D6"/>
+                </a:solidFill>
+                <a:latin typeface="Be Vietnam Pro" pitchFamily="34" charset="0"/>
+                <a:ea typeface="Be Vietnam Pro" pitchFamily="34" charset="-122"/>
+                <a:cs typeface="Be Vietnam Pro" pitchFamily="34" charset="-120"/>
+              </a:rPr>
+              <a:t> web</a:t>
             </a:r>
             <a:endParaRPr lang="en-US" sz="2100" dirty="0"/>
           </a:p>

</xml_diff>

<commit_message>
Lesson sd-10-017: count Carbon's 2022 announcement among the checked dates in the lesson, metadata and deck
Co-Authored-By: Claude Sonnet 5.5 <noreply@anthropic.com>
Claude-Session: https://claude.ai/code/session_011dmt3ZFdN8sjiTfDnyUVN7
</commit_message>
<xml_diff>
--- a/system-design-101/vi/lessons/sd-10-017/slides/sd-10-017.pptx
+++ b/system-design-101/vi/lessons/sd-10-017/slides/sd-10-017.pptx
@@ -15408,7 +15408,7 @@
               <a:buNone/>
             </a:pPr>
             <a:r>
-              <a:rPr lang="en-US" sz="7200" dirty="0" spc="-2" kern="0">
+              <a:rPr lang="en-US" sz="7200" dirty="0" spc="0" kern="0">
                 <a:solidFill>
                   <a:srgbClr val="F3EEE3"/>
                 </a:solidFill>
@@ -15416,7 +15416,7 @@
                 <a:ea typeface="Bricolage Grotesque ExtraBold" pitchFamily="34" charset="-122"/>
                 <a:cs typeface="Bricolage Grotesque ExtraBold" pitchFamily="34" charset="-120"/>
               </a:rPr>
-              <a:t>Hai</a:t>
+              <a:t>Ba</a:t>
             </a:r>
             <a:r>
               <a:rPr lang="en-US" sz="7200" dirty="0" spc="1" kern="0">
@@ -15503,7 +15503,7 @@
               <a:buNone/>
             </a:pPr>
             <a:r>
-              <a:rPr lang="en-US" sz="3300" b="1" dirty="0" spc="-2" kern="0">
+              <a:rPr lang="en-US" sz="3300" b="1" dirty="0" spc="-1" kern="0">
                 <a:solidFill>
                   <a:srgbClr val="FFB454"/>
                 </a:solidFill>
@@ -15511,10 +15511,10 @@
                 <a:ea typeface="Be Vietnam Pro" pitchFamily="34" charset="-122"/>
                 <a:cs typeface="Be Vietnam Pro" pitchFamily="34" charset="-120"/>
               </a:rPr>
-              <a:t>Python</a:t>
-            </a:r>
-            <a:r>
-              <a:rPr lang="en-US" sz="3300" b="1" dirty="0" spc="-30" kern="0">
+              <a:t>Python,</a:t>
+            </a:r>
+            <a:r>
+              <a:rPr lang="en-US" sz="3300" b="1" dirty="0" spc="-12" kern="0">
                 <a:solidFill>
                   <a:srgbClr val="FFB454"/>
                 </a:solidFill>
@@ -15522,10 +15522,10 @@
                 <a:ea typeface="Be Vietnam Pro" pitchFamily="34" charset="-122"/>
                 <a:cs typeface="Be Vietnam Pro" pitchFamily="34" charset="-120"/>
               </a:rPr>
-              <a:t> và</a:t>
-            </a:r>
-            <a:r>
-              <a:rPr lang="en-US" sz="3300" b="1" dirty="0" spc="-14" kern="0">
+              <a:t> JavaScript,</a:t>
+            </a:r>
+            <a:r>
+              <a:rPr lang="en-US" sz="3300" b="1" dirty="0" spc="-7" kern="0">
                 <a:solidFill>
                   <a:srgbClr val="FFB454"/>
                 </a:solidFill>
@@ -15533,7 +15533,7 @@
                 <a:ea typeface="Be Vietnam Pro" pitchFamily="34" charset="-122"/>
                 <a:cs typeface="Be Vietnam Pro" pitchFamily="34" charset="-120"/>
               </a:rPr>
-              <a:t> JavaScript</a:t>
+              <a:t> Carbon</a:t>
             </a:r>
             <a:endParaRPr lang="en-US" sz="3300" dirty="0"/>
           </a:p>

</xml_diff>

<commit_message>
Lessons sd-10-017, 018: give PHP's current expansion beside its original name, reword the sticky slide neutrally and list every unchecked gloss in the 018 summary
Co-Authored-By: Claude Sonnet 5.5 <noreply@anthropic.com>
Claude-Session: https://claude.ai/code/session_011dmt3ZFdN8sjiTfDnyUVN7
</commit_message>
<xml_diff>
--- a/system-design-101/vi/lessons/sd-10-017/slides/sd-10-017.pptx
+++ b/system-design-101/vi/lessons/sd-10-017/slides/sd-10-017.pptx
@@ -20663,7 +20663,7 @@
               <a:buNone/>
             </a:pPr>
             <a:r>
-              <a:rPr lang="en-US" sz="2550" dirty="0" spc="-20" kern="0">
+              <a:rPr lang="en-US" sz="2550" dirty="0" spc="-15" kern="0">
                 <a:solidFill>
                   <a:srgbClr val="F3EEE3"/>
                 </a:solidFill>
@@ -20671,10 +20671,10 @@
                 <a:ea typeface="Be Vietnam Pro" pitchFamily="34" charset="-122"/>
                 <a:cs typeface="Be Vietnam Pro" pitchFamily="34" charset="-120"/>
               </a:rPr>
-              <a:t>trang</a:t>
-            </a:r>
-            <a:r>
-              <a:rPr lang="en-US" sz="2550" dirty="0" spc="-1" kern="0">
+              <a:t>tên</a:t>
+            </a:r>
+            <a:r>
+              <a:rPr lang="en-US" sz="2550" dirty="0" spc="-4" kern="0">
                 <a:solidFill>
                   <a:srgbClr val="F3EEE3"/>
                 </a:solidFill>
@@ -20682,7 +20682,29 @@
                 <a:ea typeface="Be Vietnam Pro" pitchFamily="34" charset="-122"/>
                 <a:cs typeface="Be Vietnam Pro" pitchFamily="34" charset="-120"/>
               </a:rPr>
-              <a:t> chủ</a:t>
+              <a:t> ban</a:t>
+            </a:r>
+            <a:r>
+              <a:rPr lang="en-US" sz="2550" dirty="0" spc="11" kern="0">
+                <a:solidFill>
+                  <a:srgbClr val="F3EEE3"/>
+                </a:solidFill>
+                <a:latin typeface="Be Vietnam Pro" pitchFamily="34" charset="0"/>
+                <a:ea typeface="Be Vietnam Pro" pitchFamily="34" charset="-122"/>
+                <a:cs typeface="Be Vietnam Pro" pitchFamily="34" charset="-120"/>
+              </a:rPr>
+              <a:t> đầu;</a:t>
+            </a:r>
+            <a:r>
+              <a:rPr lang="en-US" sz="2550" dirty="0" spc="-7" kern="0">
+                <a:solidFill>
+                  <a:srgbClr val="F3EEE3"/>
+                </a:solidFill>
+                <a:latin typeface="Be Vietnam Pro" pitchFamily="34" charset="0"/>
+                <a:ea typeface="Be Vietnam Pro" pitchFamily="34" charset="-122"/>
+                <a:cs typeface="Be Vietnam Pro" pitchFamily="34" charset="-120"/>
+              </a:rPr>
+              <a:t> nay:</a:t>
             </a:r>
             <a:r>
               <a:rPr lang="en-US" sz="2550" dirty="0" spc="1" kern="0">
@@ -20693,10 +20715,10 @@
                 <a:ea typeface="Be Vietnam Pro" pitchFamily="34" charset="-122"/>
                 <a:cs typeface="Be Vietnam Pro" pitchFamily="34" charset="-120"/>
               </a:rPr>
-              <a:t> cá</a:t>
-            </a:r>
-            <a:r>
-              <a:rPr lang="en-US" sz="2550" dirty="0" spc="-1" kern="0">
+              <a:t> PHP:</a:t>
+            </a:r>
+            <a:r>
+              <a:rPr lang="en-US" sz="2550" dirty="0" spc="-13" kern="0">
                 <a:solidFill>
                   <a:srgbClr val="F3EEE3"/>
                 </a:solidFill>
@@ -20704,10 +20726,10 @@
                 <a:ea typeface="Be Vietnam Pro" pitchFamily="34" charset="-122"/>
                 <a:cs typeface="Be Vietnam Pro" pitchFamily="34" charset="-120"/>
               </a:rPr>
-              <a:t> nhân,</a:t>
-            </a:r>
-            <a:r>
-              <a:rPr lang="en-US" sz="2550" dirty="0" spc="-12" kern="0">
+              <a:t> Hypertext</a:t>
+            </a:r>
+            <a:r>
+              <a:rPr lang="en-US" sz="2550" dirty="0" spc="-19" kern="0">
                 <a:solidFill>
                   <a:srgbClr val="F3EEE3"/>
                 </a:solidFill>
@@ -20715,51 +20737,7 @@
                 <a:ea typeface="Be Vietnam Pro" pitchFamily="34" charset="-122"/>
                 <a:cs typeface="Be Vietnam Pro" pitchFamily="34" charset="-120"/>
               </a:rPr>
-              <a:t> tên</a:t>
-            </a:r>
-            <a:r>
-              <a:rPr lang="en-US" sz="2550" dirty="0" spc="-3" kern="0">
-                <a:solidFill>
-                  <a:srgbClr val="F3EEE3"/>
-                </a:solidFill>
-                <a:latin typeface="Be Vietnam Pro" pitchFamily="34" charset="0"/>
-                <a:ea typeface="Be Vietnam Pro" pitchFamily="34" charset="-122"/>
-                <a:cs typeface="Be Vietnam Pro" pitchFamily="34" charset="-120"/>
-              </a:rPr>
-              <a:t> ban</a:t>
-            </a:r>
-            <a:r>
-              <a:rPr lang="en-US" sz="2550" dirty="0" spc="14" kern="0">
-                <a:solidFill>
-                  <a:srgbClr val="F3EEE3"/>
-                </a:solidFill>
-                <a:latin typeface="Be Vietnam Pro" pitchFamily="34" charset="0"/>
-                <a:ea typeface="Be Vietnam Pro" pitchFamily="34" charset="-122"/>
-                <a:cs typeface="Be Vietnam Pro" pitchFamily="34" charset="-120"/>
-              </a:rPr>
-              <a:t> đầu</a:t>
-            </a:r>
-            <a:r>
-              <a:rPr lang="en-US" sz="2550" dirty="0" spc="-1" kern="0">
-                <a:solidFill>
-                  <a:srgbClr val="F3EEE3"/>
-                </a:solidFill>
-                <a:latin typeface="Be Vietnam Pro" pitchFamily="34" charset="0"/>
-                <a:ea typeface="Be Vietnam Pro" pitchFamily="34" charset="-122"/>
-                <a:cs typeface="Be Vietnam Pro" pitchFamily="34" charset="-120"/>
-              </a:rPr>
-              <a:t> của</a:t>
-            </a:r>
-            <a:r>
-              <a:rPr lang="en-US" sz="2550" dirty="0" spc="1" kern="0">
-                <a:solidFill>
-                  <a:srgbClr val="F3EEE3"/>
-                </a:solidFill>
-                <a:latin typeface="Be Vietnam Pro" pitchFamily="34" charset="0"/>
-                <a:ea typeface="Be Vietnam Pro" pitchFamily="34" charset="-122"/>
-                <a:cs typeface="Be Vietnam Pro" pitchFamily="34" charset="-120"/>
-              </a:rPr>
-              <a:t> PHP</a:t>
+              <a:t> Preprocessor</a:t>
             </a:r>
             <a:endParaRPr lang="en-US" sz="2550" dirty="0"/>
           </a:p>

</xml_diff>

<commit_message>
Lessons sd-10-017, 020: list MDN and JDK among the unchecked glosses and qualify the Go 2009 date on the 017 deck
Co-Authored-By: Claude Sonnet 5.5 <noreply@anthropic.com>
Claude-Session: https://claude.ai/code/session_011dmt3ZFdN8sjiTfDnyUVN7
</commit_message>
<xml_diff>
--- a/system-design-101/vi/lessons/sd-10-017/slides/sd-10-017.pptx
+++ b/system-design-101/vi/lessons/sd-10-017/slides/sd-10-017.pptx
@@ -13118,10 +13118,43 @@
                 <a:ea typeface="Be Vietnam Pro" pitchFamily="34" charset="-122"/>
                 <a:cs typeface="Be Vietnam Pro" pitchFamily="34" charset="-120"/>
               </a:rPr>
-              <a:t> (2009)</a:t>
-            </a:r>
-            <a:r>
-              <a:rPr lang="en-US" sz="2850" dirty="0" spc="-17" kern="0">
+              <a:t> (2009,</a:t>
+            </a:r>
+            <a:r>
+              <a:rPr lang="en-US" sz="2850" dirty="0" spc="10" kern="0">
+                <a:solidFill>
+                  <a:srgbClr val="14161C"/>
+                </a:solidFill>
+                <a:latin typeface="Be Vietnam Pro" pitchFamily="34" charset="0"/>
+                <a:ea typeface="Be Vietnam Pro" pitchFamily="34" charset="-122"/>
+                <a:cs typeface="Be Vietnam Pro" pitchFamily="34" charset="-120"/>
+              </a:rPr>
+              <a:t> chưa</a:t>
+            </a:r>
+            <a:r>
+              <a:rPr lang="en-US" sz="2850" dirty="0" spc="-1" kern="0">
+                <a:solidFill>
+                  <a:srgbClr val="14161C"/>
+                </a:solidFill>
+                <a:latin typeface="Be Vietnam Pro" pitchFamily="34" charset="0"/>
+                <a:ea typeface="Be Vietnam Pro" pitchFamily="34" charset="-122"/>
+                <a:cs typeface="Be Vietnam Pro" pitchFamily="34" charset="-120"/>
+              </a:rPr>
+              <a:t> kiểm</a:t>
+            </a:r>
+            <a:r>
+              <a:rPr lang="en-US" sz="2850" dirty="0" spc="-21" kern="0">
+                <a:solidFill>
+                  <a:srgbClr val="14161C"/>
+                </a:solidFill>
+                <a:latin typeface="Be Vietnam Pro" pitchFamily="34" charset="0"/>
+                <a:ea typeface="Be Vietnam Pro" pitchFamily="34" charset="-122"/>
+                <a:cs typeface="Be Vietnam Pro" pitchFamily="34" charset="-120"/>
+              </a:rPr>
+              <a:t> tra)</a:t>
+            </a:r>
+            <a:r>
+              <a:rPr lang="en-US" sz="2850" dirty="0" spc="-16" kern="0">
                 <a:solidFill>
                   <a:srgbClr val="14161C"/>
                 </a:solidFill>
@@ -13143,7 +13176,7 @@
               <a:t> Carbon</a:t>
             </a:r>
             <a:r>
-              <a:rPr lang="en-US" sz="2850" dirty="0" spc="3" kern="0">
+              <a:rPr lang="en-US" sz="2850" dirty="0" spc="4" kern="0">
                 <a:solidFill>
                   <a:srgbClr val="14161C"/>
                 </a:solidFill>
@@ -13154,7 +13187,7 @@
               <a:t> (2022)</a:t>
             </a:r>
             <a:r>
-              <a:rPr lang="en-US" sz="2850" dirty="0" spc="-2" kern="0">
+              <a:rPr lang="en-US" sz="2850" dirty="0" spc="-3" kern="0">
                 <a:solidFill>
                   <a:srgbClr val="14161C"/>
                 </a:solidFill>
@@ -15901,7 +15934,7 @@
               <a:t>Mốc</a:t>
             </a:r>
             <a:r>
-              <a:rPr lang="en-US" sz="2550" dirty="0" spc="-18" kern="0">
+              <a:rPr lang="en-US" sz="2550" dirty="0" spc="1" kern="0">
                 <a:solidFill>
                   <a:srgbClr val="F3EEE3"/>
                 </a:solidFill>
@@ -15909,7 +15942,73 @@
                 <a:ea typeface="Be Vietnam Pro" pitchFamily="34" charset="-122"/>
                 <a:cs typeface="Be Vietnam Pro" pitchFamily="34" charset="-120"/>
               </a:rPr>
-              <a:t> và</a:t>
+              <a:t> khác</a:t>
+            </a:r>
+            <a:r>
+              <a:rPr lang="en-US" sz="2550" dirty="0" spc="0" kern="0">
+                <a:solidFill>
+                  <a:srgbClr val="F3EEE3"/>
+                </a:solidFill>
+                <a:latin typeface="Be Vietnam Pro" pitchFamily="34" charset="0"/>
+                <a:ea typeface="Be Vietnam Pro" pitchFamily="34" charset="-122"/>
+                <a:cs typeface="Be Vietnam Pro" pitchFamily="34" charset="-120"/>
+              </a:rPr>
+              <a:t> là lời</a:t>
+            </a:r>
+            <a:r>
+              <a:rPr lang="en-US" sz="2550" dirty="0" spc="-2" kern="0">
+                <a:solidFill>
+                  <a:srgbClr val="F3EEE3"/>
+                </a:solidFill>
+                <a:latin typeface="Be Vietnam Pro" pitchFamily="34" charset="0"/>
+                <a:ea typeface="Be Vietnam Pro" pitchFamily="34" charset="-122"/>
+                <a:cs typeface="Be Vietnam Pro" pitchFamily="34" charset="-120"/>
+              </a:rPr>
+              <a:t> của</a:t>
+            </a:r>
+            <a:r>
+              <a:rPr lang="en-US" sz="2550" dirty="0" spc="0" kern="0">
+                <a:solidFill>
+                  <a:srgbClr val="F3EEE3"/>
+                </a:solidFill>
+                <a:latin typeface="Be Vietnam Pro" pitchFamily="34" charset="0"/>
+                <a:ea typeface="Be Vietnam Pro" pitchFamily="34" charset="-122"/>
+                <a:cs typeface="Be Vietnam Pro" pitchFamily="34" charset="-120"/>
+              </a:rPr>
+              <a:t> nguồn,</a:t>
+            </a:r>
+            <a:r>
+              <a:rPr lang="en-US" sz="2550" dirty="0" spc="7" kern="0">
+                <a:solidFill>
+                  <a:srgbClr val="F3EEE3"/>
+                </a:solidFill>
+                <a:latin typeface="Be Vietnam Pro" pitchFamily="34" charset="0"/>
+                <a:ea typeface="Be Vietnam Pro" pitchFamily="34" charset="-122"/>
+                <a:cs typeface="Be Vietnam Pro" pitchFamily="34" charset="-120"/>
+              </a:rPr>
+              <a:t> chưa</a:t>
+            </a:r>
+            <a:r>
+              <a:rPr lang="en-US" sz="2550" dirty="0" spc="1" kern="0">
+                <a:solidFill>
+                  <a:srgbClr val="F3EEE3"/>
+                </a:solidFill>
+                <a:latin typeface="Be Vietnam Pro" pitchFamily="34" charset="0"/>
+                <a:ea typeface="Be Vietnam Pro" pitchFamily="34" charset="-122"/>
+                <a:cs typeface="Be Vietnam Pro" pitchFamily="34" charset="-120"/>
+              </a:rPr>
+              <a:t> kiểm</a:t>
+            </a:r>
+            <a:r>
+              <a:rPr lang="en-US" sz="2550" dirty="0" spc="-21" kern="0">
+                <a:solidFill>
+                  <a:srgbClr val="F3EEE3"/>
+                </a:solidFill>
+                <a:latin typeface="Be Vietnam Pro" pitchFamily="34" charset="0"/>
+                <a:ea typeface="Be Vietnam Pro" pitchFamily="34" charset="-122"/>
+                <a:cs typeface="Be Vietnam Pro" pitchFamily="34" charset="-120"/>
+              </a:rPr>
+              <a:t> tra;</a:t>
             </a:r>
             <a:r>
               <a:rPr lang="en-US" sz="2550" dirty="0" spc="-1" kern="0">
@@ -15920,10 +16019,10 @@
                 <a:ea typeface="Be Vietnam Pro" pitchFamily="34" charset="-122"/>
                 <a:cs typeface="Be Vietnam Pro" pitchFamily="34" charset="-120"/>
               </a:rPr>
-              <a:t> nhận</a:t>
-            </a:r>
-            <a:r>
-              <a:rPr lang="en-US" sz="2550" dirty="0" spc="21" kern="0">
+              <a:t> Go</a:t>
+            </a:r>
+            <a:r>
+              <a:rPr lang="en-US" sz="2550" dirty="0" spc="-2" kern="0">
                 <a:solidFill>
                   <a:srgbClr val="F3EEE3"/>
                 </a:solidFill>
@@ -15931,7 +16030,106 @@
                 <a:ea typeface="Be Vietnam Pro" pitchFamily="34" charset="-122"/>
                 <a:cs typeface="Be Vietnam Pro" pitchFamily="34" charset="-120"/>
               </a:rPr>
-              <a:t> định</a:t>
+              <a:t> 2009</a:t>
+            </a:r>
+            <a:r>
+              <a:rPr lang="en-US" sz="2550" dirty="0" spc="-1" kern="0">
+                <a:solidFill>
+                  <a:srgbClr val="F3EEE3"/>
+                </a:solidFill>
+                <a:latin typeface="Be Vietnam Pro" pitchFamily="34" charset="0"/>
+                <a:ea typeface="Be Vietnam Pro" pitchFamily="34" charset="-122"/>
+                <a:cs typeface="Be Vietnam Pro" pitchFamily="34" charset="-120"/>
+              </a:rPr>
+              <a:t> cũng</a:t>
+            </a:r>
+            <a:r>
+              <a:rPr lang="en-US" sz="2550" dirty="0" spc="6" kern="0">
+                <a:solidFill>
+                  <a:srgbClr val="F3EEE3"/>
+                </a:solidFill>
+                <a:latin typeface="Be Vietnam Pro" pitchFamily="34" charset="0"/>
+                <a:ea typeface="Be Vietnam Pro" pitchFamily="34" charset="-122"/>
+                <a:cs typeface="Be Vietnam Pro" pitchFamily="34" charset="-120"/>
+              </a:rPr>
+              <a:t> chưa.</a:t>
+            </a:r>
+            <a:r>
+              <a:rPr lang="en-US" sz="2550" dirty="0" spc="-1" kern="0">
+                <a:solidFill>
+                  <a:srgbClr val="F3EEE3"/>
+                </a:solidFill>
+                <a:latin typeface="Be Vietnam Pro" pitchFamily="34" charset="0"/>
+                <a:ea typeface="Be Vietnam Pro" pitchFamily="34" charset="-122"/>
+                <a:cs typeface="Be Vietnam Pro" pitchFamily="34" charset="-120"/>
+              </a:rPr>
+              <a:t> Mô</a:t>
+            </a:r>
+            <a:r>
+              <a:rPr lang="en-US" sz="2550" dirty="0" spc="-15" kern="0">
+                <a:solidFill>
+                  <a:srgbClr val="F3EEE3"/>
+                </a:solidFill>
+                <a:latin typeface="Be Vietnam Pro" pitchFamily="34" charset="0"/>
+                <a:ea typeface="Be Vietnam Pro" pitchFamily="34" charset="-122"/>
+                <a:cs typeface="Be Vietnam Pro" pitchFamily="34" charset="-120"/>
+              </a:rPr>
+              <a:t> tả</a:t>
+            </a:r>
+            <a:r>
+              <a:rPr lang="en-US" sz="2550" dirty="0" spc="-10" kern="0">
+                <a:solidFill>
+                  <a:srgbClr val="F3EEE3"/>
+                </a:solidFill>
+                <a:latin typeface="Be Vietnam Pro" pitchFamily="34" charset="0"/>
+                <a:ea typeface="Be Vietnam Pro" pitchFamily="34" charset="-122"/>
+                <a:cs typeface="Be Vietnam Pro" pitchFamily="34" charset="-120"/>
+              </a:rPr>
+              <a:t> ngôn</a:t>
+            </a:r>
+            <a:r>
+              <a:rPr lang="en-US" sz="2550" dirty="0" spc="-2" kern="0">
+                <a:solidFill>
+                  <a:srgbClr val="F3EEE3"/>
+                </a:solidFill>
+                <a:latin typeface="Be Vietnam Pro" pitchFamily="34" charset="0"/>
+                <a:ea typeface="Be Vietnam Pro" pitchFamily="34" charset="-122"/>
+                <a:cs typeface="Be Vietnam Pro" pitchFamily="34" charset="-120"/>
+              </a:rPr>
+              <a:t> ngữ</a:t>
+            </a:r>
+            <a:r>
+              <a:rPr lang="en-US" sz="2550" dirty="0" spc="10" kern="0">
+                <a:solidFill>
+                  <a:srgbClr val="F3EEE3"/>
+                </a:solidFill>
+                <a:latin typeface="Be Vietnam Pro" pitchFamily="34" charset="0"/>
+                <a:ea typeface="Be Vietnam Pro" pitchFamily="34" charset="-122"/>
+                <a:cs typeface="Be Vietnam Pro" pitchFamily="34" charset="-120"/>
+              </a:rPr>
+              <a:t> đọc</a:t>
+            </a:r>
+            <a:r>
+              <a:rPr lang="en-US" sz="2550" dirty="0" spc="-1" kern="0">
+                <a:solidFill>
+                  <a:srgbClr val="F3EEE3"/>
+                </a:solidFill>
+                <a:latin typeface="Be Vietnam Pro" pitchFamily="34" charset="0"/>
+                <a:ea typeface="Be Vietnam Pro" pitchFamily="34" charset="-122"/>
+                <a:cs typeface="Be Vietnam Pro" pitchFamily="34" charset="-120"/>
+              </a:rPr>
+              <a:t> từ</a:t>
+            </a:r>
+            <a:r>
+              <a:rPr lang="en-US" sz="2550" dirty="0" spc="-12" kern="0">
+                <a:solidFill>
+                  <a:srgbClr val="F3EEE3"/>
+                </a:solidFill>
+                <a:latin typeface="Be Vietnam Pro" pitchFamily="34" charset="0"/>
+                <a:ea typeface="Be Vietnam Pro" pitchFamily="34" charset="-122"/>
+                <a:cs typeface="Be Vietnam Pro" pitchFamily="34" charset="-120"/>
+              </a:rPr>
+              <a:t> tài</a:t>
             </a:r>
             <a:r>
               <a:rPr lang="en-US" sz="2550" dirty="0" spc="1" kern="0">
@@ -15942,164 +16140,10 @@
                 <a:ea typeface="Be Vietnam Pro" pitchFamily="34" charset="-122"/>
                 <a:cs typeface="Be Vietnam Pro" pitchFamily="34" charset="-120"/>
               </a:rPr>
-              <a:t> khác</a:t>
-            </a:r>
-            <a:r>
-              <a:rPr lang="en-US" sz="2550" dirty="0" spc="0" kern="0">
-                <a:solidFill>
-                  <a:srgbClr val="F3EEE3"/>
-                </a:solidFill>
-                <a:latin typeface="Be Vietnam Pro" pitchFamily="34" charset="0"/>
-                <a:ea typeface="Be Vietnam Pro" pitchFamily="34" charset="-122"/>
-                <a:cs typeface="Be Vietnam Pro" pitchFamily="34" charset="-120"/>
-              </a:rPr>
-              <a:t> là lời</a:t>
+              <a:t> liệu</a:t>
             </a:r>
             <a:r>
               <a:rPr lang="en-US" sz="2550" dirty="0" spc="-2" kern="0">
-                <a:solidFill>
-                  <a:srgbClr val="F3EEE3"/>
-                </a:solidFill>
-                <a:latin typeface="Be Vietnam Pro" pitchFamily="34" charset="0"/>
-                <a:ea typeface="Be Vietnam Pro" pitchFamily="34" charset="-122"/>
-                <a:cs typeface="Be Vietnam Pro" pitchFamily="34" charset="-120"/>
-              </a:rPr>
-              <a:t> của</a:t>
-            </a:r>
-            <a:r>
-              <a:rPr lang="en-US" sz="2550" dirty="0" spc="0" kern="0">
-                <a:solidFill>
-                  <a:srgbClr val="F3EEE3"/>
-                </a:solidFill>
-                <a:latin typeface="Be Vietnam Pro" pitchFamily="34" charset="0"/>
-                <a:ea typeface="Be Vietnam Pro" pitchFamily="34" charset="-122"/>
-                <a:cs typeface="Be Vietnam Pro" pitchFamily="34" charset="-120"/>
-              </a:rPr>
-              <a:t> nguồn,</a:t>
-            </a:r>
-            <a:r>
-              <a:rPr lang="en-US" sz="2550" dirty="0" spc="7" kern="0">
-                <a:solidFill>
-                  <a:srgbClr val="F3EEE3"/>
-                </a:solidFill>
-                <a:latin typeface="Be Vietnam Pro" pitchFamily="34" charset="0"/>
-                <a:ea typeface="Be Vietnam Pro" pitchFamily="34" charset="-122"/>
-                <a:cs typeface="Be Vietnam Pro" pitchFamily="34" charset="-120"/>
-              </a:rPr>
-              <a:t> chưa</a:t>
-            </a:r>
-            <a:r>
-              <a:rPr lang="en-US" sz="2550" dirty="0" spc="1" kern="0">
-                <a:solidFill>
-                  <a:srgbClr val="F3EEE3"/>
-                </a:solidFill>
-                <a:latin typeface="Be Vietnam Pro" pitchFamily="34" charset="0"/>
-                <a:ea typeface="Be Vietnam Pro" pitchFamily="34" charset="-122"/>
-                <a:cs typeface="Be Vietnam Pro" pitchFamily="34" charset="-120"/>
-              </a:rPr>
-              <a:t> kiểm</a:t>
-            </a:r>
-            <a:r>
-              <a:rPr lang="en-US" sz="2550" dirty="0" spc="-21" kern="0">
-                <a:solidFill>
-                  <a:srgbClr val="F3EEE3"/>
-                </a:solidFill>
-                <a:latin typeface="Be Vietnam Pro" pitchFamily="34" charset="0"/>
-                <a:ea typeface="Be Vietnam Pro" pitchFamily="34" charset="-122"/>
-                <a:cs typeface="Be Vietnam Pro" pitchFamily="34" charset="-120"/>
-              </a:rPr>
-              <a:t> tra;</a:t>
-            </a:r>
-            <a:r>
-              <a:rPr lang="en-US" sz="2550" dirty="0" spc="1" kern="0">
-                <a:solidFill>
-                  <a:srgbClr val="F3EEE3"/>
-                </a:solidFill>
-                <a:latin typeface="Be Vietnam Pro" pitchFamily="34" charset="0"/>
-                <a:ea typeface="Be Vietnam Pro" pitchFamily="34" charset="-122"/>
-                <a:cs typeface="Be Vietnam Pro" pitchFamily="34" charset="-120"/>
-              </a:rPr>
-              <a:t> mô</a:t>
-            </a:r>
-            <a:r>
-              <a:rPr lang="en-US" sz="2550" dirty="0" spc="-16" kern="0">
-                <a:solidFill>
-                  <a:srgbClr val="F3EEE3"/>
-                </a:solidFill>
-                <a:latin typeface="Be Vietnam Pro" pitchFamily="34" charset="0"/>
-                <a:ea typeface="Be Vietnam Pro" pitchFamily="34" charset="-122"/>
-                <a:cs typeface="Be Vietnam Pro" pitchFamily="34" charset="-120"/>
-              </a:rPr>
-              <a:t> tả</a:t>
-            </a:r>
-            <a:r>
-              <a:rPr lang="en-US" sz="2550" dirty="0" spc="-10" kern="0">
-                <a:solidFill>
-                  <a:srgbClr val="F3EEE3"/>
-                </a:solidFill>
-                <a:latin typeface="Be Vietnam Pro" pitchFamily="34" charset="0"/>
-                <a:ea typeface="Be Vietnam Pro" pitchFamily="34" charset="-122"/>
-                <a:cs typeface="Be Vietnam Pro" pitchFamily="34" charset="-120"/>
-              </a:rPr>
-              <a:t> ngôn</a:t>
-            </a:r>
-            <a:r>
-              <a:rPr lang="en-US" sz="2550" dirty="0" spc="-2" kern="0">
-                <a:solidFill>
-                  <a:srgbClr val="F3EEE3"/>
-                </a:solidFill>
-                <a:latin typeface="Be Vietnam Pro" pitchFamily="34" charset="0"/>
-                <a:ea typeface="Be Vietnam Pro" pitchFamily="34" charset="-122"/>
-                <a:cs typeface="Be Vietnam Pro" pitchFamily="34" charset="-120"/>
-              </a:rPr>
-              <a:t> ngữ</a:t>
-            </a:r>
-            <a:r>
-              <a:rPr lang="en-US" sz="2550" dirty="0" spc="10" kern="0">
-                <a:solidFill>
-                  <a:srgbClr val="F3EEE3"/>
-                </a:solidFill>
-                <a:latin typeface="Be Vietnam Pro" pitchFamily="34" charset="0"/>
-                <a:ea typeface="Be Vietnam Pro" pitchFamily="34" charset="-122"/>
-                <a:cs typeface="Be Vietnam Pro" pitchFamily="34" charset="-120"/>
-              </a:rPr>
-              <a:t> đọc</a:t>
-            </a:r>
-            <a:r>
-              <a:rPr lang="en-US" sz="2550" dirty="0" spc="-1" kern="0">
-                <a:solidFill>
-                  <a:srgbClr val="F3EEE3"/>
-                </a:solidFill>
-                <a:latin typeface="Be Vietnam Pro" pitchFamily="34" charset="0"/>
-                <a:ea typeface="Be Vietnam Pro" pitchFamily="34" charset="-122"/>
-                <a:cs typeface="Be Vietnam Pro" pitchFamily="34" charset="-120"/>
-              </a:rPr>
-              <a:t> từ</a:t>
-            </a:r>
-            <a:r>
-              <a:rPr lang="en-US" sz="2550" dirty="0" spc="-12" kern="0">
-                <a:solidFill>
-                  <a:srgbClr val="F3EEE3"/>
-                </a:solidFill>
-                <a:latin typeface="Be Vietnam Pro" pitchFamily="34" charset="0"/>
-                <a:ea typeface="Be Vietnam Pro" pitchFamily="34" charset="-122"/>
-                <a:cs typeface="Be Vietnam Pro" pitchFamily="34" charset="-120"/>
-              </a:rPr>
-              <a:t> tài</a:t>
-            </a:r>
-            <a:r>
-              <a:rPr lang="en-US" sz="2550" dirty="0" spc="1" kern="0">
-                <a:solidFill>
-                  <a:srgbClr val="F3EEE3"/>
-                </a:solidFill>
-                <a:latin typeface="Be Vietnam Pro" pitchFamily="34" charset="0"/>
-                <a:ea typeface="Be Vietnam Pro" pitchFamily="34" charset="-122"/>
-                <a:cs typeface="Be Vietnam Pro" pitchFamily="34" charset="-120"/>
-              </a:rPr>
-              <a:t> liệu</a:t>
-            </a:r>
-            <a:r>
-              <a:rPr lang="en-US" sz="2550" dirty="0" spc="-1" kern="0">
                 <a:solidFill>
                   <a:srgbClr val="F3EEE3"/>
                 </a:solidFill>

</xml_diff>

<commit_message>
Lessons sd-10-017, 020, 021: name the language-provenance exceptions, keep the Bloom filter's definitely-not qualifier and drop the unsupported propagation line on the decks
Co-Authored-By: Claude Sonnet 5.5 <noreply@anthropic.com>
Claude-Session: https://claude.ai/code/session_011dmt3ZFdN8sjiTfDnyUVN7
</commit_message>
<xml_diff>
--- a/system-design-101/vi/lessons/sd-10-017/slides/sd-10-017.pptx
+++ b/system-design-101/vi/lessons/sd-10-017/slides/sd-10-017.pptx
@@ -16099,7 +16099,7 @@
               <a:t> ngữ</a:t>
             </a:r>
             <a:r>
-              <a:rPr lang="en-US" sz="2550" dirty="0" spc="10" kern="0">
+              <a:rPr lang="en-US" sz="2550" dirty="0" spc="-1" kern="0">
                 <a:solidFill>
                   <a:srgbClr val="F3EEE3"/>
                 </a:solidFill>
@@ -16107,7 +16107,51 @@
                 <a:ea typeface="Be Vietnam Pro" pitchFamily="34" charset="-122"/>
                 <a:cs typeface="Be Vietnam Pro" pitchFamily="34" charset="-120"/>
               </a:rPr>
-              <a:t> đọc</a:t>
+              <a:t> từ</a:t>
+            </a:r>
+            <a:r>
+              <a:rPr lang="en-US" sz="2550" dirty="0" spc="-12" kern="0">
+                <a:solidFill>
+                  <a:srgbClr val="F3EEE3"/>
+                </a:solidFill>
+                <a:latin typeface="Be Vietnam Pro" pitchFamily="34" charset="0"/>
+                <a:ea typeface="Be Vietnam Pro" pitchFamily="34" charset="-122"/>
+                <a:cs typeface="Be Vietnam Pro" pitchFamily="34" charset="-120"/>
+              </a:rPr>
+              <a:t> tài</a:t>
+            </a:r>
+            <a:r>
+              <a:rPr lang="en-US" sz="2550" dirty="0" spc="2" kern="0">
+                <a:solidFill>
+                  <a:srgbClr val="F3EEE3"/>
+                </a:solidFill>
+                <a:latin typeface="Be Vietnam Pro" pitchFamily="34" charset="0"/>
+                <a:ea typeface="Be Vietnam Pro" pitchFamily="34" charset="-122"/>
+                <a:cs typeface="Be Vietnam Pro" pitchFamily="34" charset="-120"/>
+              </a:rPr>
+              <a:t> liệu</a:t>
+            </a:r>
+            <a:r>
+              <a:rPr lang="en-US" sz="2550" dirty="0" spc="-3" kern="0">
+                <a:solidFill>
+                  <a:srgbClr val="F3EEE3"/>
+                </a:solidFill>
+                <a:latin typeface="Be Vietnam Pro" pitchFamily="34" charset="0"/>
+                <a:ea typeface="Be Vietnam Pro" pitchFamily="34" charset="-122"/>
+                <a:cs typeface="Be Vietnam Pro" pitchFamily="34" charset="-120"/>
+              </a:rPr>
+              <a:t> dự</a:t>
+            </a:r>
+            <a:r>
+              <a:rPr lang="en-US" sz="2550" dirty="0" spc="0" kern="0">
+                <a:solidFill>
+                  <a:srgbClr val="F3EEE3"/>
+                </a:solidFill>
+                <a:latin typeface="Be Vietnam Pro" pitchFamily="34" charset="0"/>
+                <a:ea typeface="Be Vietnam Pro" pitchFamily="34" charset="-122"/>
+                <a:cs typeface="Be Vietnam Pro" pitchFamily="34" charset="-120"/>
+              </a:rPr>
+              <a:t> án,</a:t>
             </a:r>
             <a:r>
               <a:rPr lang="en-US" sz="2550" dirty="0" spc="-1" kern="0">
@@ -16118,10 +16162,10 @@
                 <a:ea typeface="Be Vietnam Pro" pitchFamily="34" charset="-122"/>
                 <a:cs typeface="Be Vietnam Pro" pitchFamily="34" charset="-120"/>
               </a:rPr>
-              <a:t> từ</a:t>
-            </a:r>
-            <a:r>
-              <a:rPr lang="en-US" sz="2550" dirty="0" spc="-12" kern="0">
+              <a:t> trừ</a:t>
+            </a:r>
+            <a:r>
+              <a:rPr lang="en-US" sz="2550" dirty="0" spc="-26" kern="0">
                 <a:solidFill>
                   <a:srgbClr val="F3EEE3"/>
                 </a:solidFill>
@@ -16129,10 +16173,10 @@
                 <a:ea typeface="Be Vietnam Pro" pitchFamily="34" charset="-122"/>
                 <a:cs typeface="Be Vietnam Pro" pitchFamily="34" charset="-120"/>
               </a:rPr>
-              <a:t> tài</a:t>
-            </a:r>
-            <a:r>
-              <a:rPr lang="en-US" sz="2550" dirty="0" spc="1" kern="0">
+              <a:t> Fortran,</a:t>
+            </a:r>
+            <a:r>
+              <a:rPr lang="en-US" sz="2550" dirty="0" spc="0" kern="0">
                 <a:solidFill>
                   <a:srgbClr val="F3EEE3"/>
                 </a:solidFill>
@@ -16140,10 +16184,10 @@
                 <a:ea typeface="Be Vietnam Pro" pitchFamily="34" charset="-122"/>
                 <a:cs typeface="Be Vietnam Pro" pitchFamily="34" charset="-120"/>
               </a:rPr>
-              <a:t> liệu</a:t>
-            </a:r>
-            <a:r>
-              <a:rPr lang="en-US" sz="2550" dirty="0" spc="-2" kern="0">
+              <a:t> LISP,</a:t>
+            </a:r>
+            <a:r>
+              <a:rPr lang="en-US" sz="2550" dirty="0" spc="-19" kern="0">
                 <a:solidFill>
                   <a:srgbClr val="F3EEE3"/>
                 </a:solidFill>
@@ -16151,10 +16195,10 @@
                 <a:ea typeface="Be Vietnam Pro" pitchFamily="34" charset="-122"/>
                 <a:cs typeface="Be Vietnam Pro" pitchFamily="34" charset="-120"/>
               </a:rPr>
-              <a:t> dự</a:t>
-            </a:r>
-            <a:r>
-              <a:rPr lang="en-US" sz="2550" dirty="0" spc="1" kern="0">
+              <a:t> Java,</a:t>
+            </a:r>
+            <a:r>
+              <a:rPr lang="en-US" sz="2550" dirty="0" spc="-1" kern="0">
                 <a:solidFill>
                   <a:srgbClr val="F3EEE3"/>
                 </a:solidFill>
@@ -16162,7 +16206,7 @@
                 <a:ea typeface="Be Vietnam Pro" pitchFamily="34" charset="-122"/>
                 <a:cs typeface="Be Vietnam Pro" pitchFamily="34" charset="-120"/>
               </a:rPr>
-              <a:t> án.</a:t>
+              <a:t> Zig.</a:t>
             </a:r>
             <a:endParaRPr lang="en-US" sz="2550" dirty="0"/>
           </a:p>

</xml_diff>

<commit_message>
Lessons sd-10-017, 020: say the Roslyn note is about the team today and restore the ideal qualifier for functions on the decks
Co-Authored-By: Claude Sonnet 5.5 <noreply@anthropic.com>
Claude-Session: https://claude.ai/code/session_011dmt3ZFdN8sjiTfDnyUVN7
</commit_message>
<xml_diff>
--- a/system-design-101/vi/lessons/sd-10-017/slides/sd-10-017.pptx
+++ b/system-design-101/vi/lessons/sd-10-017/slides/sd-10-017.pptx
@@ -13611,26 +13611,37 @@
               <a:buNone/>
             </a:pPr>
             <a:r>
-              <a:rPr lang="en-US" sz="2100" dirty="0" spc="1" kern="0">
-                <a:solidFill>
-                  <a:srgbClr val="14161C"/>
-                </a:solidFill>
-                <a:latin typeface="Be Vietnam Pro" pitchFamily="34" charset="0"/>
-                <a:ea typeface="Be Vietnam Pro" pitchFamily="34" charset="-122"/>
-                <a:cs typeface="Be Vietnam Pro" pitchFamily="34" charset="-120"/>
-              </a:rPr>
-              <a:t>Do</a:t>
-            </a:r>
-            <a:r>
-              <a:rPr lang="en-US" sz="2100" dirty="0" spc="-8" kern="0">
-                <a:solidFill>
-                  <a:srgbClr val="14161C"/>
-                </a:solidFill>
-                <a:latin typeface="Be Vietnam Pro" pitchFamily="34" charset="0"/>
-                <a:ea typeface="Be Vietnam Pro" pitchFamily="34" charset="-122"/>
-                <a:cs typeface="Be Vietnam Pro" pitchFamily="34" charset="-120"/>
-              </a:rPr>
-              <a:t> một</a:t>
+              <a:rPr lang="en-US" sz="2100" dirty="0" spc="-4" kern="0">
+                <a:solidFill>
+                  <a:srgbClr val="14161C"/>
+                </a:solidFill>
+                <a:latin typeface="Be Vietnam Pro" pitchFamily="34" charset="0"/>
+                <a:ea typeface="Be Vietnam Pro" pitchFamily="34" charset="-122"/>
+                <a:cs typeface="Be Vietnam Pro" pitchFamily="34" charset="-120"/>
+              </a:rPr>
+              <a:t>Theo</a:t>
+            </a:r>
+            <a:r>
+              <a:rPr lang="en-US" sz="2100" dirty="0" spc="0" kern="0">
+                <a:solidFill>
+                  <a:srgbClr val="14161C"/>
+                </a:solidFill>
+                <a:latin typeface="Be Vietnam Pro" pitchFamily="34" charset="0"/>
+                <a:ea typeface="Be Vietnam Pro" pitchFamily="34" charset="-122"/>
+                <a:cs typeface="Be Vietnam Pro" pitchFamily="34" charset="-120"/>
+              </a:rPr>
+              <a:t> nguồn;</a:t>
+            </a:r>
+            <a:r>
+              <a:rPr lang="en-US" sz="2100" dirty="0" spc="-9" kern="0">
+                <a:solidFill>
+                  <a:srgbClr val="14161C"/>
+                </a:solidFill>
+                <a:latin typeface="Be Vietnam Pro" pitchFamily="34" charset="0"/>
+                <a:ea typeface="Be Vietnam Pro" pitchFamily="34" charset="-122"/>
+                <a:cs typeface="Be Vietnam Pro" pitchFamily="34" charset="-120"/>
+              </a:rPr>
+              <a:t> nay</a:t>
             </a:r>
             <a:r>
               <a:rPr lang="en-US" sz="2100" dirty="0" spc="-2" kern="0">
@@ -13666,26 +13677,15 @@
               <a:t> kế</a:t>
             </a:r>
             <a:r>
-              <a:rPr lang="en-US" sz="2100" dirty="0" spc="-9" kern="0">
-                <a:solidFill>
-                  <a:srgbClr val="14161C"/>
-                </a:solidFill>
-                <a:latin typeface="Be Vietnam Pro" pitchFamily="34" charset="0"/>
-                <a:ea typeface="Be Vietnam Pro" pitchFamily="34" charset="-122"/>
-                <a:cs typeface="Be Vietnam Pro" pitchFamily="34" charset="-120"/>
-              </a:rPr>
-              <a:t> ngôn</a:t>
-            </a:r>
-            <a:r>
-              <a:rPr lang="en-US" sz="2100" dirty="0" spc="0" kern="0">
-                <a:solidFill>
-                  <a:srgbClr val="14161C"/>
-                </a:solidFill>
-                <a:latin typeface="Be Vietnam Pro" pitchFamily="34" charset="0"/>
-                <a:ea typeface="Be Vietnam Pro" pitchFamily="34" charset="-122"/>
-                <a:cs typeface="Be Vietnam Pro" pitchFamily="34" charset="-120"/>
-              </a:rPr>
-              <a:t> ngữ,</a:t>
+              <a:rPr lang="en-US" sz="2100" dirty="0" spc="-3" kern="0">
+                <a:solidFill>
+                  <a:srgbClr val="14161C"/>
+                </a:solidFill>
+                <a:latin typeface="Be Vietnam Pro" pitchFamily="34" charset="0"/>
+                <a:ea typeface="Be Vietnam Pro" pitchFamily="34" charset="-122"/>
+                <a:cs typeface="Be Vietnam Pro" pitchFamily="34" charset="-120"/>
+              </a:rPr>
+              <a:t> làm</a:t>
             </a:r>
             <a:r>
               <a:rPr lang="en-US" sz="2100" dirty="0" spc="-2" kern="0">
@@ -13696,7 +13696,7 @@
                 <a:ea typeface="Be Vietnam Pro" pitchFamily="34" charset="-122"/>
                 <a:cs typeface="Be Vietnam Pro" pitchFamily="34" charset="-120"/>
               </a:rPr>
-              <a:t> làm việc</a:t>
+              <a:t> việc</a:t>
             </a:r>
             <a:r>
               <a:rPr lang="en-US" sz="2100" dirty="0" spc="-17" kern="0">
@@ -13710,7 +13710,7 @@
               <a:t> sát</a:t>
             </a:r>
             <a:r>
-              <a:rPr lang="en-US" sz="2100" dirty="0" spc="-13" kern="0">
+              <a:rPr lang="en-US" sz="2100" dirty="0" spc="-12" kern="0">
                 <a:solidFill>
                   <a:srgbClr val="14161C"/>
                 </a:solidFill>

</xml_diff>

<commit_message>
Lessons sd-10-017, 020, 021: drop the unsupported influence claim, correct the documentation count on the 020 deck and leave the 021 claim status pending
Co-Authored-By: Claude Sonnet 5.5 <noreply@anthropic.com>
Claude-Session: https://claude.ai/code/session_011dmt3ZFdN8sjiTfDnyUVN7
</commit_message>
<xml_diff>
--- a/system-design-101/vi/lessons/sd-10-017/slides/sd-10-017.pptx
+++ b/system-design-101/vi/lessons/sd-10-017/slides/sd-10-017.pptx
@@ -8888,26 +8888,48 @@
               <a:t> có</a:t>
             </a:r>
             <a:r>
-              <a:rPr lang="en-US" sz="2850" dirty="0" spc="3" kern="0">
-                <a:solidFill>
-                  <a:srgbClr val="14161C"/>
-                </a:solidFill>
-                <a:latin typeface="Be Vietnam Pro" pitchFamily="34" charset="0"/>
-                <a:ea typeface="Be Vietnam Pro" pitchFamily="34" charset="-122"/>
-                <a:cs typeface="Be Vietnam Pro" pitchFamily="34" charset="-120"/>
-              </a:rPr>
-              <a:t> hai</a:t>
-            </a:r>
-            <a:r>
-              <a:rPr lang="en-US" sz="2850" dirty="0" spc="-14" kern="0">
-                <a:solidFill>
-                  <a:srgbClr val="14161C"/>
-                </a:solidFill>
-                <a:latin typeface="Be Vietnam Pro" pitchFamily="34" charset="0"/>
-                <a:ea typeface="Be Vietnam Pro" pitchFamily="34" charset="-122"/>
-                <a:cs typeface="Be Vietnam Pro" pitchFamily="34" charset="-120"/>
-              </a:rPr>
-              <a:t> ngôn</a:t>
+              <a:rPr lang="en-US" sz="2850" dirty="0" spc="-6" kern="0">
+                <a:solidFill>
+                  <a:srgbClr val="14161C"/>
+                </a:solidFill>
+                <a:latin typeface="Be Vietnam Pro" pitchFamily="34" charset="0"/>
+                <a:ea typeface="Be Vietnam Pro" pitchFamily="34" charset="-122"/>
+                <a:cs typeface="Be Vietnam Pro" pitchFamily="34" charset="-120"/>
+              </a:rPr>
+              <a:t> Smalltalk</a:t>
+            </a:r>
+            <a:r>
+              <a:rPr lang="en-US" sz="2850" dirty="0" spc="-15" kern="0">
+                <a:solidFill>
+                  <a:srgbClr val="14161C"/>
+                </a:solidFill>
+                <a:latin typeface="Be Vietnam Pro" pitchFamily="34" charset="0"/>
+                <a:ea typeface="Be Vietnam Pro" pitchFamily="34" charset="-122"/>
+                <a:cs typeface="Be Vietnam Pro" pitchFamily="34" charset="-120"/>
+              </a:rPr>
+              <a:t> và</a:t>
+            </a:r>
+            <a:r>
+              <a:rPr lang="en-US" sz="2850" dirty="0" spc="1" kern="0">
+                <a:solidFill>
+                  <a:srgbClr val="14161C"/>
+                </a:solidFill>
+                <a:latin typeface="Be Vietnam Pro" pitchFamily="34" charset="0"/>
+                <a:ea typeface="Be Vietnam Pro" pitchFamily="34" charset="-122"/>
+                <a:cs typeface="Be Vietnam Pro" pitchFamily="34" charset="-120"/>
+              </a:rPr>
+              <a:t> C,</a:t>
+            </a:r>
+            <a:r>
+              <a:rPr lang="en-US" sz="2850" dirty="0" spc="-3" kern="0">
+                <a:solidFill>
+                  <a:srgbClr val="14161C"/>
+                </a:solidFill>
+                <a:latin typeface="Be Vietnam Pro" pitchFamily="34" charset="0"/>
+                <a:ea typeface="Be Vietnam Pro" pitchFamily="34" charset="-122"/>
+                <a:cs typeface="Be Vietnam Pro" pitchFamily="34" charset="-120"/>
+              </a:rPr>
+              <a:t> theo</a:t>
             </a:r>
             <a:r>
               <a:rPr lang="en-US" sz="2850" dirty="0" spc="-2" kern="0">
@@ -8918,43 +8940,10 @@
                 <a:ea typeface="Be Vietnam Pro" pitchFamily="34" charset="-122"/>
                 <a:cs typeface="Be Vietnam Pro" pitchFamily="34" charset="-120"/>
               </a:rPr>
-              <a:t> ngữ</a:t>
-            </a:r>
-            <a:r>
-              <a:rPr lang="en-US" sz="2850" dirty="0" spc="-1" kern="0">
-                <a:solidFill>
-                  <a:srgbClr val="14161C"/>
-                </a:solidFill>
-                <a:latin typeface="Be Vietnam Pro" pitchFamily="34" charset="0"/>
-                <a:ea typeface="Be Vietnam Pro" pitchFamily="34" charset="-122"/>
-                <a:cs typeface="Be Vietnam Pro" pitchFamily="34" charset="-120"/>
-              </a:rPr>
-              <a:t> có</a:t>
-            </a:r>
-            <a:r>
-              <a:rPr lang="en-US" sz="2850" dirty="0" spc="0" kern="0">
-                <a:solidFill>
-                  <a:srgbClr val="14161C"/>
-                </a:solidFill>
-                <a:latin typeface="Be Vietnam Pro" pitchFamily="34" charset="0"/>
-                <a:ea typeface="Be Vietnam Pro" pitchFamily="34" charset="-122"/>
-                <a:cs typeface="Be Vietnam Pro" pitchFamily="34" charset="-120"/>
-              </a:rPr>
-              <a:t> ảnh</a:t>
-            </a:r>
-            <a:r>
-              <a:rPr lang="en-US" sz="2850" dirty="0" spc="6" kern="0">
-                <a:solidFill>
-                  <a:srgbClr val="14161C"/>
-                </a:solidFill>
-                <a:latin typeface="Be Vietnam Pro" pitchFamily="34" charset="0"/>
-                <a:ea typeface="Be Vietnam Pro" pitchFamily="34" charset="-122"/>
-                <a:cs typeface="Be Vietnam Pro" pitchFamily="34" charset="-120"/>
-              </a:rPr>
-              <a:t> hưởng.</a:t>
-            </a:r>
-            <a:r>
-              <a:rPr lang="en-US" sz="2850" dirty="0" spc="0" kern="0">
+              <a:t> nguồn.</a:t>
+            </a:r>
+            <a:r>
+              <a:rPr lang="en-US" sz="2850" dirty="0" spc="1" kern="0">
                 <a:solidFill>
                   <a:srgbClr val="14161C"/>
                 </a:solidFill>

</xml_diff>

<commit_message>
Lessons sd-10-017, 020: name ABC as the language Python succeeded on the deck, restore the ideal qualifier on the functional figure card
Co-Authored-By: Claude Sonnet 5.5 <noreply@anthropic.com>
Claude-Session: https://claude.ai/code/session_011dmt3ZFdN8sjiTfDnyUVN7
</commit_message>
<xml_diff>
--- a/system-design-101/vi/lessons/sd-10-017/slides/sd-10-017.pptx
+++ b/system-design-101/vi/lessons/sd-10-017/slides/sd-10-017.pptx
@@ -11009,7 +11009,18 @@
               <a:t> nhiệm</a:t>
             </a:r>
             <a:r>
-              <a:rPr lang="en-US" sz="2250" b="1" dirty="0" spc="-10" kern="0">
+              <a:rPr lang="en-US" sz="2250" b="1" dirty="0" spc="-4" kern="0">
+                <a:solidFill>
+                  <a:srgbClr val="14161C"/>
+                </a:solidFill>
+                <a:latin typeface="Be Vietnam Pro" pitchFamily="34" charset="0"/>
+                <a:ea typeface="Be Vietnam Pro" pitchFamily="34" charset="-122"/>
+                <a:cs typeface="Be Vietnam Pro" pitchFamily="34" charset="-120"/>
+              </a:rPr>
+              <a:t> ABC,</a:t>
+            </a:r>
+            <a:r>
+              <a:rPr lang="en-US" sz="2250" b="1" dirty="0" spc="-9" kern="0">
                 <a:solidFill>
                   <a:srgbClr val="14161C"/>
                 </a:solidFill>
@@ -11647,7 +11658,7 @@
         <p:spPr>
           <a:xfrm>
             <a:off x="9791700" y="4572000"/>
-            <a:ext cx="6896100" cy="476250"/>
+            <a:ext cx="6896100" cy="381000"/>
           </a:xfrm>
           <a:prstGeom prst="rect">
             <a:avLst/>
@@ -11737,40 +11748,7 @@
                 <a:ea typeface="Be Vietnam Pro" pitchFamily="34" charset="-122"/>
                 <a:cs typeface="Be Vietnam Pro" pitchFamily="34" charset="-120"/>
               </a:rPr>
-              <a:t> một</a:t>
-            </a:r>
-            <a:r>
-              <a:rPr lang="en-US" sz="2250" dirty="0" spc="-7" kern="0">
-                <a:solidFill>
-                  <a:srgbClr val="C4C8D6"/>
-                </a:solidFill>
-                <a:latin typeface="Be Vietnam Pro" pitchFamily="34" charset="0"/>
-                <a:ea typeface="Be Vietnam Pro" pitchFamily="34" charset="-122"/>
-                <a:cs typeface="Be Vietnam Pro" pitchFamily="34" charset="-120"/>
-              </a:rPr>
-              <a:t> ngôn</a:t>
-            </a:r>
-            <a:r>
-              <a:rPr lang="en-US" sz="2250" dirty="0" spc="2" kern="0">
-                <a:solidFill>
-                  <a:srgbClr val="C4C8D6"/>
-                </a:solidFill>
-                <a:latin typeface="Be Vietnam Pro" pitchFamily="34" charset="0"/>
-                <a:ea typeface="Be Vietnam Pro" pitchFamily="34" charset="-122"/>
-                <a:cs typeface="Be Vietnam Pro" pitchFamily="34" charset="-120"/>
-              </a:rPr>
-              <a:t> ngữ</a:t>
-            </a:r>
-            <a:r>
-              <a:rPr lang="en-US" sz="2250" dirty="0" spc="4" kern="0">
-                <a:solidFill>
-                  <a:srgbClr val="C4C8D6"/>
-                </a:solidFill>
-                <a:latin typeface="Be Vietnam Pro" pitchFamily="34" charset="0"/>
-                <a:ea typeface="Be Vietnam Pro" pitchFamily="34" charset="-122"/>
-                <a:cs typeface="Be Vietnam Pro" pitchFamily="34" charset="-120"/>
-              </a:rPr>
-              <a:t> cũ</a:t>
+              <a:t> ABC</a:t>
             </a:r>
             <a:endParaRPr lang="en-US" sz="2250" dirty="0"/>
           </a:p>
@@ -19238,7 +19216,7 @@
               <a:t> nhiệm</a:t>
             </a:r>
             <a:r>
-              <a:rPr lang="en-US" sz="2250" dirty="0" spc="-5" kern="0">
+              <a:rPr lang="en-US" sz="2250" dirty="0" spc="-4" kern="0">
                 <a:solidFill>
                   <a:srgbClr val="6B6A66"/>
                 </a:solidFill>
@@ -19246,7 +19224,7 @@
                 <a:ea typeface="Be Vietnam Pro" pitchFamily="34" charset="-122"/>
                 <a:cs typeface="Be Vietnam Pro" pitchFamily="34" charset="-120"/>
               </a:rPr>
-              <a:t> một</a:t>
+              <a:t> ABC, một</a:t>
             </a:r>
             <a:r>
               <a:rPr lang="en-US" sz="2250" dirty="0" spc="-7" kern="0">
@@ -19271,7 +19249,7 @@
               <a:t> ngữ</a:t>
             </a:r>
             <a:r>
-              <a:rPr lang="en-US" sz="2250" dirty="0" spc="5" kern="0">
+              <a:rPr lang="en-US" sz="2250" dirty="0" spc="4" kern="0">
                 <a:solidFill>
                   <a:srgbClr val="6B6A66"/>
                 </a:solidFill>

</xml_diff>